<commit_message>
updated day 2 lecture
</commit_message>
<xml_diff>
--- a/Basic R - day 2.pptx
+++ b/Basic R - day 2.pptx
@@ -5,36 +5,39 @@
     <p:sldMasterId id="2147483648" r:id="rId1"/>
   </p:sldMasterIdLst>
   <p:notesMasterIdLst>
-    <p:notesMasterId r:id="rId29"/>
+    <p:notesMasterId r:id="rId32"/>
   </p:notesMasterIdLst>
   <p:sldIdLst>
     <p:sldId id="256" r:id="rId2"/>
-    <p:sldId id="257" r:id="rId3"/>
-    <p:sldId id="277" r:id="rId4"/>
-    <p:sldId id="280" r:id="rId5"/>
-    <p:sldId id="274" r:id="rId6"/>
-    <p:sldId id="285" r:id="rId7"/>
-    <p:sldId id="273" r:id="rId8"/>
-    <p:sldId id="276" r:id="rId9"/>
-    <p:sldId id="275" r:id="rId10"/>
-    <p:sldId id="281" r:id="rId11"/>
-    <p:sldId id="284" r:id="rId12"/>
-    <p:sldId id="282" r:id="rId13"/>
-    <p:sldId id="283" r:id="rId14"/>
-    <p:sldId id="289" r:id="rId15"/>
-    <p:sldId id="290" r:id="rId16"/>
-    <p:sldId id="291" r:id="rId17"/>
-    <p:sldId id="286" r:id="rId18"/>
-    <p:sldId id="288" r:id="rId19"/>
-    <p:sldId id="287" r:id="rId20"/>
-    <p:sldId id="292" r:id="rId21"/>
-    <p:sldId id="293" r:id="rId22"/>
-    <p:sldId id="294" r:id="rId23"/>
-    <p:sldId id="296" r:id="rId24"/>
-    <p:sldId id="295" r:id="rId25"/>
-    <p:sldId id="297" r:id="rId26"/>
-    <p:sldId id="299" r:id="rId27"/>
-    <p:sldId id="298" r:id="rId28"/>
+    <p:sldId id="301" r:id="rId3"/>
+    <p:sldId id="257" r:id="rId4"/>
+    <p:sldId id="272" r:id="rId5"/>
+    <p:sldId id="302" r:id="rId6"/>
+    <p:sldId id="280" r:id="rId7"/>
+    <p:sldId id="274" r:id="rId8"/>
+    <p:sldId id="285" r:id="rId9"/>
+    <p:sldId id="273" r:id="rId10"/>
+    <p:sldId id="276" r:id="rId11"/>
+    <p:sldId id="275" r:id="rId12"/>
+    <p:sldId id="281" r:id="rId13"/>
+    <p:sldId id="284" r:id="rId14"/>
+    <p:sldId id="282" r:id="rId15"/>
+    <p:sldId id="283" r:id="rId16"/>
+    <p:sldId id="289" r:id="rId17"/>
+    <p:sldId id="290" r:id="rId18"/>
+    <p:sldId id="291" r:id="rId19"/>
+    <p:sldId id="286" r:id="rId20"/>
+    <p:sldId id="288" r:id="rId21"/>
+    <p:sldId id="287" r:id="rId22"/>
+    <p:sldId id="292" r:id="rId23"/>
+    <p:sldId id="293" r:id="rId24"/>
+    <p:sldId id="294" r:id="rId25"/>
+    <p:sldId id="296" r:id="rId26"/>
+    <p:sldId id="295" r:id="rId27"/>
+    <p:sldId id="297" r:id="rId28"/>
+    <p:sldId id="299" r:id="rId29"/>
+    <p:sldId id="300" r:id="rId30"/>
+    <p:sldId id="298" r:id="rId31"/>
   </p:sldIdLst>
   <p:sldSz cx="12192000" cy="6858000"/>
   <p:notesSz cx="6858000" cy="9144000"/>
@@ -937,51 +940,6 @@
         </a:p>
       </dgm:t>
     </dgm:pt>
-    <dgm:pt modelId="{A79EB40D-8F14-444D-A975-718565B7C6CF}">
-      <dgm:prSet/>
-      <dgm:spPr/>
-      <dgm:t>
-        <a:bodyPr/>
-        <a:lstStyle/>
-        <a:p>
-          <a:r>
-            <a:rPr lang="en-US" dirty="0" err="1"/>
-            <a:t>Helt</a:t>
-          </a:r>
-          <a:r>
-            <a:rPr lang="en-US" dirty="0"/>
-            <a:t> basic </a:t>
-          </a:r>
-          <a:r>
-            <a:rPr lang="en-US" dirty="0" err="1"/>
-            <a:t>biostat</a:t>
-          </a:r>
-          <a:endParaRPr lang="en-US" dirty="0"/>
-        </a:p>
-      </dgm:t>
-    </dgm:pt>
-    <dgm:pt modelId="{4AE7F228-7241-4EAC-A5A2-E433D3AFCF95}" type="parTrans" cxnId="{0A0D2D12-DC1C-4D82-B7ED-5EB6B75354A3}">
-      <dgm:prSet/>
-      <dgm:spPr/>
-      <dgm:t>
-        <a:bodyPr/>
-        <a:lstStyle/>
-        <a:p>
-          <a:endParaRPr lang="en-US"/>
-        </a:p>
-      </dgm:t>
-    </dgm:pt>
-    <dgm:pt modelId="{91341220-11E2-4107-B3F9-4033EDE0BA43}" type="sibTrans" cxnId="{0A0D2D12-DC1C-4D82-B7ED-5EB6B75354A3}">
-      <dgm:prSet/>
-      <dgm:spPr/>
-      <dgm:t>
-        <a:bodyPr/>
-        <a:lstStyle/>
-        <a:p>
-          <a:endParaRPr lang="en-US"/>
-        </a:p>
-      </dgm:t>
-    </dgm:pt>
     <dgm:pt modelId="{E4ACCCF7-AF99-48E7-AB2C-561A737DD18B}">
       <dgm:prSet/>
       <dgm:spPr/>
@@ -1261,19 +1219,11 @@
         <a:p>
           <a:r>
             <a:rPr lang="en-US" dirty="0"/>
-            <a:t>Svar </a:t>
+            <a:t>Helt basic </a:t>
           </a:r>
           <a:r>
             <a:rPr lang="en-US" dirty="0" err="1"/>
-            <a:t>på</a:t>
-          </a:r>
-          <a:r>
-            <a:rPr lang="en-US" dirty="0"/>
-            <a:t> </a:t>
-          </a:r>
-          <a:r>
-            <a:rPr lang="en-US" dirty="0" err="1"/>
-            <a:t>øvelsen</a:t>
+            <a:t>biostat</a:t>
           </a:r>
           <a:endParaRPr lang="en-US" dirty="0"/>
         </a:p>
@@ -1352,7 +1302,7 @@
       <dgm:spPr/>
     </dgm:pt>
     <dgm:pt modelId="{497F461D-EC6E-4179-927F-0C6AD93CBEAB}" type="pres">
-      <dgm:prSet presAssocID="{16688A05-8CD1-422C-8D4B-754C457A9677}" presName="thickLine" presStyleLbl="alignNode1" presStyleIdx="0" presStyleCnt="8"/>
+      <dgm:prSet presAssocID="{16688A05-8CD1-422C-8D4B-754C457A9677}" presName="thickLine" presStyleLbl="alignNode1" presStyleIdx="0" presStyleCnt="7"/>
       <dgm:spPr/>
     </dgm:pt>
     <dgm:pt modelId="{300E4385-5189-4F6E-AFCA-6B3A01557297}" type="pres">
@@ -1360,31 +1310,15 @@
       <dgm:spPr/>
     </dgm:pt>
     <dgm:pt modelId="{6452D1B0-0F1F-4D43-8FF9-638585DFAE99}" type="pres">
-      <dgm:prSet presAssocID="{16688A05-8CD1-422C-8D4B-754C457A9677}" presName="tx1" presStyleLbl="revTx" presStyleIdx="0" presStyleCnt="8"/>
+      <dgm:prSet presAssocID="{16688A05-8CD1-422C-8D4B-754C457A9677}" presName="tx1" presStyleLbl="revTx" presStyleIdx="0" presStyleCnt="7"/>
       <dgm:spPr/>
     </dgm:pt>
     <dgm:pt modelId="{D500BA6E-E356-460C-B62D-516BE4F9C830}" type="pres">
       <dgm:prSet presAssocID="{16688A05-8CD1-422C-8D4B-754C457A9677}" presName="vert1" presStyleCnt="0"/>
       <dgm:spPr/>
     </dgm:pt>
-    <dgm:pt modelId="{95EF4453-BF73-4C1D-BC7F-8AF5EDEEEF69}" type="pres">
-      <dgm:prSet presAssocID="{A79EB40D-8F14-444D-A975-718565B7C6CF}" presName="thickLine" presStyleLbl="alignNode1" presStyleIdx="1" presStyleCnt="8"/>
-      <dgm:spPr/>
-    </dgm:pt>
-    <dgm:pt modelId="{F68A23ED-E670-4F5F-82F0-8F70611CEAA5}" type="pres">
-      <dgm:prSet presAssocID="{A79EB40D-8F14-444D-A975-718565B7C6CF}" presName="horz1" presStyleCnt="0"/>
-      <dgm:spPr/>
-    </dgm:pt>
-    <dgm:pt modelId="{E113B2DD-6D52-4109-9B54-D95668AA6D67}" type="pres">
-      <dgm:prSet presAssocID="{A79EB40D-8F14-444D-A975-718565B7C6CF}" presName="tx1" presStyleLbl="revTx" presStyleIdx="1" presStyleCnt="8"/>
-      <dgm:spPr/>
-    </dgm:pt>
-    <dgm:pt modelId="{52A96121-CE56-48B6-BF0F-5BA8B27A52F1}" type="pres">
-      <dgm:prSet presAssocID="{A79EB40D-8F14-444D-A975-718565B7C6CF}" presName="vert1" presStyleCnt="0"/>
-      <dgm:spPr/>
-    </dgm:pt>
     <dgm:pt modelId="{6D4E6855-10F1-4E4B-86F6-9420AEA4B5BC}" type="pres">
-      <dgm:prSet presAssocID="{E4ACCCF7-AF99-48E7-AB2C-561A737DD18B}" presName="thickLine" presStyleLbl="alignNode1" presStyleIdx="2" presStyleCnt="8"/>
+      <dgm:prSet presAssocID="{E4ACCCF7-AF99-48E7-AB2C-561A737DD18B}" presName="thickLine" presStyleLbl="alignNode1" presStyleIdx="1" presStyleCnt="7"/>
       <dgm:spPr/>
     </dgm:pt>
     <dgm:pt modelId="{925F6481-506F-4CA9-86C9-113872E0964C}" type="pres">
@@ -1392,7 +1326,7 @@
       <dgm:spPr/>
     </dgm:pt>
     <dgm:pt modelId="{5FFDCD4C-7A1F-4C60-8BC4-AA16B12E29F2}" type="pres">
-      <dgm:prSet presAssocID="{E4ACCCF7-AF99-48E7-AB2C-561A737DD18B}" presName="tx1" presStyleLbl="revTx" presStyleIdx="2" presStyleCnt="8"/>
+      <dgm:prSet presAssocID="{E4ACCCF7-AF99-48E7-AB2C-561A737DD18B}" presName="tx1" presStyleLbl="revTx" presStyleIdx="1" presStyleCnt="7"/>
       <dgm:spPr/>
     </dgm:pt>
     <dgm:pt modelId="{F9A8DF34-2695-4A2F-90EF-5C4A196924E9}" type="pres">
@@ -1400,7 +1334,7 @@
       <dgm:spPr/>
     </dgm:pt>
     <dgm:pt modelId="{CD3C9203-DAE0-4D0C-BF9D-D55D55B76D8D}" type="pres">
-      <dgm:prSet presAssocID="{3527EB05-C699-4F72-B42E-20D39F4630C9}" presName="thickLine" presStyleLbl="alignNode1" presStyleIdx="3" presStyleCnt="8"/>
+      <dgm:prSet presAssocID="{3527EB05-C699-4F72-B42E-20D39F4630C9}" presName="thickLine" presStyleLbl="alignNode1" presStyleIdx="2" presStyleCnt="7"/>
       <dgm:spPr/>
     </dgm:pt>
     <dgm:pt modelId="{E252B961-A896-4289-B48A-265BE689B7C2}" type="pres">
@@ -1408,7 +1342,7 @@
       <dgm:spPr/>
     </dgm:pt>
     <dgm:pt modelId="{ABCB087D-C304-42B5-B7B0-BE2EB5CD28A0}" type="pres">
-      <dgm:prSet presAssocID="{3527EB05-C699-4F72-B42E-20D39F4630C9}" presName="tx1" presStyleLbl="revTx" presStyleIdx="3" presStyleCnt="8"/>
+      <dgm:prSet presAssocID="{3527EB05-C699-4F72-B42E-20D39F4630C9}" presName="tx1" presStyleLbl="revTx" presStyleIdx="2" presStyleCnt="7"/>
       <dgm:spPr/>
     </dgm:pt>
     <dgm:pt modelId="{01B56628-D5B0-4D9B-A9BD-56F0096D220E}" type="pres">
@@ -1416,7 +1350,7 @@
       <dgm:spPr/>
     </dgm:pt>
     <dgm:pt modelId="{DBAAC0A5-4BE0-4198-A670-C41F5AA2C64A}" type="pres">
-      <dgm:prSet presAssocID="{CD3C00BB-0D2D-4D6A-9950-E3A06AD4FC07}" presName="thickLine" presStyleLbl="alignNode1" presStyleIdx="4" presStyleCnt="8"/>
+      <dgm:prSet presAssocID="{CD3C00BB-0D2D-4D6A-9950-E3A06AD4FC07}" presName="thickLine" presStyleLbl="alignNode1" presStyleIdx="3" presStyleCnt="7"/>
       <dgm:spPr/>
     </dgm:pt>
     <dgm:pt modelId="{4BCCDB29-63FB-4941-B8CB-36C31775691D}" type="pres">
@@ -1424,7 +1358,7 @@
       <dgm:spPr/>
     </dgm:pt>
     <dgm:pt modelId="{8712898D-FEE3-49BD-883B-3FA1892C584E}" type="pres">
-      <dgm:prSet presAssocID="{CD3C00BB-0D2D-4D6A-9950-E3A06AD4FC07}" presName="tx1" presStyleLbl="revTx" presStyleIdx="4" presStyleCnt="8"/>
+      <dgm:prSet presAssocID="{CD3C00BB-0D2D-4D6A-9950-E3A06AD4FC07}" presName="tx1" presStyleLbl="revTx" presStyleIdx="3" presStyleCnt="7"/>
       <dgm:spPr/>
     </dgm:pt>
     <dgm:pt modelId="{B25B7D02-C018-4000-B7E6-53AF2983D544}" type="pres">
@@ -1432,7 +1366,7 @@
       <dgm:spPr/>
     </dgm:pt>
     <dgm:pt modelId="{911A70AB-5E9A-4DF8-A39B-960757FE3BCB}" type="pres">
-      <dgm:prSet presAssocID="{38880B31-6335-4AF7-8693-8A95DA29121C}" presName="thickLine" presStyleLbl="alignNode1" presStyleIdx="5" presStyleCnt="8"/>
+      <dgm:prSet presAssocID="{38880B31-6335-4AF7-8693-8A95DA29121C}" presName="thickLine" presStyleLbl="alignNode1" presStyleIdx="4" presStyleCnt="7"/>
       <dgm:spPr/>
     </dgm:pt>
     <dgm:pt modelId="{30940C09-D36B-4121-BB7F-E169A6BC896C}" type="pres">
@@ -1440,7 +1374,7 @@
       <dgm:spPr/>
     </dgm:pt>
     <dgm:pt modelId="{2AAA0AD9-6DE0-4676-AA2D-39949CBB9021}" type="pres">
-      <dgm:prSet presAssocID="{38880B31-6335-4AF7-8693-8A95DA29121C}" presName="tx1" presStyleLbl="revTx" presStyleIdx="5" presStyleCnt="8"/>
+      <dgm:prSet presAssocID="{38880B31-6335-4AF7-8693-8A95DA29121C}" presName="tx1" presStyleLbl="revTx" presStyleIdx="4" presStyleCnt="7"/>
       <dgm:spPr/>
     </dgm:pt>
     <dgm:pt modelId="{1F4E83D4-14E0-4848-80A3-48891FD34568}" type="pres">
@@ -1448,7 +1382,7 @@
       <dgm:spPr/>
     </dgm:pt>
     <dgm:pt modelId="{18D39591-C8CB-477A-B24A-70531F1AE3D0}" type="pres">
-      <dgm:prSet presAssocID="{5F8A560E-F6DD-4254-AF73-A5259FADD990}" presName="thickLine" presStyleLbl="alignNode1" presStyleIdx="6" presStyleCnt="8"/>
+      <dgm:prSet presAssocID="{5F8A560E-F6DD-4254-AF73-A5259FADD990}" presName="thickLine" presStyleLbl="alignNode1" presStyleIdx="5" presStyleCnt="7"/>
       <dgm:spPr/>
     </dgm:pt>
     <dgm:pt modelId="{FB118834-1620-4C75-A26A-D50BFA69B9C1}" type="pres">
@@ -1456,7 +1390,7 @@
       <dgm:spPr/>
     </dgm:pt>
     <dgm:pt modelId="{929CB212-6DAA-4A10-B729-94E1FD65CBAD}" type="pres">
-      <dgm:prSet presAssocID="{5F8A560E-F6DD-4254-AF73-A5259FADD990}" presName="tx1" presStyleLbl="revTx" presStyleIdx="6" presStyleCnt="8"/>
+      <dgm:prSet presAssocID="{5F8A560E-F6DD-4254-AF73-A5259FADD990}" presName="tx1" presStyleLbl="revTx" presStyleIdx="5" presStyleCnt="7"/>
       <dgm:spPr/>
     </dgm:pt>
     <dgm:pt modelId="{F0FDFFC8-CF37-4ADE-A1CD-038CAE4FAC6A}" type="pres">
@@ -1464,7 +1398,7 @@
       <dgm:spPr/>
     </dgm:pt>
     <dgm:pt modelId="{171725A7-A228-46AC-B73D-550B0E628AC3}" type="pres">
-      <dgm:prSet presAssocID="{E51C441C-DD9F-4E3B-9DB4-7EA3A6001EFA}" presName="thickLine" presStyleLbl="alignNode1" presStyleIdx="7" presStyleCnt="8"/>
+      <dgm:prSet presAssocID="{E51C441C-DD9F-4E3B-9DB4-7EA3A6001EFA}" presName="thickLine" presStyleLbl="alignNode1" presStyleIdx="6" presStyleCnt="7"/>
       <dgm:spPr/>
     </dgm:pt>
     <dgm:pt modelId="{AE0B1B25-94C7-4F34-8BCB-B177C22FA0D4}" type="pres">
@@ -1472,7 +1406,7 @@
       <dgm:spPr/>
     </dgm:pt>
     <dgm:pt modelId="{F3E97B70-D60C-4FDB-97DF-88BF5DE7CAA2}" type="pres">
-      <dgm:prSet presAssocID="{E51C441C-DD9F-4E3B-9DB4-7EA3A6001EFA}" presName="tx1" presStyleLbl="revTx" presStyleIdx="7" presStyleCnt="8"/>
+      <dgm:prSet presAssocID="{E51C441C-DD9F-4E3B-9DB4-7EA3A6001EFA}" presName="tx1" presStyleLbl="revTx" presStyleIdx="6" presStyleCnt="7"/>
       <dgm:spPr/>
     </dgm:pt>
     <dgm:pt modelId="{735ECF1D-A152-484A-96FD-67BA82E562BB}" type="pres">
@@ -1482,52 +1416,46 @@
   </dgm:ptLst>
   <dgm:cxnLst>
     <dgm:cxn modelId="{5D837F0D-D538-418D-AEED-F4C502C8C74E}" type="presOf" srcId="{5F8A560E-F6DD-4254-AF73-A5259FADD990}" destId="{929CB212-6DAA-4A10-B729-94E1FD65CBAD}" srcOrd="0" destOrd="0" presId="urn:microsoft.com/office/officeart/2008/layout/LinedList"/>
-    <dgm:cxn modelId="{61263210-C965-4496-9ED8-78699BD0F2E2}" srcId="{FB0694DE-DFD6-45BA-B184-A9E32E281C34}" destId="{CD3C00BB-0D2D-4D6A-9950-E3A06AD4FC07}" srcOrd="4" destOrd="0" parTransId="{057A87B9-7F96-45DA-B38E-58F973C7F00E}" sibTransId="{6421F028-5D7D-4CBE-8154-222B422E7DB3}"/>
-    <dgm:cxn modelId="{0A0D2D12-DC1C-4D82-B7ED-5EB6B75354A3}" srcId="{FB0694DE-DFD6-45BA-B184-A9E32E281C34}" destId="{A79EB40D-8F14-444D-A975-718565B7C6CF}" srcOrd="1" destOrd="0" parTransId="{4AE7F228-7241-4EAC-A5A2-E433D3AFCF95}" sibTransId="{91341220-11E2-4107-B3F9-4033EDE0BA43}"/>
+    <dgm:cxn modelId="{61263210-C965-4496-9ED8-78699BD0F2E2}" srcId="{FB0694DE-DFD6-45BA-B184-A9E32E281C34}" destId="{CD3C00BB-0D2D-4D6A-9950-E3A06AD4FC07}" srcOrd="3" destOrd="0" parTransId="{057A87B9-7F96-45DA-B38E-58F973C7F00E}" sibTransId="{6421F028-5D7D-4CBE-8154-222B422E7DB3}"/>
     <dgm:cxn modelId="{6C81AD14-8BB2-484E-9EDB-0C0CBCB93B16}" type="presOf" srcId="{CD3C00BB-0D2D-4D6A-9950-E3A06AD4FC07}" destId="{8712898D-FEE3-49BD-883B-3FA1892C584E}" srcOrd="0" destOrd="0" presId="urn:microsoft.com/office/officeart/2008/layout/LinedList"/>
-    <dgm:cxn modelId="{00523C19-6427-4085-B528-98E6A90430F7}" type="presOf" srcId="{A79EB40D-8F14-444D-A975-718565B7C6CF}" destId="{E113B2DD-6D52-4109-9B54-D95668AA6D67}" srcOrd="0" destOrd="0" presId="urn:microsoft.com/office/officeart/2008/layout/LinedList"/>
-    <dgm:cxn modelId="{F75F651B-FF07-407B-9D6D-A73F876EAC36}" srcId="{FB0694DE-DFD6-45BA-B184-A9E32E281C34}" destId="{E51C441C-DD9F-4E3B-9DB4-7EA3A6001EFA}" srcOrd="7" destOrd="0" parTransId="{570245CF-D495-4915-AC58-6CC430274C59}" sibTransId="{A20D259C-8F27-40E1-A75B-32BCAA6A05AA}"/>
+    <dgm:cxn modelId="{F75F651B-FF07-407B-9D6D-A73F876EAC36}" srcId="{FB0694DE-DFD6-45BA-B184-A9E32E281C34}" destId="{E51C441C-DD9F-4E3B-9DB4-7EA3A6001EFA}" srcOrd="6" destOrd="0" parTransId="{570245CF-D495-4915-AC58-6CC430274C59}" sibTransId="{A20D259C-8F27-40E1-A75B-32BCAA6A05AA}"/>
     <dgm:cxn modelId="{47879B6D-E870-4A4B-8E17-C5EECE054898}" type="presOf" srcId="{38880B31-6335-4AF7-8693-8A95DA29121C}" destId="{2AAA0AD9-6DE0-4676-AA2D-39949CBB9021}" srcOrd="0" destOrd="0" presId="urn:microsoft.com/office/officeart/2008/layout/LinedList"/>
     <dgm:cxn modelId="{43D88853-D341-4B85-9EA1-D35C75C3B811}" type="presOf" srcId="{16688A05-8CD1-422C-8D4B-754C457A9677}" destId="{6452D1B0-0F1F-4D43-8FF9-638585DFAE99}" srcOrd="0" destOrd="0" presId="urn:microsoft.com/office/officeart/2008/layout/LinedList"/>
-    <dgm:cxn modelId="{B4872E7C-8C0C-43DC-AADC-F7D92AD106C1}" srcId="{FB0694DE-DFD6-45BA-B184-A9E32E281C34}" destId="{3527EB05-C699-4F72-B42E-20D39F4630C9}" srcOrd="3" destOrd="0" parTransId="{1EDDF355-8E45-463B-BA00-1F9EEC141276}" sibTransId="{99F8B573-13C7-4787-BC7B-7515B93426F0}"/>
+    <dgm:cxn modelId="{B4872E7C-8C0C-43DC-AADC-F7D92AD106C1}" srcId="{FB0694DE-DFD6-45BA-B184-A9E32E281C34}" destId="{3527EB05-C699-4F72-B42E-20D39F4630C9}" srcOrd="2" destOrd="0" parTransId="{1EDDF355-8E45-463B-BA00-1F9EEC141276}" sibTransId="{99F8B573-13C7-4787-BC7B-7515B93426F0}"/>
     <dgm:cxn modelId="{ABDD698B-E527-4AE9-906C-56158B5A7632}" type="presOf" srcId="{3527EB05-C699-4F72-B42E-20D39F4630C9}" destId="{ABCB087D-C304-42B5-B7B0-BE2EB5CD28A0}" srcOrd="0" destOrd="0" presId="urn:microsoft.com/office/officeart/2008/layout/LinedList"/>
-    <dgm:cxn modelId="{40CC3D9A-6145-4913-9658-71A8393E60BD}" srcId="{FB0694DE-DFD6-45BA-B184-A9E32E281C34}" destId="{E4ACCCF7-AF99-48E7-AB2C-561A737DD18B}" srcOrd="2" destOrd="0" parTransId="{4382DE98-1319-4636-A391-97B5C6FCFCF3}" sibTransId="{4BA8D7B1-2995-4441-A216-B3B9AA2CF105}"/>
+    <dgm:cxn modelId="{40CC3D9A-6145-4913-9658-71A8393E60BD}" srcId="{FB0694DE-DFD6-45BA-B184-A9E32E281C34}" destId="{E4ACCCF7-AF99-48E7-AB2C-561A737DD18B}" srcOrd="1" destOrd="0" parTransId="{4382DE98-1319-4636-A391-97B5C6FCFCF3}" sibTransId="{4BA8D7B1-2995-4441-A216-B3B9AA2CF105}"/>
     <dgm:cxn modelId="{82B263A9-32D9-4310-B2AF-56C55AF300AF}" type="presOf" srcId="{E51C441C-DD9F-4E3B-9DB4-7EA3A6001EFA}" destId="{F3E97B70-D60C-4FDB-97DF-88BF5DE7CAA2}" srcOrd="0" destOrd="0" presId="urn:microsoft.com/office/officeart/2008/layout/LinedList"/>
-    <dgm:cxn modelId="{E8ED48AB-3F97-4687-890D-58405B6FB8F5}" srcId="{FB0694DE-DFD6-45BA-B184-A9E32E281C34}" destId="{38880B31-6335-4AF7-8693-8A95DA29121C}" srcOrd="5" destOrd="0" parTransId="{51466B11-193A-4AA3-9EC1-A8FA7AB45997}" sibTransId="{80591FC5-85B4-4337-A799-BA35354C874F}"/>
+    <dgm:cxn modelId="{E8ED48AB-3F97-4687-890D-58405B6FB8F5}" srcId="{FB0694DE-DFD6-45BA-B184-A9E32E281C34}" destId="{38880B31-6335-4AF7-8693-8A95DA29121C}" srcOrd="4" destOrd="0" parTransId="{51466B11-193A-4AA3-9EC1-A8FA7AB45997}" sibTransId="{80591FC5-85B4-4337-A799-BA35354C874F}"/>
     <dgm:cxn modelId="{A2373CE8-E9C0-404F-BC7F-6EB79F185D62}" type="presOf" srcId="{FB0694DE-DFD6-45BA-B184-A9E32E281C34}" destId="{BE46ED6D-D95F-4C62-9B0D-98F60E4C8ED5}" srcOrd="0" destOrd="0" presId="urn:microsoft.com/office/officeart/2008/layout/LinedList"/>
-    <dgm:cxn modelId="{DCEA42F1-3763-494D-9A97-4A0B1EF1464F}" srcId="{FB0694DE-DFD6-45BA-B184-A9E32E281C34}" destId="{5F8A560E-F6DD-4254-AF73-A5259FADD990}" srcOrd="6" destOrd="0" parTransId="{7D3519B5-DB5A-4E72-B6E0-2E445F3A1FBA}" sibTransId="{E9BDD97C-F395-4DD8-89D9-46331EA24A65}"/>
+    <dgm:cxn modelId="{DCEA42F1-3763-494D-9A97-4A0B1EF1464F}" srcId="{FB0694DE-DFD6-45BA-B184-A9E32E281C34}" destId="{5F8A560E-F6DD-4254-AF73-A5259FADD990}" srcOrd="5" destOrd="0" parTransId="{7D3519B5-DB5A-4E72-B6E0-2E445F3A1FBA}" sibTransId="{E9BDD97C-F395-4DD8-89D9-46331EA24A65}"/>
     <dgm:cxn modelId="{7243E6FB-C209-4C7E-A35E-E497D41CCEDE}" type="presOf" srcId="{E4ACCCF7-AF99-48E7-AB2C-561A737DD18B}" destId="{5FFDCD4C-7A1F-4C60-8BC4-AA16B12E29F2}" srcOrd="0" destOrd="0" presId="urn:microsoft.com/office/officeart/2008/layout/LinedList"/>
     <dgm:cxn modelId="{FDB5A5FC-9BF8-43EF-B6E1-1A40C1288A3B}" srcId="{FB0694DE-DFD6-45BA-B184-A9E32E281C34}" destId="{16688A05-8CD1-422C-8D4B-754C457A9677}" srcOrd="0" destOrd="0" parTransId="{B83D6EE1-83BF-463F-8783-44D6D3637D9B}" sibTransId="{172E18A5-9BE4-4CB1-9165-70B154AD6A8F}"/>
     <dgm:cxn modelId="{043D36E0-0A5D-42D4-8BC2-AF3F3AFAFA68}" type="presParOf" srcId="{BE46ED6D-D95F-4C62-9B0D-98F60E4C8ED5}" destId="{497F461D-EC6E-4179-927F-0C6AD93CBEAB}" srcOrd="0" destOrd="0" presId="urn:microsoft.com/office/officeart/2008/layout/LinedList"/>
     <dgm:cxn modelId="{2DF741DD-0CA7-4B37-93B2-28E52EE82ADD}" type="presParOf" srcId="{BE46ED6D-D95F-4C62-9B0D-98F60E4C8ED5}" destId="{300E4385-5189-4F6E-AFCA-6B3A01557297}" srcOrd="1" destOrd="0" presId="urn:microsoft.com/office/officeart/2008/layout/LinedList"/>
     <dgm:cxn modelId="{81D8C7A3-37A1-41B9-BAAF-4DDD77D9144C}" type="presParOf" srcId="{300E4385-5189-4F6E-AFCA-6B3A01557297}" destId="{6452D1B0-0F1F-4D43-8FF9-638585DFAE99}" srcOrd="0" destOrd="0" presId="urn:microsoft.com/office/officeart/2008/layout/LinedList"/>
     <dgm:cxn modelId="{0AC450FA-5BAF-4F6D-8D98-6D5D2697EB60}" type="presParOf" srcId="{300E4385-5189-4F6E-AFCA-6B3A01557297}" destId="{D500BA6E-E356-460C-B62D-516BE4F9C830}" srcOrd="1" destOrd="0" presId="urn:microsoft.com/office/officeart/2008/layout/LinedList"/>
-    <dgm:cxn modelId="{2FB24933-BF00-4049-B7E3-2AF8272CC3CD}" type="presParOf" srcId="{BE46ED6D-D95F-4C62-9B0D-98F60E4C8ED5}" destId="{95EF4453-BF73-4C1D-BC7F-8AF5EDEEEF69}" srcOrd="2" destOrd="0" presId="urn:microsoft.com/office/officeart/2008/layout/LinedList"/>
-    <dgm:cxn modelId="{3775F2BA-7DBA-4DCD-AFC8-D70FA399E812}" type="presParOf" srcId="{BE46ED6D-D95F-4C62-9B0D-98F60E4C8ED5}" destId="{F68A23ED-E670-4F5F-82F0-8F70611CEAA5}" srcOrd="3" destOrd="0" presId="urn:microsoft.com/office/officeart/2008/layout/LinedList"/>
-    <dgm:cxn modelId="{472083D6-A692-4E82-8DDC-09DC40E38762}" type="presParOf" srcId="{F68A23ED-E670-4F5F-82F0-8F70611CEAA5}" destId="{E113B2DD-6D52-4109-9B54-D95668AA6D67}" srcOrd="0" destOrd="0" presId="urn:microsoft.com/office/officeart/2008/layout/LinedList"/>
-    <dgm:cxn modelId="{6B78D58F-07A3-47DE-85D9-DAEE85ED46B7}" type="presParOf" srcId="{F68A23ED-E670-4F5F-82F0-8F70611CEAA5}" destId="{52A96121-CE56-48B6-BF0F-5BA8B27A52F1}" srcOrd="1" destOrd="0" presId="urn:microsoft.com/office/officeart/2008/layout/LinedList"/>
-    <dgm:cxn modelId="{F7D7DEEC-5584-4EB6-B5C2-5B7274F2F132}" type="presParOf" srcId="{BE46ED6D-D95F-4C62-9B0D-98F60E4C8ED5}" destId="{6D4E6855-10F1-4E4B-86F6-9420AEA4B5BC}" srcOrd="4" destOrd="0" presId="urn:microsoft.com/office/officeart/2008/layout/LinedList"/>
-    <dgm:cxn modelId="{1CF404A7-C73F-4DC3-A472-8A93F2630F76}" type="presParOf" srcId="{BE46ED6D-D95F-4C62-9B0D-98F60E4C8ED5}" destId="{925F6481-506F-4CA9-86C9-113872E0964C}" srcOrd="5" destOrd="0" presId="urn:microsoft.com/office/officeart/2008/layout/LinedList"/>
+    <dgm:cxn modelId="{F7D7DEEC-5584-4EB6-B5C2-5B7274F2F132}" type="presParOf" srcId="{BE46ED6D-D95F-4C62-9B0D-98F60E4C8ED5}" destId="{6D4E6855-10F1-4E4B-86F6-9420AEA4B5BC}" srcOrd="2" destOrd="0" presId="urn:microsoft.com/office/officeart/2008/layout/LinedList"/>
+    <dgm:cxn modelId="{1CF404A7-C73F-4DC3-A472-8A93F2630F76}" type="presParOf" srcId="{BE46ED6D-D95F-4C62-9B0D-98F60E4C8ED5}" destId="{925F6481-506F-4CA9-86C9-113872E0964C}" srcOrd="3" destOrd="0" presId="urn:microsoft.com/office/officeart/2008/layout/LinedList"/>
     <dgm:cxn modelId="{F5470B52-D668-48C9-A9D0-9D061C0AF05E}" type="presParOf" srcId="{925F6481-506F-4CA9-86C9-113872E0964C}" destId="{5FFDCD4C-7A1F-4C60-8BC4-AA16B12E29F2}" srcOrd="0" destOrd="0" presId="urn:microsoft.com/office/officeart/2008/layout/LinedList"/>
     <dgm:cxn modelId="{FAE9D506-4180-420B-9F20-7A64666B2A6F}" type="presParOf" srcId="{925F6481-506F-4CA9-86C9-113872E0964C}" destId="{F9A8DF34-2695-4A2F-90EF-5C4A196924E9}" srcOrd="1" destOrd="0" presId="urn:microsoft.com/office/officeart/2008/layout/LinedList"/>
-    <dgm:cxn modelId="{BAC448EB-8FF3-4BC2-9540-629FE00BD542}" type="presParOf" srcId="{BE46ED6D-D95F-4C62-9B0D-98F60E4C8ED5}" destId="{CD3C9203-DAE0-4D0C-BF9D-D55D55B76D8D}" srcOrd="6" destOrd="0" presId="urn:microsoft.com/office/officeart/2008/layout/LinedList"/>
-    <dgm:cxn modelId="{903C0153-831D-4E2B-947E-06CFE69A8C3F}" type="presParOf" srcId="{BE46ED6D-D95F-4C62-9B0D-98F60E4C8ED5}" destId="{E252B961-A896-4289-B48A-265BE689B7C2}" srcOrd="7" destOrd="0" presId="urn:microsoft.com/office/officeart/2008/layout/LinedList"/>
+    <dgm:cxn modelId="{BAC448EB-8FF3-4BC2-9540-629FE00BD542}" type="presParOf" srcId="{BE46ED6D-D95F-4C62-9B0D-98F60E4C8ED5}" destId="{CD3C9203-DAE0-4D0C-BF9D-D55D55B76D8D}" srcOrd="4" destOrd="0" presId="urn:microsoft.com/office/officeart/2008/layout/LinedList"/>
+    <dgm:cxn modelId="{903C0153-831D-4E2B-947E-06CFE69A8C3F}" type="presParOf" srcId="{BE46ED6D-D95F-4C62-9B0D-98F60E4C8ED5}" destId="{E252B961-A896-4289-B48A-265BE689B7C2}" srcOrd="5" destOrd="0" presId="urn:microsoft.com/office/officeart/2008/layout/LinedList"/>
     <dgm:cxn modelId="{E367B23B-348E-4680-B2FC-F9EA86479A7D}" type="presParOf" srcId="{E252B961-A896-4289-B48A-265BE689B7C2}" destId="{ABCB087D-C304-42B5-B7B0-BE2EB5CD28A0}" srcOrd="0" destOrd="0" presId="urn:microsoft.com/office/officeart/2008/layout/LinedList"/>
     <dgm:cxn modelId="{1B0720E3-192B-4355-806C-4D348F1464A0}" type="presParOf" srcId="{E252B961-A896-4289-B48A-265BE689B7C2}" destId="{01B56628-D5B0-4D9B-A9BD-56F0096D220E}" srcOrd="1" destOrd="0" presId="urn:microsoft.com/office/officeart/2008/layout/LinedList"/>
-    <dgm:cxn modelId="{CBDC2953-6FD8-47D1-9DFB-8231E1B78E3F}" type="presParOf" srcId="{BE46ED6D-D95F-4C62-9B0D-98F60E4C8ED5}" destId="{DBAAC0A5-4BE0-4198-A670-C41F5AA2C64A}" srcOrd="8" destOrd="0" presId="urn:microsoft.com/office/officeart/2008/layout/LinedList"/>
-    <dgm:cxn modelId="{2D9DF66F-6A51-4AE9-8398-5F7A035C369D}" type="presParOf" srcId="{BE46ED6D-D95F-4C62-9B0D-98F60E4C8ED5}" destId="{4BCCDB29-63FB-4941-B8CB-36C31775691D}" srcOrd="9" destOrd="0" presId="urn:microsoft.com/office/officeart/2008/layout/LinedList"/>
+    <dgm:cxn modelId="{CBDC2953-6FD8-47D1-9DFB-8231E1B78E3F}" type="presParOf" srcId="{BE46ED6D-D95F-4C62-9B0D-98F60E4C8ED5}" destId="{DBAAC0A5-4BE0-4198-A670-C41F5AA2C64A}" srcOrd="6" destOrd="0" presId="urn:microsoft.com/office/officeart/2008/layout/LinedList"/>
+    <dgm:cxn modelId="{2D9DF66F-6A51-4AE9-8398-5F7A035C369D}" type="presParOf" srcId="{BE46ED6D-D95F-4C62-9B0D-98F60E4C8ED5}" destId="{4BCCDB29-63FB-4941-B8CB-36C31775691D}" srcOrd="7" destOrd="0" presId="urn:microsoft.com/office/officeart/2008/layout/LinedList"/>
     <dgm:cxn modelId="{52931BB9-E126-4930-84DB-64D043E0CE00}" type="presParOf" srcId="{4BCCDB29-63FB-4941-B8CB-36C31775691D}" destId="{8712898D-FEE3-49BD-883B-3FA1892C584E}" srcOrd="0" destOrd="0" presId="urn:microsoft.com/office/officeart/2008/layout/LinedList"/>
     <dgm:cxn modelId="{BF993B12-6CC7-462B-87BA-2B52098D51CE}" type="presParOf" srcId="{4BCCDB29-63FB-4941-B8CB-36C31775691D}" destId="{B25B7D02-C018-4000-B7E6-53AF2983D544}" srcOrd="1" destOrd="0" presId="urn:microsoft.com/office/officeart/2008/layout/LinedList"/>
-    <dgm:cxn modelId="{A2270727-383A-40F3-A41D-C7BC190CCE4B}" type="presParOf" srcId="{BE46ED6D-D95F-4C62-9B0D-98F60E4C8ED5}" destId="{911A70AB-5E9A-4DF8-A39B-960757FE3BCB}" srcOrd="10" destOrd="0" presId="urn:microsoft.com/office/officeart/2008/layout/LinedList"/>
-    <dgm:cxn modelId="{B9D7274E-B57F-4FB3-9D34-4D238D997C4A}" type="presParOf" srcId="{BE46ED6D-D95F-4C62-9B0D-98F60E4C8ED5}" destId="{30940C09-D36B-4121-BB7F-E169A6BC896C}" srcOrd="11" destOrd="0" presId="urn:microsoft.com/office/officeart/2008/layout/LinedList"/>
+    <dgm:cxn modelId="{A2270727-383A-40F3-A41D-C7BC190CCE4B}" type="presParOf" srcId="{BE46ED6D-D95F-4C62-9B0D-98F60E4C8ED5}" destId="{911A70AB-5E9A-4DF8-A39B-960757FE3BCB}" srcOrd="8" destOrd="0" presId="urn:microsoft.com/office/officeart/2008/layout/LinedList"/>
+    <dgm:cxn modelId="{B9D7274E-B57F-4FB3-9D34-4D238D997C4A}" type="presParOf" srcId="{BE46ED6D-D95F-4C62-9B0D-98F60E4C8ED5}" destId="{30940C09-D36B-4121-BB7F-E169A6BC896C}" srcOrd="9" destOrd="0" presId="urn:microsoft.com/office/officeart/2008/layout/LinedList"/>
     <dgm:cxn modelId="{74D02DDE-3293-4492-AE0D-907CC39F818F}" type="presParOf" srcId="{30940C09-D36B-4121-BB7F-E169A6BC896C}" destId="{2AAA0AD9-6DE0-4676-AA2D-39949CBB9021}" srcOrd="0" destOrd="0" presId="urn:microsoft.com/office/officeart/2008/layout/LinedList"/>
     <dgm:cxn modelId="{2264BE38-A26C-42E7-816D-709765CCDFEF}" type="presParOf" srcId="{30940C09-D36B-4121-BB7F-E169A6BC896C}" destId="{1F4E83D4-14E0-4848-80A3-48891FD34568}" srcOrd="1" destOrd="0" presId="urn:microsoft.com/office/officeart/2008/layout/LinedList"/>
-    <dgm:cxn modelId="{B807B0C5-ACD5-442D-B09B-A0ADA1BD8178}" type="presParOf" srcId="{BE46ED6D-D95F-4C62-9B0D-98F60E4C8ED5}" destId="{18D39591-C8CB-477A-B24A-70531F1AE3D0}" srcOrd="12" destOrd="0" presId="urn:microsoft.com/office/officeart/2008/layout/LinedList"/>
-    <dgm:cxn modelId="{222E298C-B85D-4B03-B7E7-BFB87A0D7C1F}" type="presParOf" srcId="{BE46ED6D-D95F-4C62-9B0D-98F60E4C8ED5}" destId="{FB118834-1620-4C75-A26A-D50BFA69B9C1}" srcOrd="13" destOrd="0" presId="urn:microsoft.com/office/officeart/2008/layout/LinedList"/>
+    <dgm:cxn modelId="{B807B0C5-ACD5-442D-B09B-A0ADA1BD8178}" type="presParOf" srcId="{BE46ED6D-D95F-4C62-9B0D-98F60E4C8ED5}" destId="{18D39591-C8CB-477A-B24A-70531F1AE3D0}" srcOrd="10" destOrd="0" presId="urn:microsoft.com/office/officeart/2008/layout/LinedList"/>
+    <dgm:cxn modelId="{222E298C-B85D-4B03-B7E7-BFB87A0D7C1F}" type="presParOf" srcId="{BE46ED6D-D95F-4C62-9B0D-98F60E4C8ED5}" destId="{FB118834-1620-4C75-A26A-D50BFA69B9C1}" srcOrd="11" destOrd="0" presId="urn:microsoft.com/office/officeart/2008/layout/LinedList"/>
     <dgm:cxn modelId="{87344097-971C-4A80-9701-C5B0C40829AD}" type="presParOf" srcId="{FB118834-1620-4C75-A26A-D50BFA69B9C1}" destId="{929CB212-6DAA-4A10-B729-94E1FD65CBAD}" srcOrd="0" destOrd="0" presId="urn:microsoft.com/office/officeart/2008/layout/LinedList"/>
     <dgm:cxn modelId="{B603CD79-4126-4600-9751-6EE91E300307}" type="presParOf" srcId="{FB118834-1620-4C75-A26A-D50BFA69B9C1}" destId="{F0FDFFC8-CF37-4ADE-A1CD-038CAE4FAC6A}" srcOrd="1" destOrd="0" presId="urn:microsoft.com/office/officeart/2008/layout/LinedList"/>
-    <dgm:cxn modelId="{62BB6469-0081-4320-8EDB-44E205BDBCA8}" type="presParOf" srcId="{BE46ED6D-D95F-4C62-9B0D-98F60E4C8ED5}" destId="{171725A7-A228-46AC-B73D-550B0E628AC3}" srcOrd="14" destOrd="0" presId="urn:microsoft.com/office/officeart/2008/layout/LinedList"/>
-    <dgm:cxn modelId="{CB64A679-2FD4-4DD5-9B87-973B3C19F68C}" type="presParOf" srcId="{BE46ED6D-D95F-4C62-9B0D-98F60E4C8ED5}" destId="{AE0B1B25-94C7-4F34-8BCB-B177C22FA0D4}" srcOrd="15" destOrd="0" presId="urn:microsoft.com/office/officeart/2008/layout/LinedList"/>
+    <dgm:cxn modelId="{62BB6469-0081-4320-8EDB-44E205BDBCA8}" type="presParOf" srcId="{BE46ED6D-D95F-4C62-9B0D-98F60E4C8ED5}" destId="{171725A7-A228-46AC-B73D-550B0E628AC3}" srcOrd="12" destOrd="0" presId="urn:microsoft.com/office/officeart/2008/layout/LinedList"/>
+    <dgm:cxn modelId="{CB64A679-2FD4-4DD5-9B87-973B3C19F68C}" type="presParOf" srcId="{BE46ED6D-D95F-4C62-9B0D-98F60E4C8ED5}" destId="{AE0B1B25-94C7-4F34-8BCB-B177C22FA0D4}" srcOrd="13" destOrd="0" presId="urn:microsoft.com/office/officeart/2008/layout/LinedList"/>
     <dgm:cxn modelId="{B07EC20F-A78C-4ED7-A429-DF13B0DF6BF6}" type="presParOf" srcId="{AE0B1B25-94C7-4F34-8BCB-B177C22FA0D4}" destId="{F3E97B70-D60C-4FDB-97DF-88BF5DE7CAA2}" srcOrd="0" destOrd="0" presId="urn:microsoft.com/office/officeart/2008/layout/LinedList"/>
     <dgm:cxn modelId="{EAD83402-1FF0-4F15-8A53-E94210DB7265}" type="presParOf" srcId="{AE0B1B25-94C7-4F34-8BCB-B177C22FA0D4}" destId="{735ECF1D-A152-484A-96FD-67BA82E562BB}" srcOrd="1" destOrd="0" presId="urn:microsoft.com/office/officeart/2008/layout/LinedList"/>
   </dgm:cxnLst>
@@ -1556,7 +1484,7 @@
       </dsp:nvSpPr>
       <dsp:spPr>
         <a:xfrm>
-          <a:off x="0" y="0"/>
+          <a:off x="0" y="675"/>
           <a:ext cx="6291714" cy="0"/>
         </a:xfrm>
         <a:prstGeom prst="line">
@@ -1606,8 +1534,8 @@
       </dsp:nvSpPr>
       <dsp:spPr>
         <a:xfrm>
-          <a:off x="0" y="0"/>
-          <a:ext cx="6291714" cy="691341"/>
+          <a:off x="0" y="675"/>
+          <a:ext cx="6291714" cy="789912"/>
         </a:xfrm>
         <a:prstGeom prst="rect">
           <a:avLst/>
@@ -1650,134 +1578,7 @@
           </a:pPr>
           <a:r>
             <a:rPr lang="en-US" sz="3100" kern="1200" dirty="0"/>
-            <a:t>Svar </a:t>
-          </a:r>
-          <a:r>
-            <a:rPr lang="en-US" sz="3100" kern="1200" dirty="0" err="1"/>
-            <a:t>på</a:t>
-          </a:r>
-          <a:r>
-            <a:rPr lang="en-US" sz="3100" kern="1200" dirty="0"/>
-            <a:t> </a:t>
-          </a:r>
-          <a:r>
-            <a:rPr lang="en-US" sz="3100" kern="1200" dirty="0" err="1"/>
-            <a:t>øvelsen</a:t>
-          </a:r>
-          <a:endParaRPr lang="en-US" sz="3100" kern="1200" dirty="0"/>
-        </a:p>
-      </dsp:txBody>
-      <dsp:txXfrm>
-        <a:off x="0" y="0"/>
-        <a:ext cx="6291714" cy="691341"/>
-      </dsp:txXfrm>
-    </dsp:sp>
-    <dsp:sp modelId="{95EF4453-BF73-4C1D-BC7F-8AF5EDEEEF69}">
-      <dsp:nvSpPr>
-        <dsp:cNvPr id="0" name=""/>
-        <dsp:cNvSpPr/>
-      </dsp:nvSpPr>
-      <dsp:spPr>
-        <a:xfrm>
-          <a:off x="0" y="691341"/>
-          <a:ext cx="6291714" cy="0"/>
-        </a:xfrm>
-        <a:prstGeom prst="line">
-          <a:avLst/>
-        </a:prstGeom>
-        <a:solidFill>
-          <a:schemeClr val="accent2">
-            <a:hueOff val="920516"/>
-            <a:satOff val="-2642"/>
-            <a:lumOff val="-4230"/>
-            <a:alphaOff val="0"/>
-          </a:schemeClr>
-        </a:solidFill>
-        <a:ln w="19050" cap="flat" cmpd="sng" algn="ctr">
-          <a:solidFill>
-            <a:schemeClr val="accent2">
-              <a:hueOff val="920516"/>
-              <a:satOff val="-2642"/>
-              <a:lumOff val="-4230"/>
-              <a:alphaOff val="0"/>
-            </a:schemeClr>
-          </a:solidFill>
-          <a:prstDash val="solid"/>
-          <a:miter lim="800000"/>
-        </a:ln>
-        <a:effectLst/>
-      </dsp:spPr>
-      <dsp:style>
-        <a:lnRef idx="2">
-          <a:scrgbClr r="0" g="0" b="0"/>
-        </a:lnRef>
-        <a:fillRef idx="1">
-          <a:scrgbClr r="0" g="0" b="0"/>
-        </a:fillRef>
-        <a:effectRef idx="0">
-          <a:scrgbClr r="0" g="0" b="0"/>
-        </a:effectRef>
-        <a:fontRef idx="minor">
-          <a:schemeClr val="lt1"/>
-        </a:fontRef>
-      </dsp:style>
-    </dsp:sp>
-    <dsp:sp modelId="{E113B2DD-6D52-4109-9B54-D95668AA6D67}">
-      <dsp:nvSpPr>
-        <dsp:cNvPr id="0" name=""/>
-        <dsp:cNvSpPr/>
-      </dsp:nvSpPr>
-      <dsp:spPr>
-        <a:xfrm>
-          <a:off x="0" y="691341"/>
-          <a:ext cx="6291714" cy="691341"/>
-        </a:xfrm>
-        <a:prstGeom prst="rect">
-          <a:avLst/>
-        </a:prstGeom>
-        <a:noFill/>
-        <a:ln>
-          <a:noFill/>
-        </a:ln>
-        <a:effectLst/>
-      </dsp:spPr>
-      <dsp:style>
-        <a:lnRef idx="0">
-          <a:scrgbClr r="0" g="0" b="0"/>
-        </a:lnRef>
-        <a:fillRef idx="0">
-          <a:scrgbClr r="0" g="0" b="0"/>
-        </a:fillRef>
-        <a:effectRef idx="0">
-          <a:scrgbClr r="0" g="0" b="0"/>
-        </a:effectRef>
-        <a:fontRef idx="minor"/>
-      </dsp:style>
-      <dsp:txBody>
-        <a:bodyPr spcFirstLastPara="0" vert="horz" wrap="square" lIns="118110" tIns="118110" rIns="118110" bIns="118110" numCol="1" spcCol="1270" anchor="t" anchorCtr="0">
-          <a:noAutofit/>
-        </a:bodyPr>
-        <a:lstStyle/>
-        <a:p>
-          <a:pPr marL="0" lvl="0" indent="0" algn="l" defTabSz="1377950">
-            <a:lnSpc>
-              <a:spcPct val="90000"/>
-            </a:lnSpc>
-            <a:spcBef>
-              <a:spcPct val="0"/>
-            </a:spcBef>
-            <a:spcAft>
-              <a:spcPct val="35000"/>
-            </a:spcAft>
-            <a:buNone/>
-          </a:pPr>
-          <a:r>
-            <a:rPr lang="en-US" sz="3100" kern="1200" dirty="0" err="1"/>
-            <a:t>Helt</a:t>
-          </a:r>
-          <a:r>
-            <a:rPr lang="en-US" sz="3100" kern="1200" dirty="0"/>
-            <a:t> basic </a:t>
+            <a:t>Helt basic </a:t>
           </a:r>
           <a:r>
             <a:rPr lang="en-US" sz="3100" kern="1200" dirty="0" err="1"/>
@@ -1787,8 +1588,8 @@
         </a:p>
       </dsp:txBody>
       <dsp:txXfrm>
-        <a:off x="0" y="691341"/>
-        <a:ext cx="6291714" cy="691341"/>
+        <a:off x="0" y="675"/>
+        <a:ext cx="6291714" cy="789912"/>
       </dsp:txXfrm>
     </dsp:sp>
     <dsp:sp modelId="{6D4E6855-10F1-4E4B-86F6-9420AEA4B5BC}">
@@ -1798,7 +1599,7 @@
       </dsp:nvSpPr>
       <dsp:spPr>
         <a:xfrm>
-          <a:off x="0" y="1382683"/>
+          <a:off x="0" y="790587"/>
           <a:ext cx="6291714" cy="0"/>
         </a:xfrm>
         <a:prstGeom prst="line">
@@ -1806,18 +1607,18 @@
         </a:prstGeom>
         <a:solidFill>
           <a:schemeClr val="accent2">
-            <a:hueOff val="1841033"/>
-            <a:satOff val="-5284"/>
-            <a:lumOff val="-8460"/>
+            <a:hueOff val="1073936"/>
+            <a:satOff val="-3082"/>
+            <a:lumOff val="-4935"/>
             <a:alphaOff val="0"/>
           </a:schemeClr>
         </a:solidFill>
         <a:ln w="19050" cap="flat" cmpd="sng" algn="ctr">
           <a:solidFill>
             <a:schemeClr val="accent2">
-              <a:hueOff val="1841033"/>
-              <a:satOff val="-5284"/>
-              <a:lumOff val="-8460"/>
+              <a:hueOff val="1073936"/>
+              <a:satOff val="-3082"/>
+              <a:lumOff val="-4935"/>
               <a:alphaOff val="0"/>
             </a:schemeClr>
           </a:solidFill>
@@ -1848,8 +1649,8 @@
       </dsp:nvSpPr>
       <dsp:spPr>
         <a:xfrm>
-          <a:off x="0" y="1382683"/>
-          <a:ext cx="6291714" cy="691341"/>
+          <a:off x="0" y="790587"/>
+          <a:ext cx="6291714" cy="789912"/>
         </a:xfrm>
         <a:prstGeom prst="rect">
           <a:avLst/>
@@ -1910,8 +1711,8 @@
         </a:p>
       </dsp:txBody>
       <dsp:txXfrm>
-        <a:off x="0" y="1382683"/>
-        <a:ext cx="6291714" cy="691341"/>
+        <a:off x="0" y="790587"/>
+        <a:ext cx="6291714" cy="789912"/>
       </dsp:txXfrm>
     </dsp:sp>
     <dsp:sp modelId="{CD3C9203-DAE0-4D0C-BF9D-D55D55B76D8D}">
@@ -1921,7 +1722,7 @@
       </dsp:nvSpPr>
       <dsp:spPr>
         <a:xfrm>
-          <a:off x="0" y="2074025"/>
+          <a:off x="0" y="1580499"/>
           <a:ext cx="6291714" cy="0"/>
         </a:xfrm>
         <a:prstGeom prst="line">
@@ -1929,18 +1730,18 @@
         </a:prstGeom>
         <a:solidFill>
           <a:schemeClr val="accent2">
-            <a:hueOff val="2761549"/>
-            <a:satOff val="-7926"/>
-            <a:lumOff val="-12690"/>
+            <a:hueOff val="2147871"/>
+            <a:satOff val="-6164"/>
+            <a:lumOff val="-9870"/>
             <a:alphaOff val="0"/>
           </a:schemeClr>
         </a:solidFill>
         <a:ln w="19050" cap="flat" cmpd="sng" algn="ctr">
           <a:solidFill>
             <a:schemeClr val="accent2">
-              <a:hueOff val="2761549"/>
-              <a:satOff val="-7926"/>
-              <a:lumOff val="-12690"/>
+              <a:hueOff val="2147871"/>
+              <a:satOff val="-6164"/>
+              <a:lumOff val="-9870"/>
               <a:alphaOff val="0"/>
             </a:schemeClr>
           </a:solidFill>
@@ -1971,8 +1772,8 @@
       </dsp:nvSpPr>
       <dsp:spPr>
         <a:xfrm>
-          <a:off x="0" y="2074025"/>
-          <a:ext cx="6291714" cy="691341"/>
+          <a:off x="0" y="1580499"/>
+          <a:ext cx="6291714" cy="789912"/>
         </a:xfrm>
         <a:prstGeom prst="rect">
           <a:avLst/>
@@ -2041,8 +1842,8 @@
         </a:p>
       </dsp:txBody>
       <dsp:txXfrm>
-        <a:off x="0" y="2074025"/>
-        <a:ext cx="6291714" cy="691341"/>
+        <a:off x="0" y="1580499"/>
+        <a:ext cx="6291714" cy="789912"/>
       </dsp:txXfrm>
     </dsp:sp>
     <dsp:sp modelId="{DBAAC0A5-4BE0-4198-A670-C41F5AA2C64A}">
@@ -2052,7 +1853,7 @@
       </dsp:nvSpPr>
       <dsp:spPr>
         <a:xfrm>
-          <a:off x="0" y="2765367"/>
+          <a:off x="0" y="2370411"/>
           <a:ext cx="6291714" cy="0"/>
         </a:xfrm>
         <a:prstGeom prst="line">
@@ -2060,18 +1861,18 @@
         </a:prstGeom>
         <a:solidFill>
           <a:schemeClr val="accent2">
-            <a:hueOff val="3682065"/>
-            <a:satOff val="-10567"/>
-            <a:lumOff val="-16919"/>
+            <a:hueOff val="3221807"/>
+            <a:satOff val="-9246"/>
+            <a:lumOff val="-14805"/>
             <a:alphaOff val="0"/>
           </a:schemeClr>
         </a:solidFill>
         <a:ln w="19050" cap="flat" cmpd="sng" algn="ctr">
           <a:solidFill>
             <a:schemeClr val="accent2">
-              <a:hueOff val="3682065"/>
-              <a:satOff val="-10567"/>
-              <a:lumOff val="-16919"/>
+              <a:hueOff val="3221807"/>
+              <a:satOff val="-9246"/>
+              <a:lumOff val="-14805"/>
               <a:alphaOff val="0"/>
             </a:schemeClr>
           </a:solidFill>
@@ -2102,8 +1903,8 @@
       </dsp:nvSpPr>
       <dsp:spPr>
         <a:xfrm>
-          <a:off x="0" y="2765367"/>
-          <a:ext cx="6291714" cy="691341"/>
+          <a:off x="0" y="2370411"/>
+          <a:ext cx="6291714" cy="789912"/>
         </a:xfrm>
         <a:prstGeom prst="rect">
           <a:avLst/>
@@ -2155,8 +1956,8 @@
         </a:p>
       </dsp:txBody>
       <dsp:txXfrm>
-        <a:off x="0" y="2765367"/>
-        <a:ext cx="6291714" cy="691341"/>
+        <a:off x="0" y="2370411"/>
+        <a:ext cx="6291714" cy="789912"/>
       </dsp:txXfrm>
     </dsp:sp>
     <dsp:sp modelId="{911A70AB-5E9A-4DF8-A39B-960757FE3BCB}">
@@ -2166,7 +1967,7 @@
       </dsp:nvSpPr>
       <dsp:spPr>
         <a:xfrm>
-          <a:off x="0" y="3456709"/>
+          <a:off x="0" y="3160323"/>
           <a:ext cx="6291714" cy="0"/>
         </a:xfrm>
         <a:prstGeom prst="line">
@@ -2174,18 +1975,18 @@
         </a:prstGeom>
         <a:solidFill>
           <a:schemeClr val="accent2">
-            <a:hueOff val="4602581"/>
-            <a:satOff val="-13209"/>
-            <a:lumOff val="-21149"/>
+            <a:hueOff val="4295743"/>
+            <a:satOff val="-12329"/>
+            <a:lumOff val="-19739"/>
             <a:alphaOff val="0"/>
           </a:schemeClr>
         </a:solidFill>
         <a:ln w="19050" cap="flat" cmpd="sng" algn="ctr">
           <a:solidFill>
             <a:schemeClr val="accent2">
-              <a:hueOff val="4602581"/>
-              <a:satOff val="-13209"/>
-              <a:lumOff val="-21149"/>
+              <a:hueOff val="4295743"/>
+              <a:satOff val="-12329"/>
+              <a:lumOff val="-19739"/>
               <a:alphaOff val="0"/>
             </a:schemeClr>
           </a:solidFill>
@@ -2216,8 +2017,8 @@
       </dsp:nvSpPr>
       <dsp:spPr>
         <a:xfrm>
-          <a:off x="0" y="3456709"/>
-          <a:ext cx="6291714" cy="691341"/>
+          <a:off x="0" y="3160323"/>
+          <a:ext cx="6291714" cy="789912"/>
         </a:xfrm>
         <a:prstGeom prst="rect">
           <a:avLst/>
@@ -2265,8 +2066,8 @@
         </a:p>
       </dsp:txBody>
       <dsp:txXfrm>
-        <a:off x="0" y="3456709"/>
-        <a:ext cx="6291714" cy="691341"/>
+        <a:off x="0" y="3160323"/>
+        <a:ext cx="6291714" cy="789912"/>
       </dsp:txXfrm>
     </dsp:sp>
     <dsp:sp modelId="{18D39591-C8CB-477A-B24A-70531F1AE3D0}">
@@ -2276,7 +2077,7 @@
       </dsp:nvSpPr>
       <dsp:spPr>
         <a:xfrm>
-          <a:off x="0" y="4148051"/>
+          <a:off x="0" y="3950235"/>
           <a:ext cx="6291714" cy="0"/>
         </a:xfrm>
         <a:prstGeom prst="line">
@@ -2284,18 +2085,18 @@
         </a:prstGeom>
         <a:solidFill>
           <a:schemeClr val="accent2">
-            <a:hueOff val="5523098"/>
-            <a:satOff val="-15851"/>
-            <a:lumOff val="-25379"/>
+            <a:hueOff val="5369678"/>
+            <a:satOff val="-15411"/>
+            <a:lumOff val="-24674"/>
             <a:alphaOff val="0"/>
           </a:schemeClr>
         </a:solidFill>
         <a:ln w="19050" cap="flat" cmpd="sng" algn="ctr">
           <a:solidFill>
             <a:schemeClr val="accent2">
-              <a:hueOff val="5523098"/>
-              <a:satOff val="-15851"/>
-              <a:lumOff val="-25379"/>
+              <a:hueOff val="5369678"/>
+              <a:satOff val="-15411"/>
+              <a:lumOff val="-24674"/>
               <a:alphaOff val="0"/>
             </a:schemeClr>
           </a:solidFill>
@@ -2326,8 +2127,8 @@
       </dsp:nvSpPr>
       <dsp:spPr>
         <a:xfrm>
-          <a:off x="0" y="4148051"/>
-          <a:ext cx="6291714" cy="691341"/>
+          <a:off x="0" y="3950235"/>
+          <a:ext cx="6291714" cy="789912"/>
         </a:xfrm>
         <a:prstGeom prst="rect">
           <a:avLst/>
@@ -2403,8 +2204,8 @@
         </a:p>
       </dsp:txBody>
       <dsp:txXfrm>
-        <a:off x="0" y="4148051"/>
-        <a:ext cx="6291714" cy="691341"/>
+        <a:off x="0" y="3950235"/>
+        <a:ext cx="6291714" cy="789912"/>
       </dsp:txXfrm>
     </dsp:sp>
     <dsp:sp modelId="{171725A7-A228-46AC-B73D-550B0E628AC3}">
@@ -2414,7 +2215,7 @@
       </dsp:nvSpPr>
       <dsp:spPr>
         <a:xfrm>
-          <a:off x="0" y="4839393"/>
+          <a:off x="0" y="4740147"/>
           <a:ext cx="6291714" cy="0"/>
         </a:xfrm>
         <a:prstGeom prst="line">
@@ -2464,8 +2265,8 @@
       </dsp:nvSpPr>
       <dsp:spPr>
         <a:xfrm>
-          <a:off x="0" y="4839393"/>
-          <a:ext cx="6291714" cy="691341"/>
+          <a:off x="0" y="4740147"/>
+          <a:ext cx="6291714" cy="789912"/>
         </a:xfrm>
         <a:prstGeom prst="rect">
           <a:avLst/>
@@ -2541,8 +2342,8 @@
         </a:p>
       </dsp:txBody>
       <dsp:txXfrm>
-        <a:off x="0" y="4839393"/>
-        <a:ext cx="6291714" cy="691341"/>
+        <a:off x="0" y="4740147"/>
+        <a:ext cx="6291714" cy="789912"/>
       </dsp:txXfrm>
     </dsp:sp>
   </dsp:spTree>
@@ -4131,7 +3932,7 @@
           <a:p>
             <a:fld id="{14456939-B675-48EC-832C-1A67790AD94F}" type="datetimeFigureOut">
               <a:rPr lang="da-DK" smtClean="0"/>
-              <a:t>30-09-2024</a:t>
+              <a:t>22-04-2025</a:t>
             </a:fld>
             <a:endParaRPr lang="da-DK"/>
           </a:p>
@@ -4463,7 +4264,7 @@
           <a:p>
             <a:fld id="{F7372562-EED8-45F3-9F76-7108979F30FA}" type="slidenum">
               <a:rPr lang="da-DK" smtClean="0"/>
-              <a:t>7</a:t>
+              <a:t>9</a:t>
             </a:fld>
             <a:endParaRPr lang="da-DK"/>
           </a:p>
@@ -4629,7 +4430,7 @@
           <a:p>
             <a:fld id="{EC4AE6B9-E943-4EAF-A560-CBFA5357EA60}" type="datetimeFigureOut">
               <a:rPr lang="da-DK" smtClean="0"/>
-              <a:t>30-09-2024</a:t>
+              <a:t>22-04-2025</a:t>
             </a:fld>
             <a:endParaRPr lang="da-DK"/>
           </a:p>
@@ -4827,7 +4628,7 @@
           <a:p>
             <a:fld id="{EC4AE6B9-E943-4EAF-A560-CBFA5357EA60}" type="datetimeFigureOut">
               <a:rPr lang="da-DK" smtClean="0"/>
-              <a:t>30-09-2024</a:t>
+              <a:t>22-04-2025</a:t>
             </a:fld>
             <a:endParaRPr lang="da-DK"/>
           </a:p>
@@ -5035,7 +4836,7 @@
           <a:p>
             <a:fld id="{EC4AE6B9-E943-4EAF-A560-CBFA5357EA60}" type="datetimeFigureOut">
               <a:rPr lang="da-DK" smtClean="0"/>
-              <a:t>30-09-2024</a:t>
+              <a:t>22-04-2025</a:t>
             </a:fld>
             <a:endParaRPr lang="da-DK"/>
           </a:p>
@@ -5233,7 +5034,7 @@
           <a:p>
             <a:fld id="{EC4AE6B9-E943-4EAF-A560-CBFA5357EA60}" type="datetimeFigureOut">
               <a:rPr lang="da-DK" smtClean="0"/>
-              <a:t>30-09-2024</a:t>
+              <a:t>22-04-2025</a:t>
             </a:fld>
             <a:endParaRPr lang="da-DK"/>
           </a:p>
@@ -5508,7 +5309,7 @@
           <a:p>
             <a:fld id="{EC4AE6B9-E943-4EAF-A560-CBFA5357EA60}" type="datetimeFigureOut">
               <a:rPr lang="da-DK" smtClean="0"/>
-              <a:t>30-09-2024</a:t>
+              <a:t>22-04-2025</a:t>
             </a:fld>
             <a:endParaRPr lang="da-DK"/>
           </a:p>
@@ -5773,7 +5574,7 @@
           <a:p>
             <a:fld id="{EC4AE6B9-E943-4EAF-A560-CBFA5357EA60}" type="datetimeFigureOut">
               <a:rPr lang="da-DK" smtClean="0"/>
-              <a:t>30-09-2024</a:t>
+              <a:t>22-04-2025</a:t>
             </a:fld>
             <a:endParaRPr lang="da-DK"/>
           </a:p>
@@ -6185,7 +5986,7 @@
           <a:p>
             <a:fld id="{EC4AE6B9-E943-4EAF-A560-CBFA5357EA60}" type="datetimeFigureOut">
               <a:rPr lang="da-DK" smtClean="0"/>
-              <a:t>30-09-2024</a:t>
+              <a:t>22-04-2025</a:t>
             </a:fld>
             <a:endParaRPr lang="da-DK"/>
           </a:p>
@@ -6326,7 +6127,7 @@
           <a:p>
             <a:fld id="{EC4AE6B9-E943-4EAF-A560-CBFA5357EA60}" type="datetimeFigureOut">
               <a:rPr lang="da-DK" smtClean="0"/>
-              <a:t>30-09-2024</a:t>
+              <a:t>22-04-2025</a:t>
             </a:fld>
             <a:endParaRPr lang="da-DK"/>
           </a:p>
@@ -6439,7 +6240,7 @@
           <a:p>
             <a:fld id="{EC4AE6B9-E943-4EAF-A560-CBFA5357EA60}" type="datetimeFigureOut">
               <a:rPr lang="da-DK" smtClean="0"/>
-              <a:t>30-09-2024</a:t>
+              <a:t>22-04-2025</a:t>
             </a:fld>
             <a:endParaRPr lang="da-DK"/>
           </a:p>
@@ -6750,7 +6551,7 @@
           <a:p>
             <a:fld id="{EC4AE6B9-E943-4EAF-A560-CBFA5357EA60}" type="datetimeFigureOut">
               <a:rPr lang="da-DK" smtClean="0"/>
-              <a:t>30-09-2024</a:t>
+              <a:t>22-04-2025</a:t>
             </a:fld>
             <a:endParaRPr lang="da-DK"/>
           </a:p>
@@ -7038,7 +6839,7 @@
           <a:p>
             <a:fld id="{EC4AE6B9-E943-4EAF-A560-CBFA5357EA60}" type="datetimeFigureOut">
               <a:rPr lang="da-DK" smtClean="0"/>
-              <a:t>30-09-2024</a:t>
+              <a:t>22-04-2025</a:t>
             </a:fld>
             <a:endParaRPr lang="da-DK"/>
           </a:p>
@@ -7279,7 +7080,7 @@
           <a:p>
             <a:fld id="{EC4AE6B9-E943-4EAF-A560-CBFA5357EA60}" type="datetimeFigureOut">
               <a:rPr lang="da-DK" smtClean="0"/>
-              <a:t>30-09-2024</a:t>
+              <a:t>22-04-2025</a:t>
             </a:fld>
             <a:endParaRPr lang="da-DK"/>
           </a:p>
@@ -7809,6 +7610,670 @@
           <p:cNvPr id="2" name="Titel 1">
             <a:extLst>
               <a:ext uri="{FF2B5EF4-FFF2-40B4-BE49-F238E27FC236}">
+                <a16:creationId xmlns:a16="http://schemas.microsoft.com/office/drawing/2014/main" id="{F0A2DC4B-CB74-6B4B-B694-91AAB018AEA7}"/>
+              </a:ext>
+            </a:extLst>
+          </p:cNvPr>
+          <p:cNvSpPr>
+            <a:spLocks noGrp="1"/>
+          </p:cNvSpPr>
+          <p:nvPr>
+            <p:ph type="title"/>
+          </p:nvPr>
+        </p:nvSpPr>
+        <p:spPr/>
+        <p:txBody>
+          <a:bodyPr/>
+          <a:lstStyle/>
+          <a:p>
+            <a:r>
+              <a:rPr lang="en-US" dirty="0" err="1"/>
+              <a:t>Hvad</a:t>
+            </a:r>
+            <a:r>
+              <a:rPr lang="en-US" dirty="0"/>
+              <a:t> er </a:t>
+            </a:r>
+            <a:r>
+              <a:rPr lang="en-US" dirty="0" err="1"/>
+              <a:t>normalfordeling</a:t>
+            </a:r>
+            <a:r>
+              <a:rPr lang="en-US" dirty="0"/>
+              <a:t> </a:t>
+            </a:r>
+            <a:r>
+              <a:rPr lang="en-US" dirty="0" err="1"/>
+              <a:t>så</a:t>
+            </a:r>
+            <a:r>
+              <a:rPr lang="en-US" dirty="0"/>
+              <a:t>?</a:t>
+            </a:r>
+            <a:endParaRPr lang="da-DK" dirty="0"/>
+          </a:p>
+        </p:txBody>
+      </p:sp>
+      <p:sp>
+        <p:nvSpPr>
+          <p:cNvPr id="3" name="Pladsholder til indhold 2">
+            <a:extLst>
+              <a:ext uri="{FF2B5EF4-FFF2-40B4-BE49-F238E27FC236}">
+                <a16:creationId xmlns:a16="http://schemas.microsoft.com/office/drawing/2014/main" id="{FB50FEFC-D48B-9312-CC76-8D9FDF32E179}"/>
+              </a:ext>
+            </a:extLst>
+          </p:cNvPr>
+          <p:cNvSpPr>
+            <a:spLocks noGrp="1"/>
+          </p:cNvSpPr>
+          <p:nvPr>
+            <p:ph idx="1"/>
+          </p:nvPr>
+        </p:nvSpPr>
+        <p:spPr/>
+        <p:txBody>
+          <a:bodyPr/>
+          <a:lstStyle/>
+          <a:p>
+            <a:r>
+              <a:rPr lang="en-US" dirty="0"/>
+              <a:t>En </a:t>
+            </a:r>
+            <a:r>
+              <a:rPr lang="en-US" dirty="0" err="1"/>
+              <a:t>hyppig</a:t>
+            </a:r>
+            <a:r>
+              <a:rPr lang="en-US" dirty="0"/>
+              <a:t> </a:t>
+            </a:r>
+            <a:r>
+              <a:rPr lang="en-US" dirty="0" err="1"/>
+              <a:t>måde</a:t>
+            </a:r>
+            <a:r>
+              <a:rPr lang="en-US" dirty="0"/>
+              <a:t> for ting at </a:t>
+            </a:r>
+            <a:r>
+              <a:rPr lang="en-US" dirty="0" err="1"/>
+              <a:t>fordele</a:t>
+            </a:r>
+            <a:r>
+              <a:rPr lang="en-US" dirty="0"/>
+              <a:t> sig </a:t>
+            </a:r>
+            <a:r>
+              <a:rPr lang="en-US" dirty="0" err="1"/>
+              <a:t>på</a:t>
+            </a:r>
+            <a:r>
+              <a:rPr lang="en-US" dirty="0"/>
+              <a:t> </a:t>
+            </a:r>
+            <a:r>
+              <a:rPr lang="en-US" dirty="0" err="1"/>
+              <a:t>i</a:t>
+            </a:r>
+            <a:r>
+              <a:rPr lang="en-US" dirty="0"/>
+              <a:t> </a:t>
+            </a:r>
+            <a:r>
+              <a:rPr lang="en-US" dirty="0" err="1"/>
+              <a:t>naturen</a:t>
+            </a:r>
+            <a:endParaRPr lang="en-US" dirty="0"/>
+          </a:p>
+          <a:p>
+            <a:endParaRPr lang="en-US" dirty="0"/>
+          </a:p>
+          <a:p>
+            <a:r>
+              <a:rPr lang="en-US" dirty="0"/>
+              <a:t>En </a:t>
+            </a:r>
+            <a:r>
+              <a:rPr lang="en-US" dirty="0" err="1"/>
+              <a:t>antagelse</a:t>
+            </a:r>
+            <a:r>
+              <a:rPr lang="en-US" dirty="0"/>
+              <a:t> for mange </a:t>
+            </a:r>
+            <a:r>
+              <a:rPr lang="en-US" dirty="0" err="1"/>
+              <a:t>statistiske</a:t>
+            </a:r>
+            <a:r>
+              <a:rPr lang="en-US" dirty="0"/>
+              <a:t> tests</a:t>
+            </a:r>
+          </a:p>
+          <a:p>
+            <a:pPr lvl="1"/>
+            <a:r>
+              <a:rPr lang="en-US" dirty="0" err="1"/>
+              <a:t>Også</a:t>
+            </a:r>
+            <a:r>
+              <a:rPr lang="en-US" dirty="0"/>
+              <a:t> </a:t>
+            </a:r>
+            <a:r>
+              <a:rPr lang="en-US" dirty="0" err="1"/>
+              <a:t>kaldet</a:t>
+            </a:r>
+            <a:r>
+              <a:rPr lang="en-US" dirty="0"/>
+              <a:t> “</a:t>
+            </a:r>
+            <a:r>
+              <a:rPr lang="en-US" dirty="0" err="1"/>
+              <a:t>parametriske</a:t>
+            </a:r>
+            <a:r>
+              <a:rPr lang="en-US" dirty="0"/>
+              <a:t>” tests</a:t>
+            </a:r>
+          </a:p>
+          <a:p>
+            <a:endParaRPr lang="da-DK" dirty="0"/>
+          </a:p>
+        </p:txBody>
+      </p:sp>
+    </p:spTree>
+    <p:extLst>
+      <p:ext uri="{BB962C8B-B14F-4D97-AF65-F5344CB8AC3E}">
+        <p14:creationId xmlns:p14="http://schemas.microsoft.com/office/powerpoint/2010/main" val="1018967817"/>
+      </p:ext>
+    </p:extLst>
+  </p:cSld>
+  <p:clrMapOvr>
+    <a:masterClrMapping/>
+  </p:clrMapOvr>
+</p:sld>
+</file>
+
+<file path=ppt/slides/slide11.xml><?xml version="1.0" encoding="utf-8"?>
+<p:sld xmlns:a="http://schemas.openxmlformats.org/drawingml/2006/main" xmlns:r="http://schemas.openxmlformats.org/officeDocument/2006/relationships" xmlns:p="http://schemas.openxmlformats.org/presentationml/2006/main">
+  <p:cSld>
+    <p:spTree>
+      <p:nvGrpSpPr>
+        <p:cNvPr id="1" name=""/>
+        <p:cNvGrpSpPr/>
+        <p:nvPr/>
+      </p:nvGrpSpPr>
+      <p:grpSpPr>
+        <a:xfrm>
+          <a:off x="0" y="0"/>
+          <a:ext cx="0" cy="0"/>
+          <a:chOff x="0" y="0"/>
+          <a:chExt cx="0" cy="0"/>
+        </a:xfrm>
+      </p:grpSpPr>
+      <p:sp>
+        <p:nvSpPr>
+          <p:cNvPr id="2" name="Titel 1">
+            <a:extLst>
+              <a:ext uri="{FF2B5EF4-FFF2-40B4-BE49-F238E27FC236}">
+                <a16:creationId xmlns:a16="http://schemas.microsoft.com/office/drawing/2014/main" id="{85D8A2BC-074F-7A8C-6B58-B6B0D7D84FF2}"/>
+              </a:ext>
+            </a:extLst>
+          </p:cNvPr>
+          <p:cNvSpPr>
+            <a:spLocks noGrp="1"/>
+          </p:cNvSpPr>
+          <p:nvPr>
+            <p:ph type="title"/>
+          </p:nvPr>
+        </p:nvSpPr>
+        <p:spPr/>
+        <p:txBody>
+          <a:bodyPr/>
+          <a:lstStyle/>
+          <a:p>
+            <a:r>
+              <a:rPr lang="en-US" dirty="0" err="1"/>
+              <a:t>Hvad</a:t>
+            </a:r>
+            <a:r>
+              <a:rPr lang="en-US" dirty="0"/>
+              <a:t> er </a:t>
+            </a:r>
+            <a:r>
+              <a:rPr lang="en-US" dirty="0" err="1"/>
+              <a:t>normalfordeling</a:t>
+            </a:r>
+            <a:r>
+              <a:rPr lang="en-US" dirty="0"/>
+              <a:t> IKKE</a:t>
+            </a:r>
+            <a:endParaRPr lang="da-DK" dirty="0"/>
+          </a:p>
+        </p:txBody>
+      </p:sp>
+      <p:sp>
+        <p:nvSpPr>
+          <p:cNvPr id="3" name="Pladsholder til indhold 2">
+            <a:extLst>
+              <a:ext uri="{FF2B5EF4-FFF2-40B4-BE49-F238E27FC236}">
+                <a16:creationId xmlns:a16="http://schemas.microsoft.com/office/drawing/2014/main" id="{4E845187-4D97-1905-FA45-1494B0B4225D}"/>
+              </a:ext>
+            </a:extLst>
+          </p:cNvPr>
+          <p:cNvSpPr>
+            <a:spLocks noGrp="1"/>
+          </p:cNvSpPr>
+          <p:nvPr>
+            <p:ph idx="1"/>
+          </p:nvPr>
+        </p:nvSpPr>
+        <p:spPr/>
+        <p:txBody>
+          <a:bodyPr/>
+          <a:lstStyle/>
+          <a:p>
+            <a:r>
+              <a:rPr lang="en-US" dirty="0" err="1"/>
+              <a:t>Magisk</a:t>
+            </a:r>
+            <a:endParaRPr lang="en-US" dirty="0"/>
+          </a:p>
+          <a:p>
+            <a:r>
+              <a:rPr lang="en-US" dirty="0" err="1"/>
+              <a:t>Bedre</a:t>
+            </a:r>
+            <a:r>
+              <a:rPr lang="en-US" dirty="0"/>
+              <a:t> end </a:t>
+            </a:r>
+            <a:r>
+              <a:rPr lang="en-US" dirty="0" err="1"/>
+              <a:t>andre</a:t>
+            </a:r>
+            <a:r>
+              <a:rPr lang="en-US" dirty="0"/>
+              <a:t> </a:t>
+            </a:r>
+            <a:r>
+              <a:rPr lang="en-US" dirty="0" err="1"/>
+              <a:t>distributioner</a:t>
+            </a:r>
+            <a:r>
+              <a:rPr lang="en-US" dirty="0"/>
+              <a:t> </a:t>
+            </a:r>
+          </a:p>
+          <a:p>
+            <a:r>
+              <a:rPr lang="da-DK" dirty="0"/>
+              <a:t>Mere robust </a:t>
+            </a:r>
+          </a:p>
+          <a:p>
+            <a:r>
+              <a:rPr lang="da-DK" dirty="0"/>
+              <a:t>”normalt”</a:t>
+            </a:r>
+          </a:p>
+        </p:txBody>
+      </p:sp>
+      <p:pic>
+        <p:nvPicPr>
+          <p:cNvPr id="8194" name="Picture 2">
+            <a:extLst>
+              <a:ext uri="{FF2B5EF4-FFF2-40B4-BE49-F238E27FC236}">
+                <a16:creationId xmlns:a16="http://schemas.microsoft.com/office/drawing/2014/main" id="{CB226D01-CFA7-4D34-457C-F2B44BF512FE}"/>
+              </a:ext>
+            </a:extLst>
+          </p:cNvPr>
+          <p:cNvPicPr>
+            <a:picLocks noChangeAspect="1" noChangeArrowheads="1"/>
+          </p:cNvPicPr>
+          <p:nvPr/>
+        </p:nvPicPr>
+        <p:blipFill>
+          <a:blip r:embed="rId2">
+            <a:extLst>
+              <a:ext uri="{28A0092B-C50C-407E-A947-70E740481C1C}">
+                <a14:useLocalDpi xmlns:a14="http://schemas.microsoft.com/office/drawing/2010/main" val="0"/>
+              </a:ext>
+            </a:extLst>
+          </a:blip>
+          <a:srcRect/>
+          <a:stretch/>
+        </p:blipFill>
+        <p:spPr bwMode="auto">
+          <a:xfrm>
+            <a:off x="6645107" y="1491048"/>
+            <a:ext cx="5073127" cy="5073127"/>
+          </a:xfrm>
+          <a:prstGeom prst="rect">
+            <a:avLst/>
+          </a:prstGeom>
+          <a:noFill/>
+          <a:extLst>
+            <a:ext uri="{909E8E84-426E-40DD-AFC4-6F175D3DCCD1}">
+              <a14:hiddenFill xmlns:a14="http://schemas.microsoft.com/office/drawing/2010/main">
+                <a:solidFill>
+                  <a:srgbClr val="FFFFFF"/>
+                </a:solidFill>
+              </a14:hiddenFill>
+            </a:ext>
+          </a:extLst>
+        </p:spPr>
+      </p:pic>
+    </p:spTree>
+    <p:extLst>
+      <p:ext uri="{BB962C8B-B14F-4D97-AF65-F5344CB8AC3E}">
+        <p14:creationId xmlns:p14="http://schemas.microsoft.com/office/powerpoint/2010/main" val="3248773268"/>
+      </p:ext>
+    </p:extLst>
+  </p:cSld>
+  <p:clrMapOvr>
+    <a:masterClrMapping/>
+  </p:clrMapOvr>
+  <p:timing>
+    <p:tnLst>
+      <p:par>
+        <p:cTn id="1" dur="indefinite" restart="never" nodeType="tmRoot">
+          <p:childTnLst>
+            <p:seq concurrent="1" nextAc="seek">
+              <p:cTn id="2" dur="indefinite" nodeType="mainSeq">
+                <p:childTnLst>
+                  <p:par>
+                    <p:cTn id="3" fill="hold">
+                      <p:stCondLst>
+                        <p:cond delay="indefinite"/>
+                      </p:stCondLst>
+                      <p:childTnLst>
+                        <p:par>
+                          <p:cTn id="4" fill="hold">
+                            <p:stCondLst>
+                              <p:cond delay="0"/>
+                            </p:stCondLst>
+                            <p:childTnLst>
+                              <p:par>
+                                <p:cTn id="5" presetID="1" presetClass="entr" presetSubtype="0" fill="hold" grpId="0" nodeType="clickEffect">
+                                  <p:stCondLst>
+                                    <p:cond delay="0"/>
+                                  </p:stCondLst>
+                                  <p:childTnLst>
+                                    <p:set>
+                                      <p:cBhvr>
+                                        <p:cTn id="6" dur="1" fill="hold">
+                                          <p:stCondLst>
+                                            <p:cond delay="0"/>
+                                          </p:stCondLst>
+                                        </p:cTn>
+                                        <p:tgtEl>
+                                          <p:spTgt spid="3">
+                                            <p:txEl>
+                                              <p:pRg st="0" end="0"/>
+                                            </p:txEl>
+                                          </p:spTgt>
+                                        </p:tgtEl>
+                                        <p:attrNameLst>
+                                          <p:attrName>style.visibility</p:attrName>
+                                        </p:attrNameLst>
+                                      </p:cBhvr>
+                                      <p:to>
+                                        <p:strVal val="visible"/>
+                                      </p:to>
+                                    </p:set>
+                                  </p:childTnLst>
+                                </p:cTn>
+                              </p:par>
+                            </p:childTnLst>
+                          </p:cTn>
+                        </p:par>
+                      </p:childTnLst>
+                    </p:cTn>
+                  </p:par>
+                  <p:par>
+                    <p:cTn id="7" fill="hold">
+                      <p:stCondLst>
+                        <p:cond delay="indefinite"/>
+                      </p:stCondLst>
+                      <p:childTnLst>
+                        <p:par>
+                          <p:cTn id="8" fill="hold">
+                            <p:stCondLst>
+                              <p:cond delay="0"/>
+                            </p:stCondLst>
+                            <p:childTnLst>
+                              <p:par>
+                                <p:cTn id="9" presetID="1" presetClass="entr" presetSubtype="0" fill="hold" grpId="0" nodeType="clickEffect">
+                                  <p:stCondLst>
+                                    <p:cond delay="0"/>
+                                  </p:stCondLst>
+                                  <p:childTnLst>
+                                    <p:set>
+                                      <p:cBhvr>
+                                        <p:cTn id="10" dur="1" fill="hold">
+                                          <p:stCondLst>
+                                            <p:cond delay="0"/>
+                                          </p:stCondLst>
+                                        </p:cTn>
+                                        <p:tgtEl>
+                                          <p:spTgt spid="3">
+                                            <p:txEl>
+                                              <p:pRg st="1" end="1"/>
+                                            </p:txEl>
+                                          </p:spTgt>
+                                        </p:tgtEl>
+                                        <p:attrNameLst>
+                                          <p:attrName>style.visibility</p:attrName>
+                                        </p:attrNameLst>
+                                      </p:cBhvr>
+                                      <p:to>
+                                        <p:strVal val="visible"/>
+                                      </p:to>
+                                    </p:set>
+                                  </p:childTnLst>
+                                </p:cTn>
+                              </p:par>
+                            </p:childTnLst>
+                          </p:cTn>
+                        </p:par>
+                      </p:childTnLst>
+                    </p:cTn>
+                  </p:par>
+                  <p:par>
+                    <p:cTn id="11" fill="hold">
+                      <p:stCondLst>
+                        <p:cond delay="indefinite"/>
+                      </p:stCondLst>
+                      <p:childTnLst>
+                        <p:par>
+                          <p:cTn id="12" fill="hold">
+                            <p:stCondLst>
+                              <p:cond delay="0"/>
+                            </p:stCondLst>
+                            <p:childTnLst>
+                              <p:par>
+                                <p:cTn id="13" presetID="1" presetClass="entr" presetSubtype="0" fill="hold" grpId="0" nodeType="clickEffect">
+                                  <p:stCondLst>
+                                    <p:cond delay="0"/>
+                                  </p:stCondLst>
+                                  <p:childTnLst>
+                                    <p:set>
+                                      <p:cBhvr>
+                                        <p:cTn id="14" dur="1" fill="hold">
+                                          <p:stCondLst>
+                                            <p:cond delay="0"/>
+                                          </p:stCondLst>
+                                        </p:cTn>
+                                        <p:tgtEl>
+                                          <p:spTgt spid="3">
+                                            <p:txEl>
+                                              <p:pRg st="2" end="2"/>
+                                            </p:txEl>
+                                          </p:spTgt>
+                                        </p:tgtEl>
+                                        <p:attrNameLst>
+                                          <p:attrName>style.visibility</p:attrName>
+                                        </p:attrNameLst>
+                                      </p:cBhvr>
+                                      <p:to>
+                                        <p:strVal val="visible"/>
+                                      </p:to>
+                                    </p:set>
+                                  </p:childTnLst>
+                                </p:cTn>
+                              </p:par>
+                            </p:childTnLst>
+                          </p:cTn>
+                        </p:par>
+                      </p:childTnLst>
+                    </p:cTn>
+                  </p:par>
+                  <p:par>
+                    <p:cTn id="15" fill="hold">
+                      <p:stCondLst>
+                        <p:cond delay="indefinite"/>
+                      </p:stCondLst>
+                      <p:childTnLst>
+                        <p:par>
+                          <p:cTn id="16" fill="hold">
+                            <p:stCondLst>
+                              <p:cond delay="0"/>
+                            </p:stCondLst>
+                            <p:childTnLst>
+                              <p:par>
+                                <p:cTn id="17" presetID="1" presetClass="entr" presetSubtype="0" fill="hold" grpId="0" nodeType="clickEffect">
+                                  <p:stCondLst>
+                                    <p:cond delay="0"/>
+                                  </p:stCondLst>
+                                  <p:childTnLst>
+                                    <p:set>
+                                      <p:cBhvr>
+                                        <p:cTn id="18" dur="1" fill="hold">
+                                          <p:stCondLst>
+                                            <p:cond delay="0"/>
+                                          </p:stCondLst>
+                                        </p:cTn>
+                                        <p:tgtEl>
+                                          <p:spTgt spid="3">
+                                            <p:txEl>
+                                              <p:pRg st="3" end="3"/>
+                                            </p:txEl>
+                                          </p:spTgt>
+                                        </p:tgtEl>
+                                        <p:attrNameLst>
+                                          <p:attrName>style.visibility</p:attrName>
+                                        </p:attrNameLst>
+                                      </p:cBhvr>
+                                      <p:to>
+                                        <p:strVal val="visible"/>
+                                      </p:to>
+                                    </p:set>
+                                  </p:childTnLst>
+                                </p:cTn>
+                              </p:par>
+                            </p:childTnLst>
+                          </p:cTn>
+                        </p:par>
+                      </p:childTnLst>
+                    </p:cTn>
+                  </p:par>
+                  <p:par>
+                    <p:cTn id="19" fill="hold">
+                      <p:stCondLst>
+                        <p:cond delay="indefinite"/>
+                      </p:stCondLst>
+                      <p:childTnLst>
+                        <p:par>
+                          <p:cTn id="20" fill="hold">
+                            <p:stCondLst>
+                              <p:cond delay="0"/>
+                            </p:stCondLst>
+                            <p:childTnLst>
+                              <p:par>
+                                <p:cTn id="21" presetID="1" presetClass="entr" presetSubtype="0" fill="hold" nodeType="clickEffect">
+                                  <p:stCondLst>
+                                    <p:cond delay="0"/>
+                                  </p:stCondLst>
+                                  <p:childTnLst>
+                                    <p:set>
+                                      <p:cBhvr>
+                                        <p:cTn id="22" dur="1" fill="hold">
+                                          <p:stCondLst>
+                                            <p:cond delay="0"/>
+                                          </p:stCondLst>
+                                        </p:cTn>
+                                        <p:tgtEl>
+                                          <p:spTgt spid="8194"/>
+                                        </p:tgtEl>
+                                        <p:attrNameLst>
+                                          <p:attrName>style.visibility</p:attrName>
+                                        </p:attrNameLst>
+                                      </p:cBhvr>
+                                      <p:to>
+                                        <p:strVal val="visible"/>
+                                      </p:to>
+                                    </p:set>
+                                  </p:childTnLst>
+                                </p:cTn>
+                              </p:par>
+                            </p:childTnLst>
+                          </p:cTn>
+                        </p:par>
+                      </p:childTnLst>
+                    </p:cTn>
+                  </p:par>
+                </p:childTnLst>
+              </p:cTn>
+              <p:prevCondLst>
+                <p:cond evt="onPrev" delay="0">
+                  <p:tgtEl>
+                    <p:sldTgt/>
+                  </p:tgtEl>
+                </p:cond>
+              </p:prevCondLst>
+              <p:nextCondLst>
+                <p:cond evt="onNext" delay="0">
+                  <p:tgtEl>
+                    <p:sldTgt/>
+                  </p:tgtEl>
+                </p:cond>
+              </p:nextCondLst>
+            </p:seq>
+          </p:childTnLst>
+        </p:cTn>
+      </p:par>
+    </p:tnLst>
+    <p:bldLst>
+      <p:bldP spid="3" grpId="0" build="p"/>
+    </p:bldLst>
+  </p:timing>
+</p:sld>
+</file>
+
+<file path=ppt/slides/slide12.xml><?xml version="1.0" encoding="utf-8"?>
+<p:sld xmlns:a="http://schemas.openxmlformats.org/drawingml/2006/main" xmlns:r="http://schemas.openxmlformats.org/officeDocument/2006/relationships" xmlns:p="http://schemas.openxmlformats.org/presentationml/2006/main">
+  <p:cSld>
+    <p:spTree>
+      <p:nvGrpSpPr>
+        <p:cNvPr id="1" name=""/>
+        <p:cNvGrpSpPr/>
+        <p:nvPr/>
+      </p:nvGrpSpPr>
+      <p:grpSpPr>
+        <a:xfrm>
+          <a:off x="0" y="0"/>
+          <a:ext cx="0" cy="0"/>
+          <a:chOff x="0" y="0"/>
+          <a:chExt cx="0" cy="0"/>
+        </a:xfrm>
+      </p:grpSpPr>
+      <p:sp>
+        <p:nvSpPr>
+          <p:cNvPr id="2" name="Titel 1">
+            <a:extLst>
+              <a:ext uri="{FF2B5EF4-FFF2-40B4-BE49-F238E27FC236}">
                 <a16:creationId xmlns:a16="http://schemas.microsoft.com/office/drawing/2014/main" id="{F53334C0-4F3E-1EB9-F5CF-AA34D19C82E5}"/>
               </a:ext>
             </a:extLst>
@@ -7875,7 +8340,7 @@
 </p:sld>
 </file>
 
-<file path=ppt/slides/slide11.xml><?xml version="1.0" encoding="utf-8"?>
+<file path=ppt/slides/slide13.xml><?xml version="1.0" encoding="utf-8"?>
 <p:sld xmlns:a="http://schemas.openxmlformats.org/drawingml/2006/main" xmlns:r="http://schemas.openxmlformats.org/officeDocument/2006/relationships" xmlns:p="http://schemas.openxmlformats.org/presentationml/2006/main">
   <p:cSld>
     <p:spTree>
@@ -7954,7 +8419,7 @@
 </p:sld>
 </file>
 
-<file path=ppt/slides/slide12.xml><?xml version="1.0" encoding="utf-8"?>
+<file path=ppt/slides/slide14.xml><?xml version="1.0" encoding="utf-8"?>
 <p:sld xmlns:a="http://schemas.openxmlformats.org/drawingml/2006/main" xmlns:r="http://schemas.openxmlformats.org/officeDocument/2006/relationships" xmlns:p="http://schemas.openxmlformats.org/presentationml/2006/main">
   <p:cSld>
     <p:spTree>
@@ -8033,7 +8498,7 @@
 </p:sld>
 </file>
 
-<file path=ppt/slides/slide13.xml><?xml version="1.0" encoding="utf-8"?>
+<file path=ppt/slides/slide15.xml><?xml version="1.0" encoding="utf-8"?>
 <p:sld xmlns:a="http://schemas.openxmlformats.org/drawingml/2006/main" xmlns:r="http://schemas.openxmlformats.org/officeDocument/2006/relationships" xmlns:p="http://schemas.openxmlformats.org/presentationml/2006/main">
   <p:cSld>
     <p:spTree>
@@ -8200,7 +8665,7 @@
 </p:sld>
 </file>
 
-<file path=ppt/slides/slide14.xml><?xml version="1.0" encoding="utf-8"?>
+<file path=ppt/slides/slide16.xml><?xml version="1.0" encoding="utf-8"?>
 <p:sld xmlns:a="http://schemas.openxmlformats.org/drawingml/2006/main" xmlns:r="http://schemas.openxmlformats.org/officeDocument/2006/relationships" xmlns:p="http://schemas.openxmlformats.org/presentationml/2006/main">
   <p:cSld>
     <p:spTree>
@@ -8296,7 +8761,7 @@
 </p:sld>
 </file>
 
-<file path=ppt/slides/slide15.xml><?xml version="1.0" encoding="utf-8"?>
+<file path=ppt/slides/slide17.xml><?xml version="1.0" encoding="utf-8"?>
 <p:sld xmlns:a="http://schemas.openxmlformats.org/drawingml/2006/main" xmlns:r="http://schemas.openxmlformats.org/officeDocument/2006/relationships" xmlns:p="http://schemas.openxmlformats.org/presentationml/2006/main">
   <p:cSld>
     <p:spTree>
@@ -8373,7 +8838,7 @@
 </p:sld>
 </file>
 
-<file path=ppt/slides/slide16.xml><?xml version="1.0" encoding="utf-8"?>
+<file path=ppt/slides/slide18.xml><?xml version="1.0" encoding="utf-8"?>
 <p:sld xmlns:a="http://schemas.openxmlformats.org/drawingml/2006/main" xmlns:r="http://schemas.openxmlformats.org/officeDocument/2006/relationships" xmlns:p="http://schemas.openxmlformats.org/presentationml/2006/main">
   <p:cSld>
     <p:spTree>
@@ -8450,7 +8915,7 @@
 </p:sld>
 </file>
 
-<file path=ppt/slides/slide17.xml><?xml version="1.0" encoding="utf-8"?>
+<file path=ppt/slides/slide19.xml><?xml version="1.0" encoding="utf-8"?>
 <p:sld xmlns:a="http://schemas.openxmlformats.org/drawingml/2006/main" xmlns:r="http://schemas.openxmlformats.org/officeDocument/2006/relationships" xmlns:p="http://schemas.openxmlformats.org/presentationml/2006/main">
   <p:cSld>
     <p:spTree>
@@ -8570,7 +9035,84 @@
 </p:sld>
 </file>
 
-<file path=ppt/slides/slide18.xml><?xml version="1.0" encoding="utf-8"?>
+<file path=ppt/slides/slide2.xml><?xml version="1.0" encoding="utf-8"?>
+<p:sld xmlns:a="http://schemas.openxmlformats.org/drawingml/2006/main" xmlns:r="http://schemas.openxmlformats.org/officeDocument/2006/relationships" xmlns:p="http://schemas.openxmlformats.org/presentationml/2006/main">
+  <p:cSld>
+    <p:spTree>
+      <p:nvGrpSpPr>
+        <p:cNvPr id="1" name=""/>
+        <p:cNvGrpSpPr/>
+        <p:nvPr/>
+      </p:nvGrpSpPr>
+      <p:grpSpPr>
+        <a:xfrm>
+          <a:off x="0" y="0"/>
+          <a:ext cx="0" cy="0"/>
+          <a:chOff x="0" y="0"/>
+          <a:chExt cx="0" cy="0"/>
+        </a:xfrm>
+      </p:grpSpPr>
+      <p:pic>
+        <p:nvPicPr>
+          <p:cNvPr id="13314" name="Picture 2" descr="Food Memes 🍠🍗🍖🍕🍔🍟🌭🍿🥨🥐🥖🧀 - Geeks + Gamers">
+            <a:extLst>
+              <a:ext uri="{FF2B5EF4-FFF2-40B4-BE49-F238E27FC236}">
+                <a16:creationId xmlns:a16="http://schemas.microsoft.com/office/drawing/2014/main" id="{EF8660DD-1A61-F7E4-F6D5-360BD0224E3F}"/>
+              </a:ext>
+            </a:extLst>
+          </p:cNvPr>
+          <p:cNvPicPr>
+            <a:picLocks noChangeAspect="1" noChangeArrowheads="1"/>
+          </p:cNvPicPr>
+          <p:nvPr/>
+        </p:nvPicPr>
+        <p:blipFill>
+          <a:blip r:embed="rId2">
+            <a:extLst>
+              <a:ext uri="{28A0092B-C50C-407E-A947-70E740481C1C}">
+                <a14:useLocalDpi xmlns:a14="http://schemas.microsoft.com/office/drawing/2010/main" val="0"/>
+              </a:ext>
+            </a:extLst>
+          </a:blip>
+          <a:srcRect/>
+          <a:stretch>
+            <a:fillRect/>
+          </a:stretch>
+        </p:blipFill>
+        <p:spPr bwMode="auto">
+          <a:xfrm>
+            <a:off x="2667000" y="0"/>
+            <a:ext cx="6858000" cy="6858000"/>
+          </a:xfrm>
+          <a:prstGeom prst="rect">
+            <a:avLst/>
+          </a:prstGeom>
+          <a:noFill/>
+          <a:extLst>
+            <a:ext uri="{909E8E84-426E-40DD-AFC4-6F175D3DCCD1}">
+              <a14:hiddenFill xmlns:a14="http://schemas.microsoft.com/office/drawing/2010/main">
+                <a:solidFill>
+                  <a:srgbClr val="FFFFFF"/>
+                </a:solidFill>
+              </a14:hiddenFill>
+            </a:ext>
+          </a:extLst>
+        </p:spPr>
+      </p:pic>
+    </p:spTree>
+    <p:extLst>
+      <p:ext uri="{BB962C8B-B14F-4D97-AF65-F5344CB8AC3E}">
+        <p14:creationId xmlns:p14="http://schemas.microsoft.com/office/powerpoint/2010/main" val="437348138"/>
+      </p:ext>
+    </p:extLst>
+  </p:cSld>
+  <p:clrMapOvr>
+    <a:masterClrMapping/>
+  </p:clrMapOvr>
+</p:sld>
+</file>
+
+<file path=ppt/slides/slide20.xml><?xml version="1.0" encoding="utf-8"?>
 <p:sld xmlns:a="http://schemas.openxmlformats.org/drawingml/2006/main" xmlns:r="http://schemas.openxmlformats.org/officeDocument/2006/relationships" xmlns:p="http://schemas.openxmlformats.org/presentationml/2006/main">
   <p:cSld>
     <p:spTree>
@@ -8666,7 +9208,7 @@
 </p:sld>
 </file>
 
-<file path=ppt/slides/slide19.xml><?xml version="1.0" encoding="utf-8"?>
+<file path=ppt/slides/slide21.xml><?xml version="1.0" encoding="utf-8"?>
 <p:sld xmlns:a="http://schemas.openxmlformats.org/drawingml/2006/main" xmlns:r="http://schemas.openxmlformats.org/officeDocument/2006/relationships" xmlns:p="http://schemas.openxmlformats.org/presentationml/2006/main">
   <p:cSld>
     <p:spTree>
@@ -9417,680 +9959,6 @@
 </p:sld>
 </file>
 
-<file path=ppt/slides/slide2.xml><?xml version="1.0" encoding="utf-8"?>
-<p:sld xmlns:a="http://schemas.openxmlformats.org/drawingml/2006/main" xmlns:r="http://schemas.openxmlformats.org/officeDocument/2006/relationships" xmlns:p="http://schemas.openxmlformats.org/presentationml/2006/main">
-  <p:cSld>
-    <p:bg>
-      <p:bgPr>
-        <a:solidFill>
-          <a:schemeClr val="bg1"/>
-        </a:solidFill>
-        <a:effectLst/>
-      </p:bgPr>
-    </p:bg>
-    <p:spTree>
-      <p:nvGrpSpPr>
-        <p:cNvPr id="1" name=""/>
-        <p:cNvGrpSpPr/>
-        <p:nvPr/>
-      </p:nvGrpSpPr>
-      <p:grpSpPr>
-        <a:xfrm>
-          <a:off x="0" y="0"/>
-          <a:ext cx="0" cy="0"/>
-          <a:chOff x="0" y="0"/>
-          <a:chExt cx="0" cy="0"/>
-        </a:xfrm>
-      </p:grpSpPr>
-      <p:sp useBgFill="1">
-        <p:nvSpPr>
-          <p:cNvPr id="9" name="Rectangle 8">
-            <a:extLst>
-              <a:ext uri="{FF2B5EF4-FFF2-40B4-BE49-F238E27FC236}">
-                <a16:creationId xmlns:a16="http://schemas.microsoft.com/office/drawing/2014/main" id="{9DBC8166-481C-4473-95F5-9A5B9073B7F1}"/>
-              </a:ext>
-              <a:ext uri="{C183D7F6-B498-43B3-948B-1728B52AA6E4}">
-                <adec:decorative xmlns:adec="http://schemas.microsoft.com/office/drawing/2017/decorative" val="1"/>
-              </a:ext>
-            </a:extLst>
-          </p:cNvPr>
-          <p:cNvSpPr>
-            <a:spLocks noGrp="1" noRot="1" noChangeAspect="1" noMove="1" noResize="1" noEditPoints="1" noAdjustHandles="1" noChangeArrowheads="1" noChangeShapeType="1" noTextEdit="1"/>
-          </p:cNvSpPr>
-          <p:nvPr>
-            <p:extLst>
-              <p:ext uri="{386F3935-93C4-4BCD-93E2-E3B085C9AB24}">
-                <p16:designElem xmlns:p16="http://schemas.microsoft.com/office/powerpoint/2015/main" val="1"/>
-              </p:ext>
-            </p:extLst>
-          </p:nvPr>
-        </p:nvSpPr>
-        <p:spPr>
-          <a:xfrm>
-            <a:off x="0" y="0"/>
-            <a:ext cx="12188952" cy="6858000"/>
-          </a:xfrm>
-          <a:prstGeom prst="rect">
-            <a:avLst/>
-          </a:prstGeom>
-          <a:ln>
-            <a:noFill/>
-          </a:ln>
-        </p:spPr>
-        <p:style>
-          <a:lnRef idx="2">
-            <a:schemeClr val="accent1">
-              <a:shade val="50000"/>
-            </a:schemeClr>
-          </a:lnRef>
-          <a:fillRef idx="1">
-            <a:schemeClr val="accent1"/>
-          </a:fillRef>
-          <a:effectRef idx="0">
-            <a:schemeClr val="accent1"/>
-          </a:effectRef>
-          <a:fontRef idx="minor">
-            <a:schemeClr val="lt1"/>
-          </a:fontRef>
-        </p:style>
-        <p:txBody>
-          <a:bodyPr rtlCol="0" anchor="ctr"/>
-          <a:lstStyle/>
-          <a:p>
-            <a:pPr algn="ctr"/>
-            <a:endParaRPr lang="en-US"/>
-          </a:p>
-        </p:txBody>
-      </p:sp>
-      <p:sp>
-        <p:nvSpPr>
-          <p:cNvPr id="11" name="Freeform: Shape 10">
-            <a:extLst>
-              <a:ext uri="{FF2B5EF4-FFF2-40B4-BE49-F238E27FC236}">
-                <a16:creationId xmlns:a16="http://schemas.microsoft.com/office/drawing/2014/main" id="{A5A5CE6E-90AF-4D43-A014-1F9EC83EB93D}"/>
-              </a:ext>
-              <a:ext uri="{C183D7F6-B498-43B3-948B-1728B52AA6E4}">
-                <adec:decorative xmlns:adec="http://schemas.microsoft.com/office/drawing/2017/decorative" val="1"/>
-              </a:ext>
-            </a:extLst>
-          </p:cNvPr>
-          <p:cNvSpPr>
-            <a:spLocks noGrp="1" noRot="1" noChangeAspect="1" noMove="1" noResize="1" noEditPoints="1" noAdjustHandles="1" noChangeArrowheads="1" noChangeShapeType="1" noTextEdit="1"/>
-          </p:cNvSpPr>
-          <p:nvPr>
-            <p:extLst>
-              <p:ext uri="{386F3935-93C4-4BCD-93E2-E3B085C9AB24}">
-                <p16:designElem xmlns:p16="http://schemas.microsoft.com/office/powerpoint/2015/main" val="1"/>
-              </p:ext>
-            </p:extLst>
-          </p:nvPr>
-        </p:nvSpPr>
-        <p:spPr>
-          <a:xfrm>
-            <a:off x="0" y="1"/>
-            <a:ext cx="4512467" cy="6858000"/>
-          </a:xfrm>
-          <a:custGeom>
-            <a:avLst/>
-            <a:gdLst>
-              <a:gd name="connsiteX0" fmla="*/ 0 w 4512467"/>
-              <a:gd name="connsiteY0" fmla="*/ 0 h 6858000"/>
-              <a:gd name="connsiteX1" fmla="*/ 2579526 w 4512467"/>
-              <a:gd name="connsiteY1" fmla="*/ 0 h 6858000"/>
-              <a:gd name="connsiteX2" fmla="*/ 2583267 w 4512467"/>
-              <a:gd name="connsiteY2" fmla="*/ 2151 h 6858000"/>
-              <a:gd name="connsiteX3" fmla="*/ 4512467 w 4512467"/>
-              <a:gd name="connsiteY3" fmla="*/ 3429000 h 6858000"/>
-              <a:gd name="connsiteX4" fmla="*/ 2583267 w 4512467"/>
-              <a:gd name="connsiteY4" fmla="*/ 6855849 h 6858000"/>
-              <a:gd name="connsiteX5" fmla="*/ 2579526 w 4512467"/>
-              <a:gd name="connsiteY5" fmla="*/ 6858000 h 6858000"/>
-              <a:gd name="connsiteX6" fmla="*/ 0 w 4512467"/>
-              <a:gd name="connsiteY6" fmla="*/ 6858000 h 6858000"/>
-            </a:gdLst>
-            <a:ahLst/>
-            <a:cxnLst>
-              <a:cxn ang="0">
-                <a:pos x="connsiteX0" y="connsiteY0"/>
-              </a:cxn>
-              <a:cxn ang="0">
-                <a:pos x="connsiteX1" y="connsiteY1"/>
-              </a:cxn>
-              <a:cxn ang="0">
-                <a:pos x="connsiteX2" y="connsiteY2"/>
-              </a:cxn>
-              <a:cxn ang="0">
-                <a:pos x="connsiteX3" y="connsiteY3"/>
-              </a:cxn>
-              <a:cxn ang="0">
-                <a:pos x="connsiteX4" y="connsiteY4"/>
-              </a:cxn>
-              <a:cxn ang="0">
-                <a:pos x="connsiteX5" y="connsiteY5"/>
-              </a:cxn>
-              <a:cxn ang="0">
-                <a:pos x="connsiteX6" y="connsiteY6"/>
-              </a:cxn>
-            </a:cxnLst>
-            <a:rect l="l" t="t" r="r" b="b"/>
-            <a:pathLst>
-              <a:path w="4512467" h="6858000">
-                <a:moveTo>
-                  <a:pt x="0" y="0"/>
-                </a:moveTo>
-                <a:lnTo>
-                  <a:pt x="2579526" y="0"/>
-                </a:lnTo>
-                <a:lnTo>
-                  <a:pt x="2583267" y="2151"/>
-                </a:lnTo>
-                <a:cubicBezTo>
-                  <a:pt x="3739868" y="704919"/>
-                  <a:pt x="4512467" y="1976735"/>
-                  <a:pt x="4512467" y="3429000"/>
-                </a:cubicBezTo>
-                <a:cubicBezTo>
-                  <a:pt x="4512467" y="4881266"/>
-                  <a:pt x="3739868" y="6153081"/>
-                  <a:pt x="2583267" y="6855849"/>
-                </a:cubicBezTo>
-                <a:lnTo>
-                  <a:pt x="2579526" y="6858000"/>
-                </a:lnTo>
-                <a:lnTo>
-                  <a:pt x="0" y="6858000"/>
-                </a:lnTo>
-                <a:close/>
-              </a:path>
-            </a:pathLst>
-          </a:custGeom>
-          <a:solidFill>
-            <a:schemeClr val="accent2"/>
-          </a:solidFill>
-          <a:ln>
-            <a:noFill/>
-          </a:ln>
-        </p:spPr>
-        <p:style>
-          <a:lnRef idx="2">
-            <a:schemeClr val="accent1">
-              <a:shade val="50000"/>
-            </a:schemeClr>
-          </a:lnRef>
-          <a:fillRef idx="1">
-            <a:schemeClr val="accent1"/>
-          </a:fillRef>
-          <a:effectRef idx="0">
-            <a:schemeClr val="accent1"/>
-          </a:effectRef>
-          <a:fontRef idx="minor">
-            <a:schemeClr val="lt1"/>
-          </a:fontRef>
-        </p:style>
-        <p:txBody>
-          <a:bodyPr wrap="square" rtlCol="0" anchor="ctr">
-            <a:noAutofit/>
-          </a:bodyPr>
-          <a:lstStyle/>
-          <a:p>
-            <a:pPr algn="ctr"/>
-            <a:endParaRPr lang="en-US">
-              <a:solidFill>
-                <a:schemeClr val="bg1"/>
-              </a:solidFill>
-            </a:endParaRPr>
-          </a:p>
-        </p:txBody>
-      </p:sp>
-      <p:sp>
-        <p:nvSpPr>
-          <p:cNvPr id="2" name="Titel 1">
-            <a:extLst>
-              <a:ext uri="{FF2B5EF4-FFF2-40B4-BE49-F238E27FC236}">
-                <a16:creationId xmlns:a16="http://schemas.microsoft.com/office/drawing/2014/main" id="{A1495B9F-CEAA-C88E-7F78-7758B929DFCB}"/>
-              </a:ext>
-            </a:extLst>
-          </p:cNvPr>
-          <p:cNvSpPr>
-            <a:spLocks noGrp="1"/>
-          </p:cNvSpPr>
-          <p:nvPr>
-            <p:ph type="title"/>
-          </p:nvPr>
-        </p:nvSpPr>
-        <p:spPr>
-          <a:xfrm>
-            <a:off x="838200" y="643467"/>
-            <a:ext cx="2951205" cy="5571066"/>
-          </a:xfrm>
-        </p:spPr>
-        <p:txBody>
-          <a:bodyPr>
-            <a:normAutofit/>
-          </a:bodyPr>
-          <a:lstStyle/>
-          <a:p>
-            <a:r>
-              <a:rPr lang="en-US">
-                <a:solidFill>
-                  <a:srgbClr val="FFFFFF"/>
-                </a:solidFill>
-              </a:rPr>
-              <a:t>Agenda</a:t>
-            </a:r>
-            <a:endParaRPr lang="da-DK">
-              <a:solidFill>
-                <a:srgbClr val="FFFFFF"/>
-              </a:solidFill>
-            </a:endParaRPr>
-          </a:p>
-        </p:txBody>
-      </p:sp>
-      <p:graphicFrame>
-        <p:nvGraphicFramePr>
-          <p:cNvPr id="5" name="Pladsholder til indhold 2">
-            <a:extLst>
-              <a:ext uri="{FF2B5EF4-FFF2-40B4-BE49-F238E27FC236}">
-                <a16:creationId xmlns:a16="http://schemas.microsoft.com/office/drawing/2014/main" id="{C7C0F459-B1A2-7BE3-CF43-91DC17D7B3CD}"/>
-              </a:ext>
-            </a:extLst>
-          </p:cNvPr>
-          <p:cNvGraphicFramePr>
-            <a:graphicFrameLocks noGrp="1"/>
-          </p:cNvGraphicFramePr>
-          <p:nvPr>
-            <p:ph idx="1"/>
-            <p:extLst>
-              <p:ext uri="{D42A27DB-BD31-4B8C-83A1-F6EECF244321}">
-                <p14:modId xmlns:p14="http://schemas.microsoft.com/office/powerpoint/2010/main" val="4085455600"/>
-              </p:ext>
-            </p:extLst>
-          </p:nvPr>
-        </p:nvGraphicFramePr>
-        <p:xfrm>
-          <a:off x="5207640" y="643466"/>
-          <a:ext cx="6291714" cy="5530735"/>
-        </p:xfrm>
-        <a:graphic>
-          <a:graphicData uri="http://schemas.openxmlformats.org/drawingml/2006/diagram">
-            <dgm:relIds xmlns:dgm="http://schemas.openxmlformats.org/drawingml/2006/diagram" xmlns:r="http://schemas.openxmlformats.org/officeDocument/2006/relationships" r:dm="rId2" r:lo="rId3" r:qs="rId4" r:cs="rId5"/>
-          </a:graphicData>
-        </a:graphic>
-      </p:graphicFrame>
-    </p:spTree>
-    <p:extLst>
-      <p:ext uri="{BB962C8B-B14F-4D97-AF65-F5344CB8AC3E}">
-        <p14:creationId xmlns:p14="http://schemas.microsoft.com/office/powerpoint/2010/main" val="2257908964"/>
-      </p:ext>
-    </p:extLst>
-  </p:cSld>
-  <p:clrMapOvr>
-    <a:masterClrMapping/>
-  </p:clrMapOvr>
-</p:sld>
-</file>
-
-<file path=ppt/slides/slide20.xml><?xml version="1.0" encoding="utf-8"?>
-<p:sld xmlns:a="http://schemas.openxmlformats.org/drawingml/2006/main" xmlns:r="http://schemas.openxmlformats.org/officeDocument/2006/relationships" xmlns:p="http://schemas.openxmlformats.org/presentationml/2006/main">
-  <p:cSld>
-    <p:spTree>
-      <p:nvGrpSpPr>
-        <p:cNvPr id="1" name=""/>
-        <p:cNvGrpSpPr/>
-        <p:nvPr/>
-      </p:nvGrpSpPr>
-      <p:grpSpPr>
-        <a:xfrm>
-          <a:off x="0" y="0"/>
-          <a:ext cx="0" cy="0"/>
-          <a:chOff x="0" y="0"/>
-          <a:chExt cx="0" cy="0"/>
-        </a:xfrm>
-      </p:grpSpPr>
-      <p:sp>
-        <p:nvSpPr>
-          <p:cNvPr id="2" name="Titel 1">
-            <a:extLst>
-              <a:ext uri="{FF2B5EF4-FFF2-40B4-BE49-F238E27FC236}">
-                <a16:creationId xmlns:a16="http://schemas.microsoft.com/office/drawing/2014/main" id="{2A193CD5-F62F-549E-8996-37160D8B4635}"/>
-              </a:ext>
-            </a:extLst>
-          </p:cNvPr>
-          <p:cNvSpPr>
-            <a:spLocks noGrp="1"/>
-          </p:cNvSpPr>
-          <p:nvPr>
-            <p:ph type="title"/>
-          </p:nvPr>
-        </p:nvSpPr>
-        <p:spPr/>
-        <p:txBody>
-          <a:bodyPr/>
-          <a:lstStyle/>
-          <a:p>
-            <a:r>
-              <a:rPr lang="en-US" dirty="0" err="1"/>
-              <a:t>Metode</a:t>
-            </a:r>
-            <a:r>
-              <a:rPr lang="en-US" dirty="0"/>
-              <a:t> 2: QQ-plots</a:t>
-            </a:r>
-            <a:endParaRPr lang="da-DK" dirty="0"/>
-          </a:p>
-        </p:txBody>
-      </p:sp>
-      <p:sp>
-        <p:nvSpPr>
-          <p:cNvPr id="3" name="Pladsholder til indhold 2">
-            <a:extLst>
-              <a:ext uri="{FF2B5EF4-FFF2-40B4-BE49-F238E27FC236}">
-                <a16:creationId xmlns:a16="http://schemas.microsoft.com/office/drawing/2014/main" id="{26F25676-1764-1CB1-3F63-5250010F52D5}"/>
-              </a:ext>
-            </a:extLst>
-          </p:cNvPr>
-          <p:cNvSpPr>
-            <a:spLocks noGrp="1"/>
-          </p:cNvSpPr>
-          <p:nvPr>
-            <p:ph idx="1"/>
-          </p:nvPr>
-        </p:nvSpPr>
-        <p:spPr/>
-        <p:txBody>
-          <a:bodyPr/>
-          <a:lstStyle/>
-          <a:p>
-            <a:r>
-              <a:rPr lang="en-US" dirty="0" err="1"/>
-              <a:t>Lav</a:t>
-            </a:r>
-            <a:r>
-              <a:rPr lang="en-US" dirty="0"/>
-              <a:t> et QQ-plot </a:t>
-            </a:r>
-          </a:p>
-          <a:p>
-            <a:r>
-              <a:rPr lang="en-US" dirty="0" err="1"/>
-              <a:t>Hvis</a:t>
-            </a:r>
-            <a:r>
-              <a:rPr lang="en-US" dirty="0"/>
-              <a:t> de </a:t>
-            </a:r>
-            <a:r>
-              <a:rPr lang="en-US" dirty="0" err="1"/>
-              <a:t>falder</a:t>
-            </a:r>
-            <a:r>
-              <a:rPr lang="en-US" dirty="0"/>
-              <a:t> </a:t>
-            </a:r>
-            <a:r>
-              <a:rPr lang="en-US" dirty="0" err="1"/>
-              <a:t>på</a:t>
-            </a:r>
-            <a:r>
-              <a:rPr lang="en-US" dirty="0"/>
-              <a:t> </a:t>
-            </a:r>
-            <a:r>
-              <a:rPr lang="en-US" dirty="0" err="1"/>
-              <a:t>en</a:t>
-            </a:r>
-            <a:r>
-              <a:rPr lang="en-US" dirty="0"/>
-              <a:t> </a:t>
-            </a:r>
-            <a:r>
-              <a:rPr lang="en-US" dirty="0" err="1"/>
-              <a:t>lige</a:t>
-            </a:r>
-            <a:r>
-              <a:rPr lang="en-US" dirty="0"/>
-              <a:t> </a:t>
-            </a:r>
-            <a:r>
-              <a:rPr lang="en-US" dirty="0" err="1"/>
-              <a:t>linje</a:t>
-            </a:r>
-            <a:r>
-              <a:rPr lang="en-US" dirty="0"/>
-              <a:t> er det </a:t>
-            </a:r>
-            <a:r>
-              <a:rPr lang="en-US" dirty="0" err="1"/>
-              <a:t>normalfordelt</a:t>
-            </a:r>
-            <a:endParaRPr lang="da-DK" dirty="0"/>
-          </a:p>
-        </p:txBody>
-      </p:sp>
-    </p:spTree>
-    <p:extLst>
-      <p:ext uri="{BB962C8B-B14F-4D97-AF65-F5344CB8AC3E}">
-        <p14:creationId xmlns:p14="http://schemas.microsoft.com/office/powerpoint/2010/main" val="1702594633"/>
-      </p:ext>
-    </p:extLst>
-  </p:cSld>
-  <p:clrMapOvr>
-    <a:masterClrMapping/>
-  </p:clrMapOvr>
-</p:sld>
-</file>
-
-<file path=ppt/slides/slide21.xml><?xml version="1.0" encoding="utf-8"?>
-<p:sld xmlns:a="http://schemas.openxmlformats.org/drawingml/2006/main" xmlns:r="http://schemas.openxmlformats.org/officeDocument/2006/relationships" xmlns:p="http://schemas.openxmlformats.org/presentationml/2006/main">
-  <p:cSld>
-    <p:spTree>
-      <p:nvGrpSpPr>
-        <p:cNvPr id="1" name=""/>
-        <p:cNvGrpSpPr/>
-        <p:nvPr/>
-      </p:nvGrpSpPr>
-      <p:grpSpPr>
-        <a:xfrm>
-          <a:off x="0" y="0"/>
-          <a:ext cx="0" cy="0"/>
-          <a:chOff x="0" y="0"/>
-          <a:chExt cx="0" cy="0"/>
-        </a:xfrm>
-      </p:grpSpPr>
-      <p:sp>
-        <p:nvSpPr>
-          <p:cNvPr id="2" name="Titel 1">
-            <a:extLst>
-              <a:ext uri="{FF2B5EF4-FFF2-40B4-BE49-F238E27FC236}">
-                <a16:creationId xmlns:a16="http://schemas.microsoft.com/office/drawing/2014/main" id="{4D147CD3-C20F-B650-4051-8B93D4102B4D}"/>
-              </a:ext>
-            </a:extLst>
-          </p:cNvPr>
-          <p:cNvSpPr>
-            <a:spLocks noGrp="1"/>
-          </p:cNvSpPr>
-          <p:nvPr>
-            <p:ph type="title"/>
-          </p:nvPr>
-        </p:nvSpPr>
-        <p:spPr/>
-        <p:txBody>
-          <a:bodyPr/>
-          <a:lstStyle/>
-          <a:p>
-            <a:r>
-              <a:rPr lang="en-US" dirty="0" err="1"/>
-              <a:t>Metode</a:t>
-            </a:r>
-            <a:r>
-              <a:rPr lang="en-US" dirty="0"/>
-              <a:t> 3: Frequentists tests</a:t>
-            </a:r>
-            <a:endParaRPr lang="da-DK" dirty="0"/>
-          </a:p>
-        </p:txBody>
-      </p:sp>
-      <p:sp>
-        <p:nvSpPr>
-          <p:cNvPr id="3" name="Pladsholder til indhold 2">
-            <a:extLst>
-              <a:ext uri="{FF2B5EF4-FFF2-40B4-BE49-F238E27FC236}">
-                <a16:creationId xmlns:a16="http://schemas.microsoft.com/office/drawing/2014/main" id="{7292B951-6BD8-A8E4-CEE5-868317FCB2A4}"/>
-              </a:ext>
-            </a:extLst>
-          </p:cNvPr>
-          <p:cNvSpPr>
-            <a:spLocks noGrp="1"/>
-          </p:cNvSpPr>
-          <p:nvPr>
-            <p:ph idx="1"/>
-          </p:nvPr>
-        </p:nvSpPr>
-        <p:spPr/>
-        <p:txBody>
-          <a:bodyPr/>
-          <a:lstStyle/>
-          <a:p>
-            <a:r>
-              <a:rPr lang="en-US" dirty="0" err="1"/>
-              <a:t>Statistisk</a:t>
-            </a:r>
-            <a:r>
-              <a:rPr lang="en-US" dirty="0"/>
-              <a:t> test for </a:t>
-            </a:r>
-            <a:r>
-              <a:rPr lang="en-US" dirty="0" err="1"/>
-              <a:t>normalfordeling</a:t>
-            </a:r>
-            <a:r>
-              <a:rPr lang="en-US" dirty="0"/>
-              <a:t> </a:t>
-            </a:r>
-          </a:p>
-          <a:p>
-            <a:r>
-              <a:rPr lang="en-US" dirty="0" err="1"/>
-              <a:t>Findes</a:t>
-            </a:r>
-            <a:r>
-              <a:rPr lang="en-US" dirty="0"/>
-              <a:t> mange </a:t>
-            </a:r>
-            <a:r>
-              <a:rPr lang="en-US" dirty="0" err="1"/>
-              <a:t>forskellige</a:t>
-            </a:r>
-            <a:r>
-              <a:rPr lang="en-US" dirty="0"/>
-              <a:t> der </a:t>
-            </a:r>
-            <a:r>
-              <a:rPr lang="en-US" dirty="0" err="1"/>
-              <a:t>har</a:t>
-            </a:r>
-            <a:r>
-              <a:rPr lang="en-US" dirty="0"/>
-              <a:t> </a:t>
-            </a:r>
-            <a:r>
-              <a:rPr lang="en-US" dirty="0" err="1"/>
-              <a:t>fordele</a:t>
-            </a:r>
-            <a:r>
-              <a:rPr lang="en-US" dirty="0"/>
-              <a:t> </a:t>
-            </a:r>
-            <a:r>
-              <a:rPr lang="en-US" dirty="0" err="1"/>
-              <a:t>og</a:t>
-            </a:r>
-            <a:r>
-              <a:rPr lang="en-US" dirty="0"/>
-              <a:t> </a:t>
-            </a:r>
-            <a:r>
-              <a:rPr lang="en-US" dirty="0" err="1"/>
-              <a:t>ulemper</a:t>
-            </a:r>
-            <a:r>
-              <a:rPr lang="en-US" dirty="0"/>
-              <a:t>.</a:t>
-            </a:r>
-          </a:p>
-          <a:p>
-            <a:r>
-              <a:rPr lang="en-US" dirty="0" err="1"/>
-              <a:t>Mest</a:t>
-            </a:r>
-            <a:r>
-              <a:rPr lang="en-US" dirty="0"/>
-              <a:t> </a:t>
-            </a:r>
-            <a:r>
-              <a:rPr lang="en-US" dirty="0" err="1"/>
-              <a:t>almindelige</a:t>
-            </a:r>
-            <a:r>
-              <a:rPr lang="en-US" dirty="0"/>
-              <a:t> er Shapiro-Wilk</a:t>
-            </a:r>
-          </a:p>
-          <a:p>
-            <a:pPr lvl="1"/>
-            <a:r>
-              <a:rPr lang="en-US" dirty="0"/>
-              <a:t>Tester om det er </a:t>
-            </a:r>
-            <a:r>
-              <a:rPr lang="en-US" dirty="0" err="1"/>
-              <a:t>forskelligt</a:t>
-            </a:r>
-            <a:r>
-              <a:rPr lang="en-US" dirty="0"/>
-              <a:t> </a:t>
-            </a:r>
-            <a:r>
-              <a:rPr lang="en-US" dirty="0" err="1"/>
-              <a:t>fra</a:t>
-            </a:r>
-            <a:r>
-              <a:rPr lang="en-US" dirty="0"/>
-              <a:t> </a:t>
-            </a:r>
-            <a:r>
-              <a:rPr lang="en-US" dirty="0" err="1"/>
-              <a:t>en</a:t>
-            </a:r>
-            <a:r>
-              <a:rPr lang="en-US" dirty="0"/>
-              <a:t> </a:t>
-            </a:r>
-            <a:r>
-              <a:rPr lang="en-US" dirty="0" err="1"/>
-              <a:t>normalfordeling</a:t>
-            </a:r>
-            <a:r>
-              <a:rPr lang="en-US" dirty="0"/>
-              <a:t> </a:t>
-            </a:r>
-            <a:endParaRPr lang="da-DK" dirty="0"/>
-          </a:p>
-        </p:txBody>
-      </p:sp>
-    </p:spTree>
-    <p:extLst>
-      <p:ext uri="{BB962C8B-B14F-4D97-AF65-F5344CB8AC3E}">
-        <p14:creationId xmlns:p14="http://schemas.microsoft.com/office/powerpoint/2010/main" val="1208351884"/>
-      </p:ext>
-    </p:extLst>
-  </p:cSld>
-  <p:clrMapOvr>
-    <a:masterClrMapping/>
-  </p:clrMapOvr>
-</p:sld>
-</file>
-
 <file path=ppt/slides/slide22.xml><?xml version="1.0" encoding="utf-8"?>
 <p:sld xmlns:a="http://schemas.openxmlformats.org/drawingml/2006/main" xmlns:r="http://schemas.openxmlformats.org/officeDocument/2006/relationships" xmlns:p="http://schemas.openxmlformats.org/presentationml/2006/main">
   <p:cSld>
@@ -10113,6 +9981,367 @@
           <p:cNvPr id="2" name="Titel 1">
             <a:extLst>
               <a:ext uri="{FF2B5EF4-FFF2-40B4-BE49-F238E27FC236}">
+                <a16:creationId xmlns:a16="http://schemas.microsoft.com/office/drawing/2014/main" id="{2A193CD5-F62F-549E-8996-37160D8B4635}"/>
+              </a:ext>
+            </a:extLst>
+          </p:cNvPr>
+          <p:cNvSpPr>
+            <a:spLocks noGrp="1"/>
+          </p:cNvSpPr>
+          <p:nvPr>
+            <p:ph type="title"/>
+          </p:nvPr>
+        </p:nvSpPr>
+        <p:spPr/>
+        <p:txBody>
+          <a:bodyPr/>
+          <a:lstStyle/>
+          <a:p>
+            <a:r>
+              <a:rPr lang="en-US" dirty="0" err="1"/>
+              <a:t>Metode</a:t>
+            </a:r>
+            <a:r>
+              <a:rPr lang="en-US" dirty="0"/>
+              <a:t> 2: QQ-plots</a:t>
+            </a:r>
+            <a:endParaRPr lang="da-DK" dirty="0"/>
+          </a:p>
+        </p:txBody>
+      </p:sp>
+      <p:sp>
+        <p:nvSpPr>
+          <p:cNvPr id="3" name="Pladsholder til indhold 2">
+            <a:extLst>
+              <a:ext uri="{FF2B5EF4-FFF2-40B4-BE49-F238E27FC236}">
+                <a16:creationId xmlns:a16="http://schemas.microsoft.com/office/drawing/2014/main" id="{26F25676-1764-1CB1-3F63-5250010F52D5}"/>
+              </a:ext>
+            </a:extLst>
+          </p:cNvPr>
+          <p:cNvSpPr>
+            <a:spLocks noGrp="1"/>
+          </p:cNvSpPr>
+          <p:nvPr>
+            <p:ph idx="1"/>
+          </p:nvPr>
+        </p:nvSpPr>
+        <p:spPr/>
+        <p:txBody>
+          <a:bodyPr/>
+          <a:lstStyle/>
+          <a:p>
+            <a:r>
+              <a:rPr lang="en-US" dirty="0" err="1"/>
+              <a:t>Lav</a:t>
+            </a:r>
+            <a:r>
+              <a:rPr lang="en-US" dirty="0"/>
+              <a:t> et QQ-plot </a:t>
+            </a:r>
+          </a:p>
+          <a:p>
+            <a:r>
+              <a:rPr lang="en-US" dirty="0" err="1"/>
+              <a:t>Hvis</a:t>
+            </a:r>
+            <a:r>
+              <a:rPr lang="en-US" dirty="0"/>
+              <a:t> de </a:t>
+            </a:r>
+            <a:r>
+              <a:rPr lang="en-US" dirty="0" err="1"/>
+              <a:t>falder</a:t>
+            </a:r>
+            <a:r>
+              <a:rPr lang="en-US" dirty="0"/>
+              <a:t> </a:t>
+            </a:r>
+            <a:r>
+              <a:rPr lang="en-US" dirty="0" err="1"/>
+              <a:t>på</a:t>
+            </a:r>
+            <a:r>
+              <a:rPr lang="en-US" dirty="0"/>
+              <a:t> </a:t>
+            </a:r>
+            <a:r>
+              <a:rPr lang="en-US" dirty="0" err="1"/>
+              <a:t>en</a:t>
+            </a:r>
+            <a:r>
+              <a:rPr lang="en-US" dirty="0"/>
+              <a:t> </a:t>
+            </a:r>
+            <a:r>
+              <a:rPr lang="en-US" dirty="0" err="1"/>
+              <a:t>lige</a:t>
+            </a:r>
+            <a:r>
+              <a:rPr lang="en-US" dirty="0"/>
+              <a:t> </a:t>
+            </a:r>
+            <a:r>
+              <a:rPr lang="en-US" dirty="0" err="1"/>
+              <a:t>linje</a:t>
+            </a:r>
+            <a:r>
+              <a:rPr lang="en-US" dirty="0"/>
+              <a:t> er det </a:t>
+            </a:r>
+            <a:r>
+              <a:rPr lang="en-US" dirty="0" err="1"/>
+              <a:t>normalfordelt</a:t>
+            </a:r>
+            <a:endParaRPr lang="da-DK" dirty="0"/>
+          </a:p>
+        </p:txBody>
+      </p:sp>
+    </p:spTree>
+    <p:extLst>
+      <p:ext uri="{BB962C8B-B14F-4D97-AF65-F5344CB8AC3E}">
+        <p14:creationId xmlns:p14="http://schemas.microsoft.com/office/powerpoint/2010/main" val="1702594633"/>
+      </p:ext>
+    </p:extLst>
+  </p:cSld>
+  <p:clrMapOvr>
+    <a:masterClrMapping/>
+  </p:clrMapOvr>
+</p:sld>
+</file>
+
+<file path=ppt/slides/slide23.xml><?xml version="1.0" encoding="utf-8"?>
+<p:sld xmlns:a="http://schemas.openxmlformats.org/drawingml/2006/main" xmlns:r="http://schemas.openxmlformats.org/officeDocument/2006/relationships" xmlns:p="http://schemas.openxmlformats.org/presentationml/2006/main">
+  <p:cSld>
+    <p:spTree>
+      <p:nvGrpSpPr>
+        <p:cNvPr id="1" name=""/>
+        <p:cNvGrpSpPr/>
+        <p:nvPr/>
+      </p:nvGrpSpPr>
+      <p:grpSpPr>
+        <a:xfrm>
+          <a:off x="0" y="0"/>
+          <a:ext cx="0" cy="0"/>
+          <a:chOff x="0" y="0"/>
+          <a:chExt cx="0" cy="0"/>
+        </a:xfrm>
+      </p:grpSpPr>
+      <p:sp>
+        <p:nvSpPr>
+          <p:cNvPr id="2" name="Titel 1">
+            <a:extLst>
+              <a:ext uri="{FF2B5EF4-FFF2-40B4-BE49-F238E27FC236}">
+                <a16:creationId xmlns:a16="http://schemas.microsoft.com/office/drawing/2014/main" id="{4D147CD3-C20F-B650-4051-8B93D4102B4D}"/>
+              </a:ext>
+            </a:extLst>
+          </p:cNvPr>
+          <p:cNvSpPr>
+            <a:spLocks noGrp="1"/>
+          </p:cNvSpPr>
+          <p:nvPr>
+            <p:ph type="title"/>
+          </p:nvPr>
+        </p:nvSpPr>
+        <p:spPr/>
+        <p:txBody>
+          <a:bodyPr/>
+          <a:lstStyle/>
+          <a:p>
+            <a:r>
+              <a:rPr lang="en-US" dirty="0" err="1"/>
+              <a:t>Metode</a:t>
+            </a:r>
+            <a:r>
+              <a:rPr lang="en-US" dirty="0"/>
+              <a:t> 3: Frequentists tests</a:t>
+            </a:r>
+            <a:endParaRPr lang="da-DK" dirty="0"/>
+          </a:p>
+        </p:txBody>
+      </p:sp>
+      <p:sp>
+        <p:nvSpPr>
+          <p:cNvPr id="3" name="Pladsholder til indhold 2">
+            <a:extLst>
+              <a:ext uri="{FF2B5EF4-FFF2-40B4-BE49-F238E27FC236}">
+                <a16:creationId xmlns:a16="http://schemas.microsoft.com/office/drawing/2014/main" id="{7292B951-6BD8-A8E4-CEE5-868317FCB2A4}"/>
+              </a:ext>
+            </a:extLst>
+          </p:cNvPr>
+          <p:cNvSpPr>
+            <a:spLocks noGrp="1"/>
+          </p:cNvSpPr>
+          <p:nvPr>
+            <p:ph idx="1"/>
+          </p:nvPr>
+        </p:nvSpPr>
+        <p:spPr/>
+        <p:txBody>
+          <a:bodyPr/>
+          <a:lstStyle/>
+          <a:p>
+            <a:r>
+              <a:rPr lang="en-US" dirty="0" err="1"/>
+              <a:t>Statistisk</a:t>
+            </a:r>
+            <a:r>
+              <a:rPr lang="en-US" dirty="0"/>
+              <a:t> test for </a:t>
+            </a:r>
+            <a:r>
+              <a:rPr lang="en-US" dirty="0" err="1"/>
+              <a:t>normalfordeling</a:t>
+            </a:r>
+            <a:r>
+              <a:rPr lang="en-US" dirty="0"/>
+              <a:t> </a:t>
+            </a:r>
+          </a:p>
+          <a:p>
+            <a:r>
+              <a:rPr lang="en-US" dirty="0" err="1"/>
+              <a:t>Findes</a:t>
+            </a:r>
+            <a:r>
+              <a:rPr lang="en-US" dirty="0"/>
+              <a:t> mange </a:t>
+            </a:r>
+            <a:r>
+              <a:rPr lang="en-US" dirty="0" err="1"/>
+              <a:t>forskellige</a:t>
+            </a:r>
+            <a:r>
+              <a:rPr lang="en-US" dirty="0"/>
+              <a:t> der </a:t>
+            </a:r>
+            <a:r>
+              <a:rPr lang="en-US" dirty="0" err="1"/>
+              <a:t>har</a:t>
+            </a:r>
+            <a:r>
+              <a:rPr lang="en-US" dirty="0"/>
+              <a:t> </a:t>
+            </a:r>
+            <a:r>
+              <a:rPr lang="en-US" dirty="0" err="1"/>
+              <a:t>fordele</a:t>
+            </a:r>
+            <a:r>
+              <a:rPr lang="en-US" dirty="0"/>
+              <a:t> </a:t>
+            </a:r>
+            <a:r>
+              <a:rPr lang="en-US" dirty="0" err="1"/>
+              <a:t>og</a:t>
+            </a:r>
+            <a:r>
+              <a:rPr lang="en-US" dirty="0"/>
+              <a:t> </a:t>
+            </a:r>
+            <a:r>
+              <a:rPr lang="en-US" dirty="0" err="1"/>
+              <a:t>ulemper</a:t>
+            </a:r>
+            <a:r>
+              <a:rPr lang="en-US" dirty="0"/>
+              <a:t>.</a:t>
+            </a:r>
+          </a:p>
+          <a:p>
+            <a:r>
+              <a:rPr lang="en-US" dirty="0" err="1"/>
+              <a:t>Mest</a:t>
+            </a:r>
+            <a:r>
+              <a:rPr lang="en-US" dirty="0"/>
+              <a:t> </a:t>
+            </a:r>
+            <a:r>
+              <a:rPr lang="en-US" dirty="0" err="1"/>
+              <a:t>almindelige</a:t>
+            </a:r>
+            <a:r>
+              <a:rPr lang="en-US" dirty="0"/>
+              <a:t> er Shapiro-Wilk</a:t>
+            </a:r>
+          </a:p>
+          <a:p>
+            <a:pPr lvl="1"/>
+            <a:r>
+              <a:rPr lang="en-US" dirty="0"/>
+              <a:t>Tester om det er </a:t>
+            </a:r>
+            <a:r>
+              <a:rPr lang="en-US" dirty="0" err="1"/>
+              <a:t>forskelligt</a:t>
+            </a:r>
+            <a:r>
+              <a:rPr lang="en-US" dirty="0"/>
+              <a:t> </a:t>
+            </a:r>
+            <a:r>
+              <a:rPr lang="en-US" dirty="0" err="1"/>
+              <a:t>fra</a:t>
+            </a:r>
+            <a:r>
+              <a:rPr lang="en-US" dirty="0"/>
+              <a:t> </a:t>
+            </a:r>
+            <a:r>
+              <a:rPr lang="en-US" dirty="0" err="1"/>
+              <a:t>en</a:t>
+            </a:r>
+            <a:r>
+              <a:rPr lang="en-US" dirty="0"/>
+              <a:t> </a:t>
+            </a:r>
+            <a:r>
+              <a:rPr lang="en-US" dirty="0" err="1"/>
+              <a:t>normalfordeling</a:t>
+            </a:r>
+            <a:r>
+              <a:rPr lang="en-US" dirty="0"/>
+              <a:t> </a:t>
+            </a:r>
+            <a:endParaRPr lang="da-DK" dirty="0"/>
+          </a:p>
+        </p:txBody>
+      </p:sp>
+    </p:spTree>
+    <p:extLst>
+      <p:ext uri="{BB962C8B-B14F-4D97-AF65-F5344CB8AC3E}">
+        <p14:creationId xmlns:p14="http://schemas.microsoft.com/office/powerpoint/2010/main" val="1208351884"/>
+      </p:ext>
+    </p:extLst>
+  </p:cSld>
+  <p:clrMapOvr>
+    <a:masterClrMapping/>
+  </p:clrMapOvr>
+</p:sld>
+</file>
+
+<file path=ppt/slides/slide24.xml><?xml version="1.0" encoding="utf-8"?>
+<p:sld xmlns:a="http://schemas.openxmlformats.org/drawingml/2006/main" xmlns:r="http://schemas.openxmlformats.org/officeDocument/2006/relationships" xmlns:p="http://schemas.openxmlformats.org/presentationml/2006/main">
+  <p:cSld>
+    <p:spTree>
+      <p:nvGrpSpPr>
+        <p:cNvPr id="1" name=""/>
+        <p:cNvGrpSpPr/>
+        <p:nvPr/>
+      </p:nvGrpSpPr>
+      <p:grpSpPr>
+        <a:xfrm>
+          <a:off x="0" y="0"/>
+          <a:ext cx="0" cy="0"/>
+          <a:chOff x="0" y="0"/>
+          <a:chExt cx="0" cy="0"/>
+        </a:xfrm>
+      </p:grpSpPr>
+      <p:sp>
+        <p:nvSpPr>
+          <p:cNvPr id="2" name="Titel 1">
+            <a:extLst>
+              <a:ext uri="{FF2B5EF4-FFF2-40B4-BE49-F238E27FC236}">
                 <a16:creationId xmlns:a16="http://schemas.microsoft.com/office/drawing/2014/main" id="{69401184-2E7A-1556-2264-13F14738696B}"/>
               </a:ext>
             </a:extLst>
@@ -10195,7 +10424,7 @@
 </p:sld>
 </file>
 
-<file path=ppt/slides/slide23.xml><?xml version="1.0" encoding="utf-8"?>
+<file path=ppt/slides/slide25.xml><?xml version="1.0" encoding="utf-8"?>
 <p:sld xmlns:a="http://schemas.openxmlformats.org/drawingml/2006/main" xmlns:r="http://schemas.openxmlformats.org/officeDocument/2006/relationships" xmlns:p="http://schemas.openxmlformats.org/presentationml/2006/main">
   <p:cSld>
     <p:spTree>
@@ -10272,7 +10501,7 @@
 </p:sld>
 </file>
 
-<file path=ppt/slides/slide24.xml><?xml version="1.0" encoding="utf-8"?>
+<file path=ppt/slides/slide26.xml><?xml version="1.0" encoding="utf-8"?>
 <p:sld xmlns:a="http://schemas.openxmlformats.org/drawingml/2006/main" xmlns:r="http://schemas.openxmlformats.org/officeDocument/2006/relationships" xmlns:p="http://schemas.openxmlformats.org/presentationml/2006/main">
   <p:cSld>
     <p:spTree>
@@ -10400,7 +10629,7 @@
 </p:sld>
 </file>
 
-<file path=ppt/slides/slide25.xml><?xml version="1.0" encoding="utf-8"?>
+<file path=ppt/slides/slide27.xml><?xml version="1.0" encoding="utf-8"?>
 <p:sld xmlns:a="http://schemas.openxmlformats.org/drawingml/2006/main" xmlns:r="http://schemas.openxmlformats.org/officeDocument/2006/relationships" xmlns:p="http://schemas.openxmlformats.org/presentationml/2006/main">
   <p:cSld>
     <p:spTree>
@@ -11637,7 +11866,7 @@
 </p:sld>
 </file>
 
-<file path=ppt/slides/slide26.xml><?xml version="1.0" encoding="utf-8"?>
+<file path=ppt/slides/slide28.xml><?xml version="1.0" encoding="utf-8"?>
 <p:sld xmlns:a="http://schemas.openxmlformats.org/drawingml/2006/main" xmlns:r="http://schemas.openxmlformats.org/officeDocument/2006/relationships" xmlns:p="http://schemas.openxmlformats.org/presentationml/2006/main">
   <p:cSld>
     <p:spTree>
@@ -11752,7 +11981,7 @@
 </p:sld>
 </file>
 
-<file path=ppt/slides/slide27.xml><?xml version="1.0" encoding="utf-8"?>
+<file path=ppt/slides/slide29.xml><?xml version="1.0" encoding="utf-8"?>
 <p:sld xmlns:a="http://schemas.openxmlformats.org/drawingml/2006/main" xmlns:r="http://schemas.openxmlformats.org/officeDocument/2006/relationships" xmlns:p="http://schemas.openxmlformats.org/presentationml/2006/main">
   <p:cSld>
     <p:spTree>
@@ -11774,7 +12003,7 @@
           <p:cNvPr id="2" name="Titel 1">
             <a:extLst>
               <a:ext uri="{FF2B5EF4-FFF2-40B4-BE49-F238E27FC236}">
-                <a16:creationId xmlns:a16="http://schemas.microsoft.com/office/drawing/2014/main" id="{32B96CDB-DA19-02ED-0B81-58996092BEB4}"/>
+                <a16:creationId xmlns:a16="http://schemas.microsoft.com/office/drawing/2014/main" id="{69401184-2E7A-1556-2264-13F14738696B}"/>
               </a:ext>
             </a:extLst>
           </p:cNvPr>
@@ -11782,7 +12011,7 @@
             <a:spLocks noGrp="1"/>
           </p:cNvSpPr>
           <p:nvPr>
-            <p:ph type="title"/>
+            <p:ph type="ctrTitle"/>
           </p:nvPr>
         </p:nvSpPr>
         <p:spPr/>
@@ -11792,35 +12021,11 @@
           <a:p>
             <a:r>
               <a:rPr lang="en-US" dirty="0" err="1"/>
-              <a:t>Koncepter</a:t>
+              <a:t>Øvelse</a:t>
             </a:r>
             <a:r>
               <a:rPr lang="en-US" dirty="0"/>
-              <a:t> vi </a:t>
-            </a:r>
-            <a:r>
-              <a:rPr lang="en-US" dirty="0" err="1"/>
-              <a:t>ikke</a:t>
-            </a:r>
-            <a:r>
-              <a:rPr lang="en-US" dirty="0"/>
-              <a:t> </a:t>
-            </a:r>
-            <a:r>
-              <a:rPr lang="en-US" dirty="0" err="1"/>
-              <a:t>har</a:t>
-            </a:r>
-            <a:r>
-              <a:rPr lang="en-US" dirty="0"/>
-              <a:t> </a:t>
-            </a:r>
-            <a:r>
-              <a:rPr lang="en-US" dirty="0" err="1"/>
-              <a:t>snakket</a:t>
-            </a:r>
-            <a:r>
-              <a:rPr lang="en-US" dirty="0"/>
-              <a:t> om</a:t>
+              <a:t> 5!</a:t>
             </a:r>
             <a:endParaRPr lang="da-DK" dirty="0"/>
           </a:p>
@@ -11828,10 +12033,10 @@
       </p:sp>
       <p:sp>
         <p:nvSpPr>
-          <p:cNvPr id="3" name="Pladsholder til indhold 2">
+          <p:cNvPr id="3" name="Undertitel 2">
             <a:extLst>
               <a:ext uri="{FF2B5EF4-FFF2-40B4-BE49-F238E27FC236}">
-                <a16:creationId xmlns:a16="http://schemas.microsoft.com/office/drawing/2014/main" id="{12CEFE9B-F979-A9D4-E80C-8F42295D54D2}"/>
+                <a16:creationId xmlns:a16="http://schemas.microsoft.com/office/drawing/2014/main" id="{34F64E3F-CE8A-368F-F0D5-C1D352155B33}"/>
               </a:ext>
             </a:extLst>
           </p:cNvPr>
@@ -11839,7 +12044,7 @@
             <a:spLocks noGrp="1"/>
           </p:cNvSpPr>
           <p:nvPr>
-            <p:ph idx="1"/>
+            <p:ph type="subTitle" idx="1"/>
           </p:nvPr>
         </p:nvSpPr>
         <p:spPr/>
@@ -11848,20 +12053,8 @@
           <a:lstStyle/>
           <a:p>
             <a:r>
-              <a:rPr lang="en-US" dirty="0"/>
-              <a:t>Confidence intervals</a:t>
-            </a:r>
-          </a:p>
-          <a:p>
-            <a:r>
-              <a:rPr lang="en-US" dirty="0"/>
-              <a:t>Time-to-event</a:t>
-            </a:r>
-          </a:p>
-          <a:p>
-            <a:r>
               <a:rPr lang="en-US" dirty="0" err="1"/>
-              <a:t>Baysiansk</a:t>
+              <a:t>Hypotesetests</a:t>
             </a:r>
             <a:r>
               <a:rPr lang="en-US" dirty="0"/>
@@ -11869,17 +12062,12 @@
             </a:r>
             <a:r>
               <a:rPr lang="en-US" dirty="0" err="1"/>
-              <a:t>statistik</a:t>
-            </a:r>
-            <a:endParaRPr lang="en-US" dirty="0"/>
-          </a:p>
-          <a:p>
+              <a:t>og</a:t>
+            </a:r>
             <a:r>
               <a:rPr lang="en-US" dirty="0"/>
-              <a:t>Machine learning </a:t>
-            </a:r>
-          </a:p>
-          <a:p>
+              <a:t> diverse</a:t>
+            </a:r>
             <a:endParaRPr lang="da-DK" dirty="0"/>
           </a:p>
         </p:txBody>
@@ -11887,7 +12075,7 @@
     </p:spTree>
     <p:extLst>
       <p:ext uri="{BB962C8B-B14F-4D97-AF65-F5344CB8AC3E}">
-        <p14:creationId xmlns:p14="http://schemas.microsoft.com/office/powerpoint/2010/main" val="1922600953"/>
+        <p14:creationId xmlns:p14="http://schemas.microsoft.com/office/powerpoint/2010/main" val="1716853627"/>
       </p:ext>
     </p:extLst>
   </p:cSld>
@@ -11898,6 +12086,319 @@
 </file>
 
 <file path=ppt/slides/slide3.xml><?xml version="1.0" encoding="utf-8"?>
+<p:sld xmlns:a="http://schemas.openxmlformats.org/drawingml/2006/main" xmlns:r="http://schemas.openxmlformats.org/officeDocument/2006/relationships" xmlns:p="http://schemas.openxmlformats.org/presentationml/2006/main">
+  <p:cSld>
+    <p:bg>
+      <p:bgPr>
+        <a:solidFill>
+          <a:schemeClr val="bg1"/>
+        </a:solidFill>
+        <a:effectLst/>
+      </p:bgPr>
+    </p:bg>
+    <p:spTree>
+      <p:nvGrpSpPr>
+        <p:cNvPr id="1" name=""/>
+        <p:cNvGrpSpPr/>
+        <p:nvPr/>
+      </p:nvGrpSpPr>
+      <p:grpSpPr>
+        <a:xfrm>
+          <a:off x="0" y="0"/>
+          <a:ext cx="0" cy="0"/>
+          <a:chOff x="0" y="0"/>
+          <a:chExt cx="0" cy="0"/>
+        </a:xfrm>
+      </p:grpSpPr>
+      <p:sp useBgFill="1">
+        <p:nvSpPr>
+          <p:cNvPr id="9" name="Rectangle 8">
+            <a:extLst>
+              <a:ext uri="{FF2B5EF4-FFF2-40B4-BE49-F238E27FC236}">
+                <a16:creationId xmlns:a16="http://schemas.microsoft.com/office/drawing/2014/main" id="{9DBC8166-481C-4473-95F5-9A5B9073B7F1}"/>
+              </a:ext>
+              <a:ext uri="{C183D7F6-B498-43B3-948B-1728B52AA6E4}">
+                <adec:decorative xmlns:adec="http://schemas.microsoft.com/office/drawing/2017/decorative" val="1"/>
+              </a:ext>
+            </a:extLst>
+          </p:cNvPr>
+          <p:cNvSpPr>
+            <a:spLocks noGrp="1" noRot="1" noChangeAspect="1" noMove="1" noResize="1" noEditPoints="1" noAdjustHandles="1" noChangeArrowheads="1" noChangeShapeType="1" noTextEdit="1"/>
+          </p:cNvSpPr>
+          <p:nvPr>
+            <p:extLst>
+              <p:ext uri="{386F3935-93C4-4BCD-93E2-E3B085C9AB24}">
+                <p16:designElem xmlns:p16="http://schemas.microsoft.com/office/powerpoint/2015/main" val="1"/>
+              </p:ext>
+            </p:extLst>
+          </p:nvPr>
+        </p:nvSpPr>
+        <p:spPr>
+          <a:xfrm>
+            <a:off x="0" y="0"/>
+            <a:ext cx="12188952" cy="6858000"/>
+          </a:xfrm>
+          <a:prstGeom prst="rect">
+            <a:avLst/>
+          </a:prstGeom>
+          <a:ln>
+            <a:noFill/>
+          </a:ln>
+        </p:spPr>
+        <p:style>
+          <a:lnRef idx="2">
+            <a:schemeClr val="accent1">
+              <a:shade val="50000"/>
+            </a:schemeClr>
+          </a:lnRef>
+          <a:fillRef idx="1">
+            <a:schemeClr val="accent1"/>
+          </a:fillRef>
+          <a:effectRef idx="0">
+            <a:schemeClr val="accent1"/>
+          </a:effectRef>
+          <a:fontRef idx="minor">
+            <a:schemeClr val="lt1"/>
+          </a:fontRef>
+        </p:style>
+        <p:txBody>
+          <a:bodyPr rtlCol="0" anchor="ctr"/>
+          <a:lstStyle/>
+          <a:p>
+            <a:pPr algn="ctr"/>
+            <a:endParaRPr lang="en-US"/>
+          </a:p>
+        </p:txBody>
+      </p:sp>
+      <p:sp>
+        <p:nvSpPr>
+          <p:cNvPr id="11" name="Freeform: Shape 10">
+            <a:extLst>
+              <a:ext uri="{FF2B5EF4-FFF2-40B4-BE49-F238E27FC236}">
+                <a16:creationId xmlns:a16="http://schemas.microsoft.com/office/drawing/2014/main" id="{A5A5CE6E-90AF-4D43-A014-1F9EC83EB93D}"/>
+              </a:ext>
+              <a:ext uri="{C183D7F6-B498-43B3-948B-1728B52AA6E4}">
+                <adec:decorative xmlns:adec="http://schemas.microsoft.com/office/drawing/2017/decorative" val="1"/>
+              </a:ext>
+            </a:extLst>
+          </p:cNvPr>
+          <p:cNvSpPr>
+            <a:spLocks noGrp="1" noRot="1" noChangeAspect="1" noMove="1" noResize="1" noEditPoints="1" noAdjustHandles="1" noChangeArrowheads="1" noChangeShapeType="1" noTextEdit="1"/>
+          </p:cNvSpPr>
+          <p:nvPr>
+            <p:extLst>
+              <p:ext uri="{386F3935-93C4-4BCD-93E2-E3B085C9AB24}">
+                <p16:designElem xmlns:p16="http://schemas.microsoft.com/office/powerpoint/2015/main" val="1"/>
+              </p:ext>
+            </p:extLst>
+          </p:nvPr>
+        </p:nvSpPr>
+        <p:spPr>
+          <a:xfrm>
+            <a:off x="0" y="1"/>
+            <a:ext cx="4512467" cy="6858000"/>
+          </a:xfrm>
+          <a:custGeom>
+            <a:avLst/>
+            <a:gdLst>
+              <a:gd name="connsiteX0" fmla="*/ 0 w 4512467"/>
+              <a:gd name="connsiteY0" fmla="*/ 0 h 6858000"/>
+              <a:gd name="connsiteX1" fmla="*/ 2579526 w 4512467"/>
+              <a:gd name="connsiteY1" fmla="*/ 0 h 6858000"/>
+              <a:gd name="connsiteX2" fmla="*/ 2583267 w 4512467"/>
+              <a:gd name="connsiteY2" fmla="*/ 2151 h 6858000"/>
+              <a:gd name="connsiteX3" fmla="*/ 4512467 w 4512467"/>
+              <a:gd name="connsiteY3" fmla="*/ 3429000 h 6858000"/>
+              <a:gd name="connsiteX4" fmla="*/ 2583267 w 4512467"/>
+              <a:gd name="connsiteY4" fmla="*/ 6855849 h 6858000"/>
+              <a:gd name="connsiteX5" fmla="*/ 2579526 w 4512467"/>
+              <a:gd name="connsiteY5" fmla="*/ 6858000 h 6858000"/>
+              <a:gd name="connsiteX6" fmla="*/ 0 w 4512467"/>
+              <a:gd name="connsiteY6" fmla="*/ 6858000 h 6858000"/>
+            </a:gdLst>
+            <a:ahLst/>
+            <a:cxnLst>
+              <a:cxn ang="0">
+                <a:pos x="connsiteX0" y="connsiteY0"/>
+              </a:cxn>
+              <a:cxn ang="0">
+                <a:pos x="connsiteX1" y="connsiteY1"/>
+              </a:cxn>
+              <a:cxn ang="0">
+                <a:pos x="connsiteX2" y="connsiteY2"/>
+              </a:cxn>
+              <a:cxn ang="0">
+                <a:pos x="connsiteX3" y="connsiteY3"/>
+              </a:cxn>
+              <a:cxn ang="0">
+                <a:pos x="connsiteX4" y="connsiteY4"/>
+              </a:cxn>
+              <a:cxn ang="0">
+                <a:pos x="connsiteX5" y="connsiteY5"/>
+              </a:cxn>
+              <a:cxn ang="0">
+                <a:pos x="connsiteX6" y="connsiteY6"/>
+              </a:cxn>
+            </a:cxnLst>
+            <a:rect l="l" t="t" r="r" b="b"/>
+            <a:pathLst>
+              <a:path w="4512467" h="6858000">
+                <a:moveTo>
+                  <a:pt x="0" y="0"/>
+                </a:moveTo>
+                <a:lnTo>
+                  <a:pt x="2579526" y="0"/>
+                </a:lnTo>
+                <a:lnTo>
+                  <a:pt x="2583267" y="2151"/>
+                </a:lnTo>
+                <a:cubicBezTo>
+                  <a:pt x="3739868" y="704919"/>
+                  <a:pt x="4512467" y="1976735"/>
+                  <a:pt x="4512467" y="3429000"/>
+                </a:cubicBezTo>
+                <a:cubicBezTo>
+                  <a:pt x="4512467" y="4881266"/>
+                  <a:pt x="3739868" y="6153081"/>
+                  <a:pt x="2583267" y="6855849"/>
+                </a:cubicBezTo>
+                <a:lnTo>
+                  <a:pt x="2579526" y="6858000"/>
+                </a:lnTo>
+                <a:lnTo>
+                  <a:pt x="0" y="6858000"/>
+                </a:lnTo>
+                <a:close/>
+              </a:path>
+            </a:pathLst>
+          </a:custGeom>
+          <a:solidFill>
+            <a:schemeClr val="accent2"/>
+          </a:solidFill>
+          <a:ln>
+            <a:noFill/>
+          </a:ln>
+        </p:spPr>
+        <p:style>
+          <a:lnRef idx="2">
+            <a:schemeClr val="accent1">
+              <a:shade val="50000"/>
+            </a:schemeClr>
+          </a:lnRef>
+          <a:fillRef idx="1">
+            <a:schemeClr val="accent1"/>
+          </a:fillRef>
+          <a:effectRef idx="0">
+            <a:schemeClr val="accent1"/>
+          </a:effectRef>
+          <a:fontRef idx="minor">
+            <a:schemeClr val="lt1"/>
+          </a:fontRef>
+        </p:style>
+        <p:txBody>
+          <a:bodyPr wrap="square" rtlCol="0" anchor="ctr">
+            <a:noAutofit/>
+          </a:bodyPr>
+          <a:lstStyle/>
+          <a:p>
+            <a:pPr algn="ctr"/>
+            <a:endParaRPr lang="en-US">
+              <a:solidFill>
+                <a:schemeClr val="bg1"/>
+              </a:solidFill>
+            </a:endParaRPr>
+          </a:p>
+        </p:txBody>
+      </p:sp>
+      <p:sp>
+        <p:nvSpPr>
+          <p:cNvPr id="2" name="Titel 1">
+            <a:extLst>
+              <a:ext uri="{FF2B5EF4-FFF2-40B4-BE49-F238E27FC236}">
+                <a16:creationId xmlns:a16="http://schemas.microsoft.com/office/drawing/2014/main" id="{A1495B9F-CEAA-C88E-7F78-7758B929DFCB}"/>
+              </a:ext>
+            </a:extLst>
+          </p:cNvPr>
+          <p:cNvSpPr>
+            <a:spLocks noGrp="1"/>
+          </p:cNvSpPr>
+          <p:nvPr>
+            <p:ph type="title"/>
+          </p:nvPr>
+        </p:nvSpPr>
+        <p:spPr>
+          <a:xfrm>
+            <a:off x="838200" y="643467"/>
+            <a:ext cx="2951205" cy="5571066"/>
+          </a:xfrm>
+        </p:spPr>
+        <p:txBody>
+          <a:bodyPr>
+            <a:normAutofit/>
+          </a:bodyPr>
+          <a:lstStyle/>
+          <a:p>
+            <a:r>
+              <a:rPr lang="en-US">
+                <a:solidFill>
+                  <a:srgbClr val="FFFFFF"/>
+                </a:solidFill>
+              </a:rPr>
+              <a:t>Agenda</a:t>
+            </a:r>
+            <a:endParaRPr lang="da-DK">
+              <a:solidFill>
+                <a:srgbClr val="FFFFFF"/>
+              </a:solidFill>
+            </a:endParaRPr>
+          </a:p>
+        </p:txBody>
+      </p:sp>
+      <p:graphicFrame>
+        <p:nvGraphicFramePr>
+          <p:cNvPr id="5" name="Pladsholder til indhold 2">
+            <a:extLst>
+              <a:ext uri="{FF2B5EF4-FFF2-40B4-BE49-F238E27FC236}">
+                <a16:creationId xmlns:a16="http://schemas.microsoft.com/office/drawing/2014/main" id="{C7C0F459-B1A2-7BE3-CF43-91DC17D7B3CD}"/>
+              </a:ext>
+            </a:extLst>
+          </p:cNvPr>
+          <p:cNvGraphicFramePr>
+            <a:graphicFrameLocks noGrp="1"/>
+          </p:cNvGraphicFramePr>
+          <p:nvPr>
+            <p:ph idx="1"/>
+            <p:extLst>
+              <p:ext uri="{D42A27DB-BD31-4B8C-83A1-F6EECF244321}">
+                <p14:modId xmlns:p14="http://schemas.microsoft.com/office/powerpoint/2010/main" val="907560398"/>
+              </p:ext>
+            </p:extLst>
+          </p:nvPr>
+        </p:nvGraphicFramePr>
+        <p:xfrm>
+          <a:off x="5207640" y="643466"/>
+          <a:ext cx="6291714" cy="5530735"/>
+        </p:xfrm>
+        <a:graphic>
+          <a:graphicData uri="http://schemas.openxmlformats.org/drawingml/2006/diagram">
+            <dgm:relIds xmlns:dgm="http://schemas.openxmlformats.org/drawingml/2006/diagram" xmlns:r="http://schemas.openxmlformats.org/officeDocument/2006/relationships" r:dm="rId2" r:lo="rId3" r:qs="rId4" r:cs="rId5"/>
+          </a:graphicData>
+        </a:graphic>
+      </p:graphicFrame>
+    </p:spTree>
+    <p:extLst>
+      <p:ext uri="{BB962C8B-B14F-4D97-AF65-F5344CB8AC3E}">
+        <p14:creationId xmlns:p14="http://schemas.microsoft.com/office/powerpoint/2010/main" val="2257908964"/>
+      </p:ext>
+    </p:extLst>
+  </p:cSld>
+  <p:clrMapOvr>
+    <a:masterClrMapping/>
+  </p:clrMapOvr>
+</p:sld>
+</file>
+
+<file path=ppt/slides/slide30.xml><?xml version="1.0" encoding="utf-8"?>
 <p:sld xmlns:a="http://schemas.openxmlformats.org/drawingml/2006/main" xmlns:r="http://schemas.openxmlformats.org/officeDocument/2006/relationships" xmlns:p="http://schemas.openxmlformats.org/presentationml/2006/main">
   <p:cSld>
     <p:spTree>
@@ -11919,7 +12420,7 @@
           <p:cNvPr id="2" name="Titel 1">
             <a:extLst>
               <a:ext uri="{FF2B5EF4-FFF2-40B4-BE49-F238E27FC236}">
-                <a16:creationId xmlns:a16="http://schemas.microsoft.com/office/drawing/2014/main" id="{B59FA2A5-8C4B-D1BC-72B4-DE29A2ED5B1F}"/>
+                <a16:creationId xmlns:a16="http://schemas.microsoft.com/office/drawing/2014/main" id="{32B96CDB-DA19-02ED-0B81-58996092BEB4}"/>
               </a:ext>
             </a:extLst>
           </p:cNvPr>
@@ -11937,7 +12438,15 @@
           <a:p>
             <a:r>
               <a:rPr lang="en-US" dirty="0" err="1"/>
-              <a:t>Øvelserne</a:t>
+              <a:t>Koncepter</a:t>
+            </a:r>
+            <a:r>
+              <a:rPr lang="en-US" dirty="0"/>
+              <a:t> vi </a:t>
+            </a:r>
+            <a:r>
+              <a:rPr lang="en-US" dirty="0" err="1"/>
+              <a:t>ikke</a:t>
             </a:r>
             <a:r>
               <a:rPr lang="en-US" dirty="0"/>
@@ -11945,11 +12454,19 @@
             </a:r>
             <a:r>
               <a:rPr lang="en-US" dirty="0" err="1"/>
-              <a:t>imellem</a:t>
+              <a:t>har</a:t>
             </a:r>
             <a:r>
               <a:rPr lang="en-US" dirty="0"/>
               <a:t> </a:t>
+            </a:r>
+            <a:r>
+              <a:rPr lang="en-US" dirty="0" err="1"/>
+              <a:t>snakket</a:t>
+            </a:r>
+            <a:r>
+              <a:rPr lang="en-US" dirty="0"/>
+              <a:t> om</a:t>
             </a:r>
             <a:endParaRPr lang="da-DK" dirty="0"/>
           </a:p>
@@ -11960,7 +12477,7 @@
           <p:cNvPr id="3" name="Pladsholder til indhold 2">
             <a:extLst>
               <a:ext uri="{FF2B5EF4-FFF2-40B4-BE49-F238E27FC236}">
-                <a16:creationId xmlns:a16="http://schemas.microsoft.com/office/drawing/2014/main" id="{BB635A08-BF34-CC00-CDF7-B45326C7E656}"/>
+                <a16:creationId xmlns:a16="http://schemas.microsoft.com/office/drawing/2014/main" id="{12CEFE9B-F979-A9D4-E80C-8F42295D54D2}"/>
               </a:ext>
             </a:extLst>
           </p:cNvPr>
@@ -11978,11 +12495,57 @@
           <a:p>
             <a:r>
               <a:rPr lang="en-US" dirty="0"/>
-              <a:t>Sorry </a:t>
+              <a:t>Linear </a:t>
             </a:r>
             <a:r>
               <a:rPr lang="en-US" dirty="0" err="1"/>
-              <a:t>jeg</a:t>
+              <a:t>regressioner</a:t>
+            </a:r>
+            <a:r>
+              <a:rPr lang="en-US" dirty="0"/>
+              <a:t> (</a:t>
+            </a:r>
+            <a:r>
+              <a:rPr lang="en-US" dirty="0" err="1"/>
+              <a:t>næste</a:t>
+            </a:r>
+            <a:r>
+              <a:rPr lang="en-US" dirty="0"/>
+              <a:t> gang)</a:t>
+            </a:r>
+          </a:p>
+          <a:p>
+            <a:r>
+              <a:rPr lang="en-US" dirty="0"/>
+              <a:t>Confidence intervals (</a:t>
+            </a:r>
+            <a:r>
+              <a:rPr lang="en-US" dirty="0" err="1"/>
+              <a:t>næste</a:t>
+            </a:r>
+            <a:r>
+              <a:rPr lang="en-US" dirty="0"/>
+              <a:t> gang)</a:t>
+            </a:r>
+          </a:p>
+          <a:p>
+            <a:r>
+              <a:rPr lang="en-US" dirty="0"/>
+              <a:t>Time-to-event (</a:t>
+            </a:r>
+            <a:r>
+              <a:rPr lang="en-US" dirty="0" err="1"/>
+              <a:t>næste</a:t>
+            </a:r>
+            <a:r>
+              <a:rPr lang="en-US" dirty="0"/>
+              <a:t> gang)</a:t>
+            </a:r>
+          </a:p>
+          <a:p>
+            <a:r>
+              <a:rPr lang="en-US" dirty="0" err="1"/>
+              <a:t>Baysiansk</a:t>
             </a:r>
             <a:r>
               <a:rPr lang="en-US" dirty="0"/>
@@ -11990,42 +12553,17 @@
             </a:r>
             <a:r>
               <a:rPr lang="en-US" dirty="0" err="1"/>
-              <a:t>sendte</a:t>
-            </a:r>
+              <a:t>statistik</a:t>
+            </a:r>
+            <a:endParaRPr lang="en-US" dirty="0"/>
+          </a:p>
+          <a:p>
             <a:r>
               <a:rPr lang="en-US" dirty="0"/>
-              <a:t> </a:t>
-            </a:r>
-            <a:r>
-              <a:rPr lang="en-US" dirty="0" err="1"/>
-              <a:t>versionen</a:t>
-            </a:r>
-            <a:r>
-              <a:rPr lang="en-US" dirty="0"/>
-              <a:t> med </a:t>
-            </a:r>
-            <a:r>
-              <a:rPr lang="en-US" dirty="0" err="1"/>
-              <a:t>svar</a:t>
-            </a:r>
-            <a:r>
-              <a:rPr lang="en-US" dirty="0"/>
-              <a:t> </a:t>
-            </a:r>
-            <a:r>
-              <a:rPr lang="en-US" dirty="0" err="1"/>
-              <a:t>ud</a:t>
-            </a:r>
-            <a:r>
-              <a:rPr lang="en-US" dirty="0"/>
-              <a:t> </a:t>
-            </a:r>
-            <a:r>
-              <a:rPr lang="en-US" dirty="0">
-                <a:sym typeface="Wingdings" panose="05000000000000000000" pitchFamily="2" charset="2"/>
-              </a:rPr>
-              <a:t> </a:t>
-            </a:r>
+              <a:t>Machine learning </a:t>
+            </a:r>
+          </a:p>
+          <a:p>
             <a:endParaRPr lang="da-DK" dirty="0"/>
           </a:p>
         </p:txBody>
@@ -12033,95 +12571,13 @@
     </p:spTree>
     <p:extLst>
       <p:ext uri="{BB962C8B-B14F-4D97-AF65-F5344CB8AC3E}">
-        <p14:creationId xmlns:p14="http://schemas.microsoft.com/office/powerpoint/2010/main" val="1022630639"/>
+        <p14:creationId xmlns:p14="http://schemas.microsoft.com/office/powerpoint/2010/main" val="1922600953"/>
       </p:ext>
     </p:extLst>
   </p:cSld>
   <p:clrMapOvr>
     <a:masterClrMapping/>
   </p:clrMapOvr>
-  <p:timing>
-    <p:tnLst>
-      <p:par>
-        <p:cTn id="1" dur="indefinite" restart="never" nodeType="tmRoot">
-          <p:childTnLst>
-            <p:seq concurrent="1" nextAc="seek">
-              <p:cTn id="2" dur="indefinite" nodeType="mainSeq">
-                <p:childTnLst>
-                  <p:par>
-                    <p:cTn id="3" fill="hold">
-                      <p:stCondLst>
-                        <p:cond delay="indefinite"/>
-                      </p:stCondLst>
-                      <p:childTnLst>
-                        <p:par>
-                          <p:cTn id="4" fill="hold">
-                            <p:stCondLst>
-                              <p:cond delay="0"/>
-                            </p:stCondLst>
-                            <p:childTnLst>
-                              <p:par>
-                                <p:cTn id="5" presetID="1" presetClass="entr" presetSubtype="0" fill="hold" grpId="0" nodeType="clickEffect">
-                                  <p:stCondLst>
-                                    <p:cond delay="0"/>
-                                  </p:stCondLst>
-                                  <p:childTnLst>
-                                    <p:set>
-                                      <p:cBhvr>
-                                        <p:cTn id="6" dur="1" fill="hold">
-                                          <p:stCondLst>
-                                            <p:cond delay="0"/>
-                                          </p:stCondLst>
-                                        </p:cTn>
-                                        <p:tgtEl>
-                                          <p:spTgt spid="3">
-                                            <p:txEl>
-                                              <p:pRg st="0" end="0"/>
-                                            </p:txEl>
-                                          </p:spTgt>
-                                        </p:tgtEl>
-                                        <p:attrNameLst>
-                                          <p:attrName>style.visibility</p:attrName>
-                                        </p:attrNameLst>
-                                      </p:cBhvr>
-                                      <p:to>
-                                        <p:strVal val="visible"/>
-                                      </p:to>
-                                    </p:set>
-                                  </p:childTnLst>
-                                </p:cTn>
-                              </p:par>
-                            </p:childTnLst>
-                          </p:cTn>
-                        </p:par>
-                      </p:childTnLst>
-                    </p:cTn>
-                  </p:par>
-                </p:childTnLst>
-              </p:cTn>
-              <p:prevCondLst>
-                <p:cond evt="onPrev" delay="0">
-                  <p:tgtEl>
-                    <p:sldTgt/>
-                  </p:tgtEl>
-                </p:cond>
-              </p:prevCondLst>
-              <p:nextCondLst>
-                <p:cond evt="onNext" delay="0">
-                  <p:tgtEl>
-                    <p:sldTgt/>
-                  </p:tgtEl>
-                </p:cond>
-              </p:nextCondLst>
-            </p:seq>
-          </p:childTnLst>
-        </p:cTn>
-      </p:par>
-    </p:tnLst>
-    <p:bldLst>
-      <p:bldP spid="3" grpId="0" build="p"/>
-    </p:bldLst>
-  </p:timing>
 </p:sld>
 </file>
 
@@ -12147,7 +12603,120 @@
           <p:cNvPr id="2" name="Titel 1">
             <a:extLst>
               <a:ext uri="{FF2B5EF4-FFF2-40B4-BE49-F238E27FC236}">
-                <a16:creationId xmlns:a16="http://schemas.microsoft.com/office/drawing/2014/main" id="{927FB607-6D2E-C5BF-9C9E-DD9E53D70A8D}"/>
+                <a16:creationId xmlns:a16="http://schemas.microsoft.com/office/drawing/2014/main" id="{5AFCD89C-9869-0813-DF0E-1547A2647DF5}"/>
+              </a:ext>
+            </a:extLst>
+          </p:cNvPr>
+          <p:cNvSpPr>
+            <a:spLocks noGrp="1"/>
+          </p:cNvSpPr>
+          <p:nvPr>
+            <p:ph type="title"/>
+          </p:nvPr>
+        </p:nvSpPr>
+        <p:spPr/>
+        <p:txBody>
+          <a:bodyPr/>
+          <a:lstStyle/>
+          <a:p>
+            <a:r>
+              <a:rPr lang="da-DK" dirty="0"/>
+              <a:t>Hypotesetest</a:t>
+            </a:r>
+          </a:p>
+        </p:txBody>
+      </p:sp>
+      <p:pic>
+        <p:nvPicPr>
+          <p:cNvPr id="3074" name="Picture 2" descr="Hypothesis Testing - Definition, Examples, Formula, Types">
+            <a:extLst>
+              <a:ext uri="{FF2B5EF4-FFF2-40B4-BE49-F238E27FC236}">
+                <a16:creationId xmlns:a16="http://schemas.microsoft.com/office/drawing/2014/main" id="{C9333904-A1BC-3C70-64DA-B6E5B03D4E29}"/>
+              </a:ext>
+            </a:extLst>
+          </p:cNvPr>
+          <p:cNvPicPr>
+            <a:picLocks noGrp="1" noChangeAspect="1" noChangeArrowheads="1"/>
+          </p:cNvPicPr>
+          <p:nvPr>
+            <p:ph idx="1"/>
+          </p:nvPr>
+        </p:nvPicPr>
+        <p:blipFill>
+          <a:blip r:embed="rId2">
+            <a:extLst>
+              <a:ext uri="{28A0092B-C50C-407E-A947-70E740481C1C}">
+                <a14:useLocalDpi xmlns:a14="http://schemas.microsoft.com/office/drawing/2010/main" val="0"/>
+              </a:ext>
+            </a:extLst>
+          </a:blip>
+          <a:srcRect/>
+          <a:stretch>
+            <a:fillRect/>
+          </a:stretch>
+        </p:blipFill>
+        <p:spPr bwMode="auto">
+          <a:xfrm>
+            <a:off x="3201183" y="2341233"/>
+            <a:ext cx="5789634" cy="3320122"/>
+          </a:xfrm>
+          <a:prstGeom prst="rect">
+            <a:avLst/>
+          </a:prstGeom>
+          <a:noFill/>
+          <a:extLst>
+            <a:ext uri="{909E8E84-426E-40DD-AFC4-6F175D3DCCD1}">
+              <a14:hiddenFill xmlns:a14="http://schemas.microsoft.com/office/drawing/2010/main">
+                <a:solidFill>
+                  <a:srgbClr val="FFFFFF"/>
+                </a:solidFill>
+              </a14:hiddenFill>
+            </a:ext>
+          </a:extLst>
+        </p:spPr>
+      </p:pic>
+    </p:spTree>
+    <p:extLst>
+      <p:ext uri="{BB962C8B-B14F-4D97-AF65-F5344CB8AC3E}">
+        <p14:creationId xmlns:p14="http://schemas.microsoft.com/office/powerpoint/2010/main" val="1469270370"/>
+      </p:ext>
+    </p:extLst>
+  </p:cSld>
+  <p:clrMapOvr>
+    <a:masterClrMapping/>
+  </p:clrMapOvr>
+</p:sld>
+</file>
+
+<file path=ppt/slides/slide5.xml><?xml version="1.0" encoding="utf-8"?>
+<p:sld xmlns:a="http://schemas.openxmlformats.org/drawingml/2006/main" xmlns:r="http://schemas.openxmlformats.org/officeDocument/2006/relationships" xmlns:p="http://schemas.openxmlformats.org/presentationml/2006/main">
+  <p:cSld>
+    <p:spTree>
+      <p:nvGrpSpPr>
+        <p:cNvPr id="1" name="">
+          <a:extLst>
+            <a:ext uri="{FF2B5EF4-FFF2-40B4-BE49-F238E27FC236}">
+              <a16:creationId xmlns:a16="http://schemas.microsoft.com/office/drawing/2014/main" id="{1F7A24DA-38D8-A116-7C23-4F20FB244A10}"/>
+            </a:ext>
+          </a:extLst>
+        </p:cNvPr>
+        <p:cNvGrpSpPr/>
+        <p:nvPr/>
+      </p:nvGrpSpPr>
+      <p:grpSpPr>
+        <a:xfrm>
+          <a:off x="0" y="0"/>
+          <a:ext cx="0" cy="0"/>
+          <a:chOff x="0" y="0"/>
+          <a:chExt cx="0" cy="0"/>
+        </a:xfrm>
+      </p:grpSpPr>
+      <p:sp>
+        <p:nvSpPr>
+          <p:cNvPr id="2" name="Titel 1">
+            <a:extLst>
+              <a:ext uri="{FF2B5EF4-FFF2-40B4-BE49-F238E27FC236}">
+                <a16:creationId xmlns:a16="http://schemas.microsoft.com/office/drawing/2014/main" id="{91151244-0A0D-1FDF-7882-EE6AF430B1CA}"/>
               </a:ext>
             </a:extLst>
           </p:cNvPr>
@@ -12164,8 +12733,12 @@
           <a:lstStyle/>
           <a:p>
             <a:r>
+              <a:rPr lang="en-US" dirty="0" err="1"/>
+              <a:t>Øvelse</a:t>
+            </a:r>
+            <a:r>
               <a:rPr lang="en-US" dirty="0"/>
-              <a:t>Basic concept 1</a:t>
+              <a:t> 3!</a:t>
             </a:r>
             <a:endParaRPr lang="da-DK" dirty="0"/>
           </a:p>
@@ -12176,7 +12749,7 @@
           <p:cNvPr id="3" name="Undertitel 2">
             <a:extLst>
               <a:ext uri="{FF2B5EF4-FFF2-40B4-BE49-F238E27FC236}">
-                <a16:creationId xmlns:a16="http://schemas.microsoft.com/office/drawing/2014/main" id="{267A5B4D-C76A-ECA9-85E3-C41F67416F13}"/>
+                <a16:creationId xmlns:a16="http://schemas.microsoft.com/office/drawing/2014/main" id="{BC3D8388-7D9D-493C-7881-38474C5A35C7}"/>
               </a:ext>
             </a:extLst>
           </p:cNvPr>
@@ -12193,8 +12766,12 @@
           <a:lstStyle/>
           <a:p>
             <a:r>
-              <a:rPr lang="en-US" dirty="0" err="1"/>
-              <a:t>Normalfordeling</a:t>
+              <a:rPr lang="en-US" dirty="0"/>
+              <a:t>T-</a:t>
+            </a:r>
+            <a:r>
+              <a:rPr lang="en-US"/>
+              <a:t>testen</a:t>
             </a:r>
             <a:endParaRPr lang="da-DK" dirty="0"/>
           </a:p>
@@ -12203,7 +12780,7 @@
     </p:spTree>
     <p:extLst>
       <p:ext uri="{BB962C8B-B14F-4D97-AF65-F5344CB8AC3E}">
-        <p14:creationId xmlns:p14="http://schemas.microsoft.com/office/powerpoint/2010/main" val="246476336"/>
+        <p14:creationId xmlns:p14="http://schemas.microsoft.com/office/powerpoint/2010/main" val="2996042283"/>
       </p:ext>
     </p:extLst>
   </p:cSld>
@@ -12213,7 +12790,7 @@
 </p:sld>
 </file>
 
-<file path=ppt/slides/slide5.xml><?xml version="1.0" encoding="utf-8"?>
+<file path=ppt/slides/slide6.xml><?xml version="1.0" encoding="utf-8"?>
 <p:sld xmlns:a="http://schemas.openxmlformats.org/drawingml/2006/main" xmlns:r="http://schemas.openxmlformats.org/officeDocument/2006/relationships" xmlns:p="http://schemas.openxmlformats.org/presentationml/2006/main">
   <p:cSld>
     <p:spTree>
@@ -12235,6 +12812,94 @@
           <p:cNvPr id="2" name="Titel 1">
             <a:extLst>
               <a:ext uri="{FF2B5EF4-FFF2-40B4-BE49-F238E27FC236}">
+                <a16:creationId xmlns:a16="http://schemas.microsoft.com/office/drawing/2014/main" id="{927FB607-6D2E-C5BF-9C9E-DD9E53D70A8D}"/>
+              </a:ext>
+            </a:extLst>
+          </p:cNvPr>
+          <p:cNvSpPr>
+            <a:spLocks noGrp="1"/>
+          </p:cNvSpPr>
+          <p:nvPr>
+            <p:ph type="ctrTitle"/>
+          </p:nvPr>
+        </p:nvSpPr>
+        <p:spPr/>
+        <p:txBody>
+          <a:bodyPr/>
+          <a:lstStyle/>
+          <a:p>
+            <a:r>
+              <a:rPr lang="en-US" dirty="0"/>
+              <a:t>Basic concept 1</a:t>
+            </a:r>
+            <a:endParaRPr lang="da-DK" dirty="0"/>
+          </a:p>
+        </p:txBody>
+      </p:sp>
+      <p:sp>
+        <p:nvSpPr>
+          <p:cNvPr id="3" name="Undertitel 2">
+            <a:extLst>
+              <a:ext uri="{FF2B5EF4-FFF2-40B4-BE49-F238E27FC236}">
+                <a16:creationId xmlns:a16="http://schemas.microsoft.com/office/drawing/2014/main" id="{267A5B4D-C76A-ECA9-85E3-C41F67416F13}"/>
+              </a:ext>
+            </a:extLst>
+          </p:cNvPr>
+          <p:cNvSpPr>
+            <a:spLocks noGrp="1"/>
+          </p:cNvSpPr>
+          <p:nvPr>
+            <p:ph type="subTitle" idx="1"/>
+          </p:nvPr>
+        </p:nvSpPr>
+        <p:spPr/>
+        <p:txBody>
+          <a:bodyPr/>
+          <a:lstStyle/>
+          <a:p>
+            <a:r>
+              <a:rPr lang="en-US" dirty="0" err="1"/>
+              <a:t>Normalfordeling</a:t>
+            </a:r>
+            <a:endParaRPr lang="da-DK" dirty="0"/>
+          </a:p>
+        </p:txBody>
+      </p:sp>
+    </p:spTree>
+    <p:extLst>
+      <p:ext uri="{BB962C8B-B14F-4D97-AF65-F5344CB8AC3E}">
+        <p14:creationId xmlns:p14="http://schemas.microsoft.com/office/powerpoint/2010/main" val="246476336"/>
+      </p:ext>
+    </p:extLst>
+  </p:cSld>
+  <p:clrMapOvr>
+    <a:masterClrMapping/>
+  </p:clrMapOvr>
+</p:sld>
+</file>
+
+<file path=ppt/slides/slide7.xml><?xml version="1.0" encoding="utf-8"?>
+<p:sld xmlns:a="http://schemas.openxmlformats.org/drawingml/2006/main" xmlns:r="http://schemas.openxmlformats.org/officeDocument/2006/relationships" xmlns:p="http://schemas.openxmlformats.org/presentationml/2006/main">
+  <p:cSld>
+    <p:spTree>
+      <p:nvGrpSpPr>
+        <p:cNvPr id="1" name=""/>
+        <p:cNvGrpSpPr/>
+        <p:nvPr/>
+      </p:nvGrpSpPr>
+      <p:grpSpPr>
+        <a:xfrm>
+          <a:off x="0" y="0"/>
+          <a:ext cx="0" cy="0"/>
+          <a:chOff x="0" y="0"/>
+          <a:chExt cx="0" cy="0"/>
+        </a:xfrm>
+      </p:grpSpPr>
+      <p:sp>
+        <p:nvSpPr>
+          <p:cNvPr id="2" name="Titel 1">
+            <a:extLst>
+              <a:ext uri="{FF2B5EF4-FFF2-40B4-BE49-F238E27FC236}">
                 <a16:creationId xmlns:a16="http://schemas.microsoft.com/office/drawing/2014/main" id="{02891F5F-BD18-791A-E23F-628700098BA0}"/>
               </a:ext>
             </a:extLst>
@@ -12309,7 +12974,7 @@
 </p:sld>
 </file>
 
-<file path=ppt/slides/slide6.xml><?xml version="1.0" encoding="utf-8"?>
+<file path=ppt/slides/slide8.xml><?xml version="1.0" encoding="utf-8"?>
 <p:sld xmlns:a="http://schemas.openxmlformats.org/drawingml/2006/main" xmlns:r="http://schemas.openxmlformats.org/officeDocument/2006/relationships" xmlns:p="http://schemas.openxmlformats.org/presentationml/2006/main">
   <p:cSld>
     <p:spTree>
@@ -12388,7 +13053,7 @@
 </p:sld>
 </file>
 
-<file path=ppt/slides/slide7.xml><?xml version="1.0" encoding="utf-8"?>
+<file path=ppt/slides/slide9.xml><?xml version="1.0" encoding="utf-8"?>
 <p:sld xmlns:a="http://schemas.openxmlformats.org/drawingml/2006/main" xmlns:r="http://schemas.openxmlformats.org/officeDocument/2006/relationships" xmlns:p="http://schemas.openxmlformats.org/presentationml/2006/main">
   <p:cSld>
     <p:spTree>
@@ -12462,670 +13127,6 @@
   <p:clrMapOvr>
     <a:masterClrMapping/>
   </p:clrMapOvr>
-</p:sld>
-</file>
-
-<file path=ppt/slides/slide8.xml><?xml version="1.0" encoding="utf-8"?>
-<p:sld xmlns:a="http://schemas.openxmlformats.org/drawingml/2006/main" xmlns:r="http://schemas.openxmlformats.org/officeDocument/2006/relationships" xmlns:p="http://schemas.openxmlformats.org/presentationml/2006/main">
-  <p:cSld>
-    <p:spTree>
-      <p:nvGrpSpPr>
-        <p:cNvPr id="1" name=""/>
-        <p:cNvGrpSpPr/>
-        <p:nvPr/>
-      </p:nvGrpSpPr>
-      <p:grpSpPr>
-        <a:xfrm>
-          <a:off x="0" y="0"/>
-          <a:ext cx="0" cy="0"/>
-          <a:chOff x="0" y="0"/>
-          <a:chExt cx="0" cy="0"/>
-        </a:xfrm>
-      </p:grpSpPr>
-      <p:sp>
-        <p:nvSpPr>
-          <p:cNvPr id="2" name="Titel 1">
-            <a:extLst>
-              <a:ext uri="{FF2B5EF4-FFF2-40B4-BE49-F238E27FC236}">
-                <a16:creationId xmlns:a16="http://schemas.microsoft.com/office/drawing/2014/main" id="{F0A2DC4B-CB74-6B4B-B694-91AAB018AEA7}"/>
-              </a:ext>
-            </a:extLst>
-          </p:cNvPr>
-          <p:cNvSpPr>
-            <a:spLocks noGrp="1"/>
-          </p:cNvSpPr>
-          <p:nvPr>
-            <p:ph type="title"/>
-          </p:nvPr>
-        </p:nvSpPr>
-        <p:spPr/>
-        <p:txBody>
-          <a:bodyPr/>
-          <a:lstStyle/>
-          <a:p>
-            <a:r>
-              <a:rPr lang="en-US" dirty="0" err="1"/>
-              <a:t>Hvad</a:t>
-            </a:r>
-            <a:r>
-              <a:rPr lang="en-US" dirty="0"/>
-              <a:t> er </a:t>
-            </a:r>
-            <a:r>
-              <a:rPr lang="en-US" dirty="0" err="1"/>
-              <a:t>normalfordeling</a:t>
-            </a:r>
-            <a:r>
-              <a:rPr lang="en-US" dirty="0"/>
-              <a:t> </a:t>
-            </a:r>
-            <a:r>
-              <a:rPr lang="en-US" dirty="0" err="1"/>
-              <a:t>så</a:t>
-            </a:r>
-            <a:r>
-              <a:rPr lang="en-US" dirty="0"/>
-              <a:t>?</a:t>
-            </a:r>
-            <a:endParaRPr lang="da-DK" dirty="0"/>
-          </a:p>
-        </p:txBody>
-      </p:sp>
-      <p:sp>
-        <p:nvSpPr>
-          <p:cNvPr id="3" name="Pladsholder til indhold 2">
-            <a:extLst>
-              <a:ext uri="{FF2B5EF4-FFF2-40B4-BE49-F238E27FC236}">
-                <a16:creationId xmlns:a16="http://schemas.microsoft.com/office/drawing/2014/main" id="{FB50FEFC-D48B-9312-CC76-8D9FDF32E179}"/>
-              </a:ext>
-            </a:extLst>
-          </p:cNvPr>
-          <p:cNvSpPr>
-            <a:spLocks noGrp="1"/>
-          </p:cNvSpPr>
-          <p:nvPr>
-            <p:ph idx="1"/>
-          </p:nvPr>
-        </p:nvSpPr>
-        <p:spPr/>
-        <p:txBody>
-          <a:bodyPr/>
-          <a:lstStyle/>
-          <a:p>
-            <a:r>
-              <a:rPr lang="en-US" dirty="0"/>
-              <a:t>En </a:t>
-            </a:r>
-            <a:r>
-              <a:rPr lang="en-US" dirty="0" err="1"/>
-              <a:t>hyppig</a:t>
-            </a:r>
-            <a:r>
-              <a:rPr lang="en-US" dirty="0"/>
-              <a:t> </a:t>
-            </a:r>
-            <a:r>
-              <a:rPr lang="en-US" dirty="0" err="1"/>
-              <a:t>måde</a:t>
-            </a:r>
-            <a:r>
-              <a:rPr lang="en-US" dirty="0"/>
-              <a:t> for ting at </a:t>
-            </a:r>
-            <a:r>
-              <a:rPr lang="en-US" dirty="0" err="1"/>
-              <a:t>fordele</a:t>
-            </a:r>
-            <a:r>
-              <a:rPr lang="en-US" dirty="0"/>
-              <a:t> sig </a:t>
-            </a:r>
-            <a:r>
-              <a:rPr lang="en-US" dirty="0" err="1"/>
-              <a:t>på</a:t>
-            </a:r>
-            <a:r>
-              <a:rPr lang="en-US" dirty="0"/>
-              <a:t> </a:t>
-            </a:r>
-            <a:r>
-              <a:rPr lang="en-US" dirty="0" err="1"/>
-              <a:t>i</a:t>
-            </a:r>
-            <a:r>
-              <a:rPr lang="en-US" dirty="0"/>
-              <a:t> </a:t>
-            </a:r>
-            <a:r>
-              <a:rPr lang="en-US" dirty="0" err="1"/>
-              <a:t>naturen</a:t>
-            </a:r>
-            <a:endParaRPr lang="en-US" dirty="0"/>
-          </a:p>
-          <a:p>
-            <a:endParaRPr lang="en-US" dirty="0"/>
-          </a:p>
-          <a:p>
-            <a:r>
-              <a:rPr lang="en-US" dirty="0"/>
-              <a:t>En </a:t>
-            </a:r>
-            <a:r>
-              <a:rPr lang="en-US" dirty="0" err="1"/>
-              <a:t>antagelse</a:t>
-            </a:r>
-            <a:r>
-              <a:rPr lang="en-US" dirty="0"/>
-              <a:t> for mange </a:t>
-            </a:r>
-            <a:r>
-              <a:rPr lang="en-US" dirty="0" err="1"/>
-              <a:t>statistiske</a:t>
-            </a:r>
-            <a:r>
-              <a:rPr lang="en-US" dirty="0"/>
-              <a:t> tests</a:t>
-            </a:r>
-          </a:p>
-          <a:p>
-            <a:pPr lvl="1"/>
-            <a:r>
-              <a:rPr lang="en-US" dirty="0" err="1"/>
-              <a:t>Også</a:t>
-            </a:r>
-            <a:r>
-              <a:rPr lang="en-US" dirty="0"/>
-              <a:t> </a:t>
-            </a:r>
-            <a:r>
-              <a:rPr lang="en-US" dirty="0" err="1"/>
-              <a:t>kaldet</a:t>
-            </a:r>
-            <a:r>
-              <a:rPr lang="en-US" dirty="0"/>
-              <a:t> “</a:t>
-            </a:r>
-            <a:r>
-              <a:rPr lang="en-US" dirty="0" err="1"/>
-              <a:t>parametriske</a:t>
-            </a:r>
-            <a:r>
-              <a:rPr lang="en-US" dirty="0"/>
-              <a:t>” tests</a:t>
-            </a:r>
-          </a:p>
-          <a:p>
-            <a:endParaRPr lang="da-DK" dirty="0"/>
-          </a:p>
-        </p:txBody>
-      </p:sp>
-    </p:spTree>
-    <p:extLst>
-      <p:ext uri="{BB962C8B-B14F-4D97-AF65-F5344CB8AC3E}">
-        <p14:creationId xmlns:p14="http://schemas.microsoft.com/office/powerpoint/2010/main" val="1018967817"/>
-      </p:ext>
-    </p:extLst>
-  </p:cSld>
-  <p:clrMapOvr>
-    <a:masterClrMapping/>
-  </p:clrMapOvr>
-</p:sld>
-</file>
-
-<file path=ppt/slides/slide9.xml><?xml version="1.0" encoding="utf-8"?>
-<p:sld xmlns:a="http://schemas.openxmlformats.org/drawingml/2006/main" xmlns:r="http://schemas.openxmlformats.org/officeDocument/2006/relationships" xmlns:p="http://schemas.openxmlformats.org/presentationml/2006/main">
-  <p:cSld>
-    <p:spTree>
-      <p:nvGrpSpPr>
-        <p:cNvPr id="1" name=""/>
-        <p:cNvGrpSpPr/>
-        <p:nvPr/>
-      </p:nvGrpSpPr>
-      <p:grpSpPr>
-        <a:xfrm>
-          <a:off x="0" y="0"/>
-          <a:ext cx="0" cy="0"/>
-          <a:chOff x="0" y="0"/>
-          <a:chExt cx="0" cy="0"/>
-        </a:xfrm>
-      </p:grpSpPr>
-      <p:sp>
-        <p:nvSpPr>
-          <p:cNvPr id="2" name="Titel 1">
-            <a:extLst>
-              <a:ext uri="{FF2B5EF4-FFF2-40B4-BE49-F238E27FC236}">
-                <a16:creationId xmlns:a16="http://schemas.microsoft.com/office/drawing/2014/main" id="{85D8A2BC-074F-7A8C-6B58-B6B0D7D84FF2}"/>
-              </a:ext>
-            </a:extLst>
-          </p:cNvPr>
-          <p:cNvSpPr>
-            <a:spLocks noGrp="1"/>
-          </p:cNvSpPr>
-          <p:nvPr>
-            <p:ph type="title"/>
-          </p:nvPr>
-        </p:nvSpPr>
-        <p:spPr/>
-        <p:txBody>
-          <a:bodyPr/>
-          <a:lstStyle/>
-          <a:p>
-            <a:r>
-              <a:rPr lang="en-US" dirty="0" err="1"/>
-              <a:t>Hvad</a:t>
-            </a:r>
-            <a:r>
-              <a:rPr lang="en-US" dirty="0"/>
-              <a:t> er </a:t>
-            </a:r>
-            <a:r>
-              <a:rPr lang="en-US" dirty="0" err="1"/>
-              <a:t>normalfordeling</a:t>
-            </a:r>
-            <a:r>
-              <a:rPr lang="en-US" dirty="0"/>
-              <a:t> IKKE</a:t>
-            </a:r>
-            <a:endParaRPr lang="da-DK" dirty="0"/>
-          </a:p>
-        </p:txBody>
-      </p:sp>
-      <p:sp>
-        <p:nvSpPr>
-          <p:cNvPr id="3" name="Pladsholder til indhold 2">
-            <a:extLst>
-              <a:ext uri="{FF2B5EF4-FFF2-40B4-BE49-F238E27FC236}">
-                <a16:creationId xmlns:a16="http://schemas.microsoft.com/office/drawing/2014/main" id="{4E845187-4D97-1905-FA45-1494B0B4225D}"/>
-              </a:ext>
-            </a:extLst>
-          </p:cNvPr>
-          <p:cNvSpPr>
-            <a:spLocks noGrp="1"/>
-          </p:cNvSpPr>
-          <p:nvPr>
-            <p:ph idx="1"/>
-          </p:nvPr>
-        </p:nvSpPr>
-        <p:spPr/>
-        <p:txBody>
-          <a:bodyPr/>
-          <a:lstStyle/>
-          <a:p>
-            <a:r>
-              <a:rPr lang="en-US" dirty="0" err="1"/>
-              <a:t>Magisk</a:t>
-            </a:r>
-            <a:endParaRPr lang="en-US" dirty="0"/>
-          </a:p>
-          <a:p>
-            <a:r>
-              <a:rPr lang="en-US" dirty="0" err="1"/>
-              <a:t>Bedre</a:t>
-            </a:r>
-            <a:r>
-              <a:rPr lang="en-US" dirty="0"/>
-              <a:t> end </a:t>
-            </a:r>
-            <a:r>
-              <a:rPr lang="en-US" dirty="0" err="1"/>
-              <a:t>andre</a:t>
-            </a:r>
-            <a:r>
-              <a:rPr lang="en-US" dirty="0"/>
-              <a:t> </a:t>
-            </a:r>
-            <a:r>
-              <a:rPr lang="en-US" dirty="0" err="1"/>
-              <a:t>distributioner</a:t>
-            </a:r>
-            <a:r>
-              <a:rPr lang="en-US" dirty="0"/>
-              <a:t> </a:t>
-            </a:r>
-          </a:p>
-          <a:p>
-            <a:r>
-              <a:rPr lang="da-DK" dirty="0"/>
-              <a:t>Mere robust </a:t>
-            </a:r>
-          </a:p>
-          <a:p>
-            <a:r>
-              <a:rPr lang="da-DK" dirty="0"/>
-              <a:t>”normalt”</a:t>
-            </a:r>
-          </a:p>
-        </p:txBody>
-      </p:sp>
-      <p:pic>
-        <p:nvPicPr>
-          <p:cNvPr id="8194" name="Picture 2">
-            <a:extLst>
-              <a:ext uri="{FF2B5EF4-FFF2-40B4-BE49-F238E27FC236}">
-                <a16:creationId xmlns:a16="http://schemas.microsoft.com/office/drawing/2014/main" id="{CB226D01-CFA7-4D34-457C-F2B44BF512FE}"/>
-              </a:ext>
-            </a:extLst>
-          </p:cNvPr>
-          <p:cNvPicPr>
-            <a:picLocks noChangeAspect="1" noChangeArrowheads="1"/>
-          </p:cNvPicPr>
-          <p:nvPr/>
-        </p:nvPicPr>
-        <p:blipFill>
-          <a:blip r:embed="rId2">
-            <a:extLst>
-              <a:ext uri="{28A0092B-C50C-407E-A947-70E740481C1C}">
-                <a14:useLocalDpi xmlns:a14="http://schemas.microsoft.com/office/drawing/2010/main" val="0"/>
-              </a:ext>
-            </a:extLst>
-          </a:blip>
-          <a:srcRect/>
-          <a:stretch/>
-        </p:blipFill>
-        <p:spPr bwMode="auto">
-          <a:xfrm>
-            <a:off x="6645107" y="1491048"/>
-            <a:ext cx="5073127" cy="5073127"/>
-          </a:xfrm>
-          <a:prstGeom prst="rect">
-            <a:avLst/>
-          </a:prstGeom>
-          <a:noFill/>
-          <a:extLst>
-            <a:ext uri="{909E8E84-426E-40DD-AFC4-6F175D3DCCD1}">
-              <a14:hiddenFill xmlns:a14="http://schemas.microsoft.com/office/drawing/2010/main">
-                <a:solidFill>
-                  <a:srgbClr val="FFFFFF"/>
-                </a:solidFill>
-              </a14:hiddenFill>
-            </a:ext>
-          </a:extLst>
-        </p:spPr>
-      </p:pic>
-    </p:spTree>
-    <p:extLst>
-      <p:ext uri="{BB962C8B-B14F-4D97-AF65-F5344CB8AC3E}">
-        <p14:creationId xmlns:p14="http://schemas.microsoft.com/office/powerpoint/2010/main" val="3248773268"/>
-      </p:ext>
-    </p:extLst>
-  </p:cSld>
-  <p:clrMapOvr>
-    <a:masterClrMapping/>
-  </p:clrMapOvr>
-  <p:timing>
-    <p:tnLst>
-      <p:par>
-        <p:cTn id="1" dur="indefinite" restart="never" nodeType="tmRoot">
-          <p:childTnLst>
-            <p:seq concurrent="1" nextAc="seek">
-              <p:cTn id="2" dur="indefinite" nodeType="mainSeq">
-                <p:childTnLst>
-                  <p:par>
-                    <p:cTn id="3" fill="hold">
-                      <p:stCondLst>
-                        <p:cond delay="indefinite"/>
-                      </p:stCondLst>
-                      <p:childTnLst>
-                        <p:par>
-                          <p:cTn id="4" fill="hold">
-                            <p:stCondLst>
-                              <p:cond delay="0"/>
-                            </p:stCondLst>
-                            <p:childTnLst>
-                              <p:par>
-                                <p:cTn id="5" presetID="1" presetClass="entr" presetSubtype="0" fill="hold" grpId="0" nodeType="clickEffect">
-                                  <p:stCondLst>
-                                    <p:cond delay="0"/>
-                                  </p:stCondLst>
-                                  <p:childTnLst>
-                                    <p:set>
-                                      <p:cBhvr>
-                                        <p:cTn id="6" dur="1" fill="hold">
-                                          <p:stCondLst>
-                                            <p:cond delay="0"/>
-                                          </p:stCondLst>
-                                        </p:cTn>
-                                        <p:tgtEl>
-                                          <p:spTgt spid="3">
-                                            <p:txEl>
-                                              <p:pRg st="0" end="0"/>
-                                            </p:txEl>
-                                          </p:spTgt>
-                                        </p:tgtEl>
-                                        <p:attrNameLst>
-                                          <p:attrName>style.visibility</p:attrName>
-                                        </p:attrNameLst>
-                                      </p:cBhvr>
-                                      <p:to>
-                                        <p:strVal val="visible"/>
-                                      </p:to>
-                                    </p:set>
-                                  </p:childTnLst>
-                                </p:cTn>
-                              </p:par>
-                            </p:childTnLst>
-                          </p:cTn>
-                        </p:par>
-                      </p:childTnLst>
-                    </p:cTn>
-                  </p:par>
-                  <p:par>
-                    <p:cTn id="7" fill="hold">
-                      <p:stCondLst>
-                        <p:cond delay="indefinite"/>
-                      </p:stCondLst>
-                      <p:childTnLst>
-                        <p:par>
-                          <p:cTn id="8" fill="hold">
-                            <p:stCondLst>
-                              <p:cond delay="0"/>
-                            </p:stCondLst>
-                            <p:childTnLst>
-                              <p:par>
-                                <p:cTn id="9" presetID="1" presetClass="entr" presetSubtype="0" fill="hold" grpId="0" nodeType="clickEffect">
-                                  <p:stCondLst>
-                                    <p:cond delay="0"/>
-                                  </p:stCondLst>
-                                  <p:childTnLst>
-                                    <p:set>
-                                      <p:cBhvr>
-                                        <p:cTn id="10" dur="1" fill="hold">
-                                          <p:stCondLst>
-                                            <p:cond delay="0"/>
-                                          </p:stCondLst>
-                                        </p:cTn>
-                                        <p:tgtEl>
-                                          <p:spTgt spid="3">
-                                            <p:txEl>
-                                              <p:pRg st="1" end="1"/>
-                                            </p:txEl>
-                                          </p:spTgt>
-                                        </p:tgtEl>
-                                        <p:attrNameLst>
-                                          <p:attrName>style.visibility</p:attrName>
-                                        </p:attrNameLst>
-                                      </p:cBhvr>
-                                      <p:to>
-                                        <p:strVal val="visible"/>
-                                      </p:to>
-                                    </p:set>
-                                  </p:childTnLst>
-                                </p:cTn>
-                              </p:par>
-                            </p:childTnLst>
-                          </p:cTn>
-                        </p:par>
-                      </p:childTnLst>
-                    </p:cTn>
-                  </p:par>
-                  <p:par>
-                    <p:cTn id="11" fill="hold">
-                      <p:stCondLst>
-                        <p:cond delay="indefinite"/>
-                      </p:stCondLst>
-                      <p:childTnLst>
-                        <p:par>
-                          <p:cTn id="12" fill="hold">
-                            <p:stCondLst>
-                              <p:cond delay="0"/>
-                            </p:stCondLst>
-                            <p:childTnLst>
-                              <p:par>
-                                <p:cTn id="13" presetID="1" presetClass="entr" presetSubtype="0" fill="hold" grpId="0" nodeType="clickEffect">
-                                  <p:stCondLst>
-                                    <p:cond delay="0"/>
-                                  </p:stCondLst>
-                                  <p:childTnLst>
-                                    <p:set>
-                                      <p:cBhvr>
-                                        <p:cTn id="14" dur="1" fill="hold">
-                                          <p:stCondLst>
-                                            <p:cond delay="0"/>
-                                          </p:stCondLst>
-                                        </p:cTn>
-                                        <p:tgtEl>
-                                          <p:spTgt spid="3">
-                                            <p:txEl>
-                                              <p:pRg st="2" end="2"/>
-                                            </p:txEl>
-                                          </p:spTgt>
-                                        </p:tgtEl>
-                                        <p:attrNameLst>
-                                          <p:attrName>style.visibility</p:attrName>
-                                        </p:attrNameLst>
-                                      </p:cBhvr>
-                                      <p:to>
-                                        <p:strVal val="visible"/>
-                                      </p:to>
-                                    </p:set>
-                                  </p:childTnLst>
-                                </p:cTn>
-                              </p:par>
-                            </p:childTnLst>
-                          </p:cTn>
-                        </p:par>
-                      </p:childTnLst>
-                    </p:cTn>
-                  </p:par>
-                  <p:par>
-                    <p:cTn id="15" fill="hold">
-                      <p:stCondLst>
-                        <p:cond delay="indefinite"/>
-                      </p:stCondLst>
-                      <p:childTnLst>
-                        <p:par>
-                          <p:cTn id="16" fill="hold">
-                            <p:stCondLst>
-                              <p:cond delay="0"/>
-                            </p:stCondLst>
-                            <p:childTnLst>
-                              <p:par>
-                                <p:cTn id="17" presetID="1" presetClass="entr" presetSubtype="0" fill="hold" grpId="0" nodeType="clickEffect">
-                                  <p:stCondLst>
-                                    <p:cond delay="0"/>
-                                  </p:stCondLst>
-                                  <p:childTnLst>
-                                    <p:set>
-                                      <p:cBhvr>
-                                        <p:cTn id="18" dur="1" fill="hold">
-                                          <p:stCondLst>
-                                            <p:cond delay="0"/>
-                                          </p:stCondLst>
-                                        </p:cTn>
-                                        <p:tgtEl>
-                                          <p:spTgt spid="3">
-                                            <p:txEl>
-                                              <p:pRg st="3" end="3"/>
-                                            </p:txEl>
-                                          </p:spTgt>
-                                        </p:tgtEl>
-                                        <p:attrNameLst>
-                                          <p:attrName>style.visibility</p:attrName>
-                                        </p:attrNameLst>
-                                      </p:cBhvr>
-                                      <p:to>
-                                        <p:strVal val="visible"/>
-                                      </p:to>
-                                    </p:set>
-                                  </p:childTnLst>
-                                </p:cTn>
-                              </p:par>
-                            </p:childTnLst>
-                          </p:cTn>
-                        </p:par>
-                      </p:childTnLst>
-                    </p:cTn>
-                  </p:par>
-                  <p:par>
-                    <p:cTn id="19" fill="hold">
-                      <p:stCondLst>
-                        <p:cond delay="indefinite"/>
-                      </p:stCondLst>
-                      <p:childTnLst>
-                        <p:par>
-                          <p:cTn id="20" fill="hold">
-                            <p:stCondLst>
-                              <p:cond delay="0"/>
-                            </p:stCondLst>
-                            <p:childTnLst>
-                              <p:par>
-                                <p:cTn id="21" presetID="1" presetClass="entr" presetSubtype="0" fill="hold" nodeType="clickEffect">
-                                  <p:stCondLst>
-                                    <p:cond delay="0"/>
-                                  </p:stCondLst>
-                                  <p:childTnLst>
-                                    <p:set>
-                                      <p:cBhvr>
-                                        <p:cTn id="22" dur="1" fill="hold">
-                                          <p:stCondLst>
-                                            <p:cond delay="0"/>
-                                          </p:stCondLst>
-                                        </p:cTn>
-                                        <p:tgtEl>
-                                          <p:spTgt spid="8194"/>
-                                        </p:tgtEl>
-                                        <p:attrNameLst>
-                                          <p:attrName>style.visibility</p:attrName>
-                                        </p:attrNameLst>
-                                      </p:cBhvr>
-                                      <p:to>
-                                        <p:strVal val="visible"/>
-                                      </p:to>
-                                    </p:set>
-                                  </p:childTnLst>
-                                </p:cTn>
-                              </p:par>
-                            </p:childTnLst>
-                          </p:cTn>
-                        </p:par>
-                      </p:childTnLst>
-                    </p:cTn>
-                  </p:par>
-                </p:childTnLst>
-              </p:cTn>
-              <p:prevCondLst>
-                <p:cond evt="onPrev" delay="0">
-                  <p:tgtEl>
-                    <p:sldTgt/>
-                  </p:tgtEl>
-                </p:cond>
-              </p:prevCondLst>
-              <p:nextCondLst>
-                <p:cond evt="onNext" delay="0">
-                  <p:tgtEl>
-                    <p:sldTgt/>
-                  </p:tgtEl>
-                </p:cond>
-              </p:nextCondLst>
-            </p:seq>
-          </p:childTnLst>
-        </p:cTn>
-      </p:par>
-    </p:tnLst>
-    <p:bldLst>
-      <p:bldP spid="3" grpId="0" build="p"/>
-    </p:bldLst>
-  </p:timing>
 </p:sld>
 </file>
 

</xml_diff>